<commit_message>
Sync session-00.pptx with the workshop export (instructor guide in the notes)
Co-Authored-By: Claude Opus 5.5 <noreply@anthropic.com>
</commit_message>
<xml_diff>
--- a/slides/session-00.pptx
+++ b/slides/session-00.pptx
@@ -532,25 +532,162 @@
           <a:lstStyle/>
           <a:p>
             <a:r>
+              <a:rPr lang="en-US" b="1" dirty="0"/>
+              <a:t>POINT:</a:t>
+            </a:r>
+            <a:r>
               <a:rPr lang="en-US" dirty="0"/>
-              <a:t>Welcome everyone. Say up front: this is optional, nothing is graded, and nobody is expected to master any of it before Monday. The goal is that on day one nothing on the screen is completely new. The kit is a folder called prep-kit that works on its own, eight short steps, about three to four hours if they do it alone. Today we walk through it together and get as many laptops working as we can.
-──── INSTRUCTOR GUIDE ────
-TIMING (75 MINUTES)
-Block — Slides — Minutes — If you're running late
-Welcome and the route — 1–4 — 8 — Skip slide 3; Session 1 tells the story anyway
-Terminal and venv — 5–8 — 12 — Show slide 6, then point at the step 01 page
-APIs — 9–13 — 13 — Demo the /docs page only, skip hello_api.py
-Secrets — 14–15 — 5 — Read the four habits, move on
-Where LLMs came from, LLM calls, three providers — 16–22 — 17 — Skip 16 (it's in the extra reading); one live call, not three
-Tokens, cost, taste of Resolvo — 23–28 — 10 — Keep 28 (two kinds of wrong); skip 24 and 25
-Course key and setup check — 29–32 — 10 — Never cut this block
-Leave the call open for 15 minutes afterwards for anyone whose setup check fails.
-──── INSTRUCTOR GUIDE ────
-BEFORE THE CALL
-• [ ] Run every command in the deck once on your own machine, today. Model names on free tiers change, and a retired model gives a 404.
-• [ ] Have Ollama running with llama3.2 pulled, so you have one demo that needs no network and no key.
-• [ ] Start the mock order API in a terminal you can share.
-• [ ] Have &lt;https://github.com/hasankanaan26/prep-kit&gt; ready to paste into the chat.</a:t>
+              <a:t> Today is optional and nothing is graded. The goal: on Monday, nothing on the screen is completely new.</a:t>
+            </a:r>
+            <a:endParaRPr lang="en-US" dirty="0"/>
+          </a:p>
+          <a:p>
+            <a:r>
+              <a:rPr lang="en-US" b="1" dirty="0"/>
+              <a:t>SAY:</a:t>
+            </a:r>
+            <a:r>
+              <a:rPr lang="en-US" dirty="0"/>
+              <a:t> "Nobody needs to master this before Monday. We'll walk through the kit and get as many laptops working as we can."</a:t>
+            </a:r>
+            <a:endParaRPr lang="en-US" dirty="0"/>
+          </a:p>
+          <a:p>
+            <a:r>
+              <a:rPr lang="en-US" b="1" dirty="0"/>
+              <a:t>IF ASKED:</a:t>
+            </a:r>
+            <a:r>
+              <a:rPr lang="en-US" dirty="0"/>
+              <a:t> The kit is a folder called prep-kit: eight short steps, three to four hours alone.</a:t>
+            </a:r>
+            <a:endParaRPr lang="en-US" dirty="0"/>
+          </a:p>
+          <a:p>
+            <a:endParaRPr lang="en-US" dirty="0"/>
+          </a:p>
+          <a:p>
+            <a:r>
+              <a:rPr lang="en-US" dirty="0"/>
+              <a:t>──── INSTRUCTOR GUIDE ────</a:t>
+            </a:r>
+            <a:endParaRPr lang="en-US" dirty="0"/>
+          </a:p>
+          <a:p>
+            <a:r>
+              <a:rPr lang="en-US" dirty="0"/>
+              <a:t>TIMING (75 MINUTES)</a:t>
+            </a:r>
+            <a:endParaRPr lang="en-US" dirty="0"/>
+          </a:p>
+          <a:p>
+            <a:r>
+              <a:rPr lang="en-US" dirty="0"/>
+              <a:t>Block — Slides — Minutes — If you're running late</a:t>
+            </a:r>
+            <a:endParaRPr lang="en-US" dirty="0"/>
+          </a:p>
+          <a:p>
+            <a:r>
+              <a:rPr lang="en-US" dirty="0"/>
+              <a:t>Welcome and the route — 1–4 — 8 — Skip slide 3; Session 1 tells the story anyway</a:t>
+            </a:r>
+            <a:endParaRPr lang="en-US" dirty="0"/>
+          </a:p>
+          <a:p>
+            <a:r>
+              <a:rPr lang="en-US" dirty="0"/>
+              <a:t>Terminal and venv — 5–8 — 12 — Show slide 6, then point at the step 01 page</a:t>
+            </a:r>
+            <a:endParaRPr lang="en-US" dirty="0"/>
+          </a:p>
+          <a:p>
+            <a:r>
+              <a:rPr lang="en-US" dirty="0"/>
+              <a:t>APIs — 9–13 — 13 — Demo the /docs page only, skip hello_api.py</a:t>
+            </a:r>
+            <a:endParaRPr lang="en-US" dirty="0"/>
+          </a:p>
+          <a:p>
+            <a:r>
+              <a:rPr lang="en-US" dirty="0"/>
+              <a:t>Secrets — 14–15 — 5 — Read the four habits, move on</a:t>
+            </a:r>
+            <a:endParaRPr lang="en-US" dirty="0"/>
+          </a:p>
+          <a:p>
+            <a:r>
+              <a:rPr lang="en-US" dirty="0"/>
+              <a:t>Where LLMs came from, LLM calls, three providers — 16–22 — 17 — Skip 16 (it's in the extra reading); one live call, not three</a:t>
+            </a:r>
+            <a:endParaRPr lang="en-US" dirty="0"/>
+          </a:p>
+          <a:p>
+            <a:r>
+              <a:rPr lang="en-US" dirty="0"/>
+              <a:t>Tokens, cost, taste of Resolvo — 23–28 — 10 — Keep 28 (two kinds of wrong); skip 24 and 25</a:t>
+            </a:r>
+            <a:endParaRPr lang="en-US" dirty="0"/>
+          </a:p>
+          <a:p>
+            <a:r>
+              <a:rPr lang="en-US" dirty="0"/>
+              <a:t>Course key and setup check — 29–32 — 10 — Never cut this block</a:t>
+            </a:r>
+            <a:endParaRPr lang="en-US" dirty="0"/>
+          </a:p>
+          <a:p>
+            <a:endParaRPr lang="en-US" dirty="0"/>
+          </a:p>
+          <a:p>
+            <a:r>
+              <a:rPr lang="en-US" dirty="0"/>
+              <a:t>Leave the call open for 15 minutes afterwards for anyone whose setup check fails.</a:t>
+            </a:r>
+            <a:endParaRPr lang="en-US" dirty="0"/>
+          </a:p>
+          <a:p>
+            <a:endParaRPr lang="en-US" dirty="0"/>
+          </a:p>
+          <a:p>
+            <a:r>
+              <a:rPr lang="en-US" dirty="0"/>
+              <a:t>──── INSTRUCTOR GUIDE ────</a:t>
+            </a:r>
+            <a:endParaRPr lang="en-US" dirty="0"/>
+          </a:p>
+          <a:p>
+            <a:r>
+              <a:rPr lang="en-US" dirty="0"/>
+              <a:t>BEFORE THE CALL</a:t>
+            </a:r>
+            <a:endParaRPr lang="en-US" dirty="0"/>
+          </a:p>
+          <a:p>
+            <a:r>
+              <a:rPr lang="en-US" dirty="0"/>
+              <a:t>• [ ] Run every command in the deck once on your own machine, today. Model names on free tiers change, and a retired model gives a 404.</a:t>
+            </a:r>
+            <a:endParaRPr lang="en-US" dirty="0"/>
+          </a:p>
+          <a:p>
+            <a:r>
+              <a:rPr lang="en-US" dirty="0"/>
+              <a:t>• [ ] Have Ollama running with llama3.2 pulled, so you have one demo that needs no network and no key.</a:t>
+            </a:r>
+            <a:endParaRPr lang="en-US" dirty="0"/>
+          </a:p>
+          <a:p>
+            <a:r>
+              <a:rPr lang="en-US" dirty="0"/>
+              <a:t>• [ ] Start the mock order API in a terminal you can share.</a:t>
+            </a:r>
+            <a:endParaRPr lang="en-US" dirty="0"/>
+          </a:p>
+          <a:p>
+            <a:r>
+              <a:rPr lang="en-US" dirty="0"/>
+              <a:t>• [ ] Have &lt;https://github.com/hasankanaan26/prep-kit&gt; ready to paste into the chat.</a:t>
             </a:r>
             <a:endParaRPr lang="en-US" dirty="0"/>
           </a:p>
@@ -637,8 +774,34 @@
           <a:lstStyle/>
           <a:p>
             <a:r>
+              <a:rPr lang="en-US" b="1" dirty="0"/>
+              <a:t>POINT:</a:t>
+            </a:r>
+            <a:r>
               <a:rPr lang="en-US" dirty="0"/>
-              <a:t>Four codes are enough for this month. 429 matters because free tiers on Gemini and OpenRouter rate-limit you: the fix is to wait, not to hammer it. 500 matters because real APIs fail, and the course makes them fail on purpose (the X-Chaos header on the mock API) so they can practise handling it in Session 5.</a:t>
+              <a:t> Good code reads the status code and decides what to do.</a:t>
+            </a:r>
+            <a:endParaRPr lang="en-US" dirty="0"/>
+          </a:p>
+          <a:p>
+            <a:r>
+              <a:rPr lang="en-US" b="1" dirty="0"/>
+              <a:t>SAY:</a:t>
+            </a:r>
+            <a:r>
+              <a:rPr lang="en-US" dirty="0"/>
+              <a:t> "429 on a free tier means wait, don't hammer it. 500 means the other side broke. Real APIs do, and the course makes them fail on purpose so you can practise."</a:t>
+            </a:r>
+            <a:endParaRPr lang="en-US" dirty="0"/>
+          </a:p>
+          <a:p>
+            <a:r>
+              <a:rPr lang="en-US" b="1" dirty="0"/>
+              <a:t>IF ASKED:</a:t>
+            </a:r>
+            <a:r>
+              <a:rPr lang="en-US" dirty="0"/>
+              <a:t> The mock API fails on demand: an X-Chaos header for one request, or MOCK_CHAOS for all. Session 5 uses MOCK_CHAOS.</a:t>
             </a:r>
             <a:endParaRPr lang="en-US" dirty="0"/>
           </a:p>
@@ -725,11 +888,58 @@
           <a:lstStyle/>
           <a:p>
             <a:r>
+              <a:rPr lang="en-US" b="1" dirty="0"/>
+              <a:t>POINT:</a:t>
+            </a:r>
+            <a:r>
               <a:rPr lang="en-US" dirty="0"/>
-              <a:t>This is a small fake version of the Nimbus order system, and the course uses it in every week. The docs page is generated from the code, and it's the friendliest way to see an API: click GET /orders/{order_id}, Try it out, O-48291, Execute. Then run hello_api.py and read the output top to bottom. The script is about 60 lines and worth reading: each request is one line of httpx.
-──── INSTRUCTOR GUIDE ────
-A REAL API, RUNNING ON YOUR LAPTOP
-Open http://localhost:9000/docs first. Clicking "Try it out" on GET /orders/{order_id} is the gentlest possible first API call, and the response panel shows the status code and the JSON together. Then run hello_api.py and read the five blocks aloud. Ask "is the 404 a bug?" before you explain it.</a:t>
+              <a:t> They make real API calls to a small fake Nimbus order system, which the course uses every week.</a:t>
+            </a:r>
+            <a:endParaRPr lang="en-US" dirty="0"/>
+          </a:p>
+          <a:p>
+            <a:r>
+              <a:rPr lang="en-US" b="1" dirty="0"/>
+              <a:t>DO:</a:t>
+            </a:r>
+            <a:r>
+              <a:rPr lang="en-US" dirty="0"/>
+              <a:t> On /docs: GET /orders/{order_id}, Try it out, O-48291, Execute. Then run hello_api.py and read the output aloud.</a:t>
+            </a:r>
+            <a:endParaRPr lang="en-US" dirty="0"/>
+          </a:p>
+          <a:p>
+            <a:r>
+              <a:rPr lang="en-US" b="1" dirty="0"/>
+              <a:t>ASK:</a:t>
+            </a:r>
+            <a:r>
+              <a:rPr lang="en-US" dirty="0"/>
+              <a:t> "Is the 404 a bug?" Answer: No. The server answered: that order doesn't exist.</a:t>
+            </a:r>
+            <a:endParaRPr lang="en-US" dirty="0"/>
+          </a:p>
+          <a:p>
+            <a:endParaRPr lang="en-US" dirty="0"/>
+          </a:p>
+          <a:p>
+            <a:r>
+              <a:rPr lang="en-US" dirty="0"/>
+              <a:t>──── INSTRUCTOR GUIDE ────</a:t>
+            </a:r>
+            <a:endParaRPr lang="en-US" dirty="0"/>
+          </a:p>
+          <a:p>
+            <a:r>
+              <a:rPr lang="en-US" dirty="0"/>
+              <a:t>A REAL API, RUNNING ON YOUR LAPTOP</a:t>
+            </a:r>
+            <a:endParaRPr lang="en-US" dirty="0"/>
+          </a:p>
+          <a:p>
+            <a:r>
+              <a:rPr lang="en-US" dirty="0"/>
+              <a:t>Open http://localhost:9000/docs first. Clicking "Try it out" on GET /orders/{order_id} is the gentlest possible first API call, and the response panel shows the status code and the JSON together. Then run hello_api.py and read the five blocks aloud. Ask "is the 404 a bug?" before you explain it.</a:t>
             </a:r>
             <a:endParaRPr lang="en-US" dirty="0"/>
           </a:p>
@@ -816,8 +1026,34 @@
           <a:lstStyle/>
           <a:p>
             <a:r>
+              <a:rPr lang="en-US" b="1" dirty="0"/>
+              <a:t>POINT:</a:t>
+            </a:r>
+            <a:r>
               <a:rPr lang="en-US" dirty="0"/>
-              <a:t>This is the one API idea worth naming today, because money is involved. Networks time out. If a refund request times out, you don't know if it happened, so you retry. Without a key, a retry can refund twice. With the key, the server recognises the request and returns the first refund. Session 5 builds the real refund tool on this. Don't go deeper today; the name and the picture are enough.</a:t>
+              <a:t> The same Idempotency-Key means the customer is refunded once, however many times you retry.</a:t>
+            </a:r>
+            <a:endParaRPr lang="en-US" dirty="0"/>
+          </a:p>
+          <a:p>
+            <a:r>
+              <a:rPr lang="en-US" b="1" dirty="0"/>
+              <a:t>SAY:</a:t>
+            </a:r>
+            <a:r>
+              <a:rPr lang="en-US" dirty="0"/>
+              <a:t> "A refund times out. Did it happen? You don't know, so you retry. Without a key, that can refund twice. With it, the server returns the first refund."</a:t>
+            </a:r>
+            <a:endParaRPr lang="en-US" dirty="0"/>
+          </a:p>
+          <a:p>
+            <a:r>
+              <a:rPr lang="en-US" b="1" dirty="0"/>
+              <a:t>IF ASKED:</a:t>
+            </a:r>
+            <a:r>
+              <a:rPr lang="en-US" dirty="0"/>
+              <a:t> Session 5 builds the real refund tool on this. Don't go deeper today.</a:t>
             </a:r>
             <a:endParaRPr lang="en-US" dirty="0"/>
           </a:p>
@@ -904,8 +1140,34 @@
           <a:lstStyle/>
           <a:p>
             <a:r>
+              <a:rPr lang="en-US" b="1" dirty="0"/>
+              <a:t>ASK:</a:t>
+            </a:r>
+            <a:r>
               <a:rPr lang="en-US" dirty="0"/>
-              <a:t>Answers. 1: No. The server answered correctly: that order doesn't exist. 404 is information, not a failure. 2: The server remembers the key. If the first request went through, it returns that same refund instead of making a second one; if it didn't, the retry does it. Either way the customer is refunded exactly once. 3: Activating the venv in this terminal (.venv\Scripts\activate, or source .venv/bin/activate).</a:t>
+              <a:t> Question 1. Answer: No. The server answered correctly: that order doesn't exist. A 404 is information, not a failure.</a:t>
+            </a:r>
+            <a:endParaRPr lang="en-US" dirty="0"/>
+          </a:p>
+          <a:p>
+            <a:r>
+              <a:rPr lang="en-US" b="1" dirty="0"/>
+              <a:t>ASK:</a:t>
+            </a:r>
+            <a:r>
+              <a:rPr lang="en-US" dirty="0"/>
+              <a:t> Question 2. Answer: The server remembers the key. If the first request went through, it returns that refund; if not, the retry does it. Refunded exactly once.</a:t>
+            </a:r>
+            <a:endParaRPr lang="en-US" dirty="0"/>
+          </a:p>
+          <a:p>
+            <a:r>
+              <a:rPr lang="en-US" b="1" dirty="0"/>
+              <a:t>ASK:</a:t>
+            </a:r>
+            <a:r>
+              <a:rPr lang="en-US" dirty="0"/>
+              <a:t> Question 3. Answer: Activating the venv in this terminal.</a:t>
             </a:r>
             <a:endParaRPr lang="en-US" dirty="0"/>
           </a:p>
@@ -992,8 +1254,34 @@
           <a:lstStyle/>
           <a:p>
             <a:r>
+              <a:rPr lang="en-US" b="1" dirty="0"/>
+              <a:t>POINT:</a:t>
+            </a:r>
+            <a:r>
               <a:rPr lang="en-US" dirty="0"/>
-              <a:t>An API key is your username and password in one string, attached to your credit card. Environment variables are named values the operating system hands to each program. Typing them every time is tedious, so projects keep them in a .env file, and a small package reads it. Show show_env.py: it reports which keys are set and how long they are, never the value, and warns about the two classic paste mistakes, a trailing space and quote marks.</a:t>
+              <a:t> A key is your username and password in one string, tied to your credit card. It lives in .env, never in code.</a:t>
+            </a:r>
+            <a:endParaRPr lang="en-US" dirty="0"/>
+          </a:p>
+          <a:p>
+            <a:r>
+              <a:rPr lang="en-US" b="1" dirty="0"/>
+              <a:t>SAY:</a:t>
+            </a:r>
+            <a:r>
+              <a:rPr lang="en-US" dirty="0"/>
+              <a:t> "Environment variables are named values the operating system hands to each program."</a:t>
+            </a:r>
+            <a:endParaRPr lang="en-US" dirty="0"/>
+          </a:p>
+          <a:p>
+            <a:r>
+              <a:rPr lang="en-US" b="1" dirty="0"/>
+              <a:t>DO:</a:t>
+            </a:r>
+            <a:r>
+              <a:rPr lang="en-US" dirty="0"/>
+              <a:t> Show show_env.py: which keys are set and how long, never the value. It flags a trailing space and quote marks.</a:t>
             </a:r>
             <a:endParaRPr lang="en-US" dirty="0"/>
           </a:p>
@@ -1080,8 +1368,34 @@
           <a:lstStyle/>
           <a:p>
             <a:r>
+              <a:rPr lang="en-US" b="1" dirty="0"/>
+              <a:t>POINT:</a:t>
+            </a:r>
+            <a:r>
               <a:rPr lang="en-US" dirty="0"/>
-              <a:t>The spending limit is the one to stress. A loop with a bug can make thousands of calls while you're at lunch; a limit turns that into an annoyance instead of a bill. And revoking is not a big deal: people leak keys all the time, and the fix is boring and fast. The two .env files keep practice and course separate, so nothing in the prep kit can change how the course code behaves.</a:t>
+              <a:t> Set a spending limit the day you create a paid key.</a:t>
+            </a:r>
+            <a:endParaRPr lang="en-US" dirty="0"/>
+          </a:p>
+          <a:p>
+            <a:r>
+              <a:rPr lang="en-US" b="1" dirty="0"/>
+              <a:t>SAY:</a:t>
+            </a:r>
+            <a:r>
+              <a:rPr lang="en-US" dirty="0"/>
+              <a:t> "A loop with a bug can make thousands of calls while you're at lunch. A limit turns that into an annoyance instead of a bill." Leaked keys are common; revoking is fast.</a:t>
+            </a:r>
+            <a:endParaRPr lang="en-US" dirty="0"/>
+          </a:p>
+          <a:p>
+            <a:r>
+              <a:rPr lang="en-US" b="1" dirty="0"/>
+              <a:t>IF ASKED:</a:t>
+            </a:r>
+            <a:r>
+              <a:rPr lang="en-US" dirty="0"/>
+              <a:t> Two .env files keep practice and course separate.</a:t>
             </a:r>
             <a:endParaRPr lang="en-US" dirty="0"/>
           </a:p>
@@ -1168,8 +1482,34 @@
           <a:lstStyle/>
           <a:p>
             <a:r>
+              <a:rPr lang="en-US" b="1" dirty="0"/>
+              <a:t>POINT:</a:t>
+            </a:r>
+            <a:r>
               <a:rPr lang="en-US" dirty="0"/>
-              <a:t>This is background, moved here from Session 1 so that session can spend its time on the broken bot. Students don't need the history to build anything; skip the slide if time is short and point at prep-kit/extra-how-llms-work.md. ML means machine learning: the computer learns rules from examples instead of you writing them. The best example is instruction tuning: ask a raw model "What is your refund window?" and it may continue with "What is your shipping time? What is your warranty?", because it thinks it is in the middle of an FAQ page. An instruction-tuned model answers the question.</a:t>
+              <a:t> Behind the API is a text predictor trained to be helpful. Optional: skip it if short on time and point at prep-kit/extra-how-llms-work.md.</a:t>
+            </a:r>
+            <a:endParaRPr lang="en-US" dirty="0"/>
+          </a:p>
+          <a:p>
+            <a:r>
+              <a:rPr lang="en-US" b="1" dirty="0"/>
+              <a:t>SAY:</a:t>
+            </a:r>
+            <a:r>
+              <a:rPr lang="en-US" dirty="0"/>
+              <a:t> "Ask a raw model 'What is your refund window?' and it may continue 'What is your shipping time?' It thinks it's on an FAQ page. An instruction-tuned model answers."</a:t>
+            </a:r>
+            <a:endParaRPr lang="en-US" dirty="0"/>
+          </a:p>
+          <a:p>
+            <a:r>
+              <a:rPr lang="en-US" b="1" dirty="0"/>
+              <a:t>IF ASKED:</a:t>
+            </a:r>
+            <a:r>
+              <a:rPr lang="en-US" dirty="0"/>
+              <a:t> ML is machine learning: the computer learns rules from examples.</a:t>
             </a:r>
             <a:endParaRPr lang="en-US" dirty="0"/>
           </a:p>
@@ -1256,8 +1596,34 @@
           <a:lstStyle/>
           <a:p>
             <a:r>
+              <a:rPr lang="en-US" b="1" dirty="0"/>
+              <a:t>POINT:</a:t>
+            </a:r>
+            <a:r>
               <a:rPr lang="en-US" dirty="0"/>
-              <a:t>Connect it back to step 02: a POST, JSON in, JSON out. The model field picks which model. Messages is the conversation so far: the system message sets the rules, the user message asks. Temperature controls randomness: near 0 you get the same answer most times, higher gives more variety. The response has the reply and a usage block with token counts, which is what the bill is based on. Tokens get their own step later.</a:t>
+              <a:t> An LLM call is the same POST as step 02: JSON in, JSON out.</a:t>
+            </a:r>
+            <a:endParaRPr lang="en-US" dirty="0"/>
+          </a:p>
+          <a:p>
+            <a:r>
+              <a:rPr lang="en-US" b="1" dirty="0"/>
+              <a:t>SAY:</a:t>
+            </a:r>
+            <a:r>
+              <a:rPr lang="en-US" dirty="0"/>
+              <a:t> "System sets the rules, user asks. Temperature near 0 gives the same answer most times; higher gives variety. Usage is the token count, and the bill is based on it."</a:t>
+            </a:r>
+            <a:endParaRPr lang="en-US" dirty="0"/>
+          </a:p>
+          <a:p>
+            <a:r>
+              <a:rPr lang="en-US" b="1" dirty="0"/>
+              <a:t>IF ASKED:</a:t>
+            </a:r>
+            <a:r>
+              <a:rPr lang="en-US" dirty="0"/>
+              <a:t> What a token is comes in step 06.</a:t>
             </a:r>
             <a:endParaRPr lang="en-US" dirty="0"/>
           </a:p>
@@ -1344,11 +1710,58 @@
           <a:lstStyle/>
           <a:p>
             <a:r>
+              <a:rPr lang="en-US" b="1" dirty="0"/>
+              <a:t>POINT:</a:t>
+            </a:r>
+            <a:r>
               <a:rPr lang="en-US" dirty="0"/>
-              <a:t>This is the one idea to take from step 04. Most providers now offer an OpenAI-compatible API, meaning the same request shape OpenAI made popular. So the openai Python package talks to all of them; only base_url, the key and the model name change. In prep-kit/code/providers.py that's a three-row table. The Resolvo code does the same thing in a file called llm.py: one place knows about the provider and the rest of the program never does. They'll meet llm.py in Session 2.
-──── INSTRUCTOR GUIDE ────
-ONE SDK, THREE ADDRESSES
-Open prep-kit/code/providers.py next to the slide. The whole provider table is three entries with a URL, a key name and a default model. Then run chat.py twice with two different --provider values and point out that only the bracket line changes.</a:t>
+              <a:t> A provider is an address plus a key. The openai package talks to all three; only base_url, the key and the model name change.</a:t>
+            </a:r>
+            <a:endParaRPr lang="en-US" dirty="0"/>
+          </a:p>
+          <a:p>
+            <a:r>
+              <a:rPr lang="en-US" b="1" dirty="0"/>
+              <a:t>SAY:</a:t>
+            </a:r>
+            <a:r>
+              <a:rPr lang="en-US" dirty="0"/>
+              <a:t> "Most providers copy OpenAI's request shape, so one package works for all of them."</a:t>
+            </a:r>
+            <a:endParaRPr lang="en-US" dirty="0"/>
+          </a:p>
+          <a:p>
+            <a:r>
+              <a:rPr lang="en-US" b="1" dirty="0"/>
+              <a:t>DO:</a:t>
+            </a:r>
+            <a:r>
+              <a:rPr lang="en-US" dirty="0"/>
+              <a:t> Open prep-kit/code/providers.py, a three-row table. Run chat.py with two --provider values: only the bracket line changes.</a:t>
+            </a:r>
+            <a:endParaRPr lang="en-US" dirty="0"/>
+          </a:p>
+          <a:p>
+            <a:endParaRPr lang="en-US" dirty="0"/>
+          </a:p>
+          <a:p>
+            <a:r>
+              <a:rPr lang="en-US" dirty="0"/>
+              <a:t>──── INSTRUCTOR GUIDE ────</a:t>
+            </a:r>
+            <a:endParaRPr lang="en-US" dirty="0"/>
+          </a:p>
+          <a:p>
+            <a:r>
+              <a:rPr lang="en-US" dirty="0"/>
+              <a:t>ONE SDK, THREE ADDRESSES</a:t>
+            </a:r>
+            <a:endParaRPr lang="en-US" dirty="0"/>
+          </a:p>
+          <a:p>
+            <a:r>
+              <a:rPr lang="en-US" dirty="0"/>
+              <a:t>Open prep-kit/code/providers.py next to the slide. The whole provider table is three entries with a URL, a key name and a default model. Then run chat.py twice with two different --provider values and point out that only the bracket line changes.</a:t>
             </a:r>
             <a:endParaRPr lang="en-US" dirty="0"/>
           </a:p>
@@ -1435,8 +1848,34 @@
           <a:lstStyle/>
           <a:p>
             <a:r>
+              <a:rPr lang="en-US" b="1" dirty="0"/>
+              <a:t>POINT:</a:t>
+            </a:r>
+            <a:r>
               <a:rPr lang="en-US" dirty="0"/>
-              <a:t>Read it line by line: make a client pointed at an address with a key, send a model name and messages, print the reply and the two token counts. That's it. Everything clever in the next four weeks happens around this call, not inside it. chat.py adds a timer and turns the usual errors (missing key, 401, 429, 404) into a sentence with a fix.</a:t>
+              <a:t> Everything clever in the next four weeks happens around this call, not inside it.</a:t>
+            </a:r>
+            <a:endParaRPr lang="en-US" dirty="0"/>
+          </a:p>
+          <a:p>
+            <a:r>
+              <a:rPr lang="en-US" b="1" dirty="0"/>
+              <a:t>DO:</a:t>
+            </a:r>
+            <a:r>
+              <a:rPr lang="en-US" dirty="0"/>
+              <a:t> Read it line by line: a client with an address and a key, a model name and messages, then the reply and two token counts.</a:t>
+            </a:r>
+            <a:endParaRPr lang="en-US" dirty="0"/>
+          </a:p>
+          <a:p>
+            <a:r>
+              <a:rPr lang="en-US" b="1" dirty="0"/>
+              <a:t>IF ASKED:</a:t>
+            </a:r>
+            <a:r>
+              <a:rPr lang="en-US" dirty="0"/>
+              <a:t> chat.py adds a timer and turns the usual errors (missing key, 401, 429, 404) into a sentence with a fix.</a:t>
             </a:r>
             <a:endParaRPr lang="en-US" dirty="0"/>
           </a:p>
@@ -1523,8 +1962,34 @@
           <a:lstStyle/>
           <a:p>
             <a:r>
+              <a:rPr lang="en-US" b="1" dirty="0"/>
+              <a:t>POINT:</a:t>
+            </a:r>
+            <a:r>
               <a:rPr lang="en-US" dirty="0"/>
-              <a:t>Set the tone: relaxed. Many of them already know half of this (most developers have used a terminal and an API), and that's fine; tell those people to go straight to steps 04, 05 and 08. The one thing that must be done before Monday is step 08: a paid course key and the full install, because that install takes 10 to 20 minutes and we don't want to spend class time on it.</a:t>
+              <a:t> Only step 08 must be done before Monday: a paid course key and the full install.</a:t>
+            </a:r>
+            <a:endParaRPr lang="en-US" dirty="0"/>
+          </a:p>
+          <a:p>
+            <a:r>
+              <a:rPr lang="en-US" b="1" dirty="0"/>
+              <a:t>SAY:</a:t>
+            </a:r>
+            <a:r>
+              <a:rPr lang="en-US" dirty="0"/>
+              <a:t> Keep it relaxed. "Already use a terminal and APIs? Go straight to steps 04, 05 and 08."</a:t>
+            </a:r>
+            <a:endParaRPr lang="en-US" dirty="0"/>
+          </a:p>
+          <a:p>
+            <a:r>
+              <a:rPr lang="en-US" b="1" dirty="0"/>
+              <a:t>IF ASKED:</a:t>
+            </a:r>
+            <a:r>
+              <a:rPr lang="en-US" dirty="0"/>
+              <a:t> The install takes 10 to 20 minutes, and we don't want to spend class time on it.</a:t>
             </a:r>
             <a:endParaRPr lang="en-US" dirty="0"/>
           </a:p>
@@ -1611,8 +2076,34 @@
           <a:lstStyle/>
           <a:p>
             <a:r>
+              <a:rPr lang="en-US" b="1" dirty="0"/>
+              <a:t>POINT:</a:t>
+            </a:r>
+            <a:r>
               <a:rPr lang="en-US" dirty="0"/>
-              <a:t>Go through each card. Gemini is the easiest start, but warn about the free-tier data rule: never send anything personal or from work. OpenRouter is useful because it shows how many models exist; the model name in chat.py's output changes as openrouter/free picks different ones. Ollama is the one that makes "a model is a file of numbers" concrete. Then the warning: none of these three is wired into the course checkpoints.</a:t>
+              <a:t> Three free ways to practise. None of them is wired into the course code.</a:t>
+            </a:r>
+            <a:endParaRPr lang="en-US" dirty="0"/>
+          </a:p>
+          <a:p>
+            <a:r>
+              <a:rPr lang="en-US" b="1" dirty="0"/>
+              <a:t>WATCH OUT:</a:t>
+            </a:r>
+            <a:r>
+              <a:rPr lang="en-US" dirty="0"/>
+              <a:t> Gemini's free tier may use what you send. Never send anything personal or from work.</a:t>
+            </a:r>
+            <a:endParaRPr lang="en-US" dirty="0"/>
+          </a:p>
+          <a:p>
+            <a:r>
+              <a:rPr lang="en-US" b="1" dirty="0"/>
+              <a:t>SAY:</a:t>
+            </a:r>
+            <a:r>
+              <a:rPr lang="en-US" dirty="0"/>
+              <a:t> "OpenRouter shows how many models exist: the model name in the output changes as openrouter/free picks one. Ollama shows that a model is just a file of numbers."</a:t>
             </a:r>
             <a:endParaRPr lang="en-US" dirty="0"/>
           </a:p>
@@ -1699,8 +2190,34 @@
           <a:lstStyle/>
           <a:p>
             <a:r>
+              <a:rPr lang="en-US" b="1" dirty="0"/>
+              <a:t>POINT:</a:t>
+            </a:r>
+            <a:r>
               <a:rPr lang="en-US" dirty="0"/>
-              <a:t>The bracket line is the thing to point at: which model answered, tokens in, tokens out, milliseconds. Those four numbers come back in every session. The exact numbers on the slide are an example; theirs will differ. The temperature exercise shows randomness directly. If someone gets 429, that's the free tier: wait a minute. If they get 401, show_env.py will usually spot a stray space or quote mark.</a:t>
+              <a:t> Everyone gets one working call, and sees temperature change the answers.</a:t>
+            </a:r>
+            <a:endParaRPr lang="en-US" dirty="0"/>
+          </a:p>
+          <a:p>
+            <a:r>
+              <a:rPr lang="en-US" b="1" dirty="0"/>
+              <a:t>DO:</a:t>
+            </a:r>
+            <a:r>
+              <a:rPr lang="en-US" dirty="0"/>
+              <a:t> Point at the bracket line: model, tokens in, tokens out, milliseconds. Those four numbers come back every session. Theirs will differ from the slide.</a:t>
+            </a:r>
+            <a:endParaRPr lang="en-US" dirty="0"/>
+          </a:p>
+          <a:p>
+            <a:r>
+              <a:rPr lang="en-US" b="1" dirty="0"/>
+              <a:t>WATCH OUT:</a:t>
+            </a:r>
+            <a:r>
+              <a:rPr lang="en-US" dirty="0"/>
+              <a:t> 429 is the free tier: wait a minute. 401: show_env.py usually spots a stray space or quote mark.</a:t>
             </a:r>
             <a:endParaRPr lang="en-US" dirty="0"/>
           </a:p>
@@ -1787,11 +2304,58 @@
           <a:lstStyle/>
           <a:p>
             <a:r>
+              <a:rPr lang="en-US" b="1" dirty="0"/>
+              <a:t>POINT:</a:t>
+            </a:r>
+            <a:r>
               <a:rPr lang="en-US" dirty="0"/>
-              <a:t>The first call is slow, 10 to 20 seconds, because the model loads into memory; later calls are much faster. Then the party trick: turn off Wi-Fi and run it again. It still works. The crash on the slide is real: we hit it on a Windows laptop while building this kit, and running on the CPU fixed it. If a laptop can't run a model at all, that's fine; Gemini and OpenRouter cover everything else.
-──── INSTRUCTOR GUIDE ────
-A MODEL ON YOUR OWN LAPTOP
-Turn off your Wi-Fi on screen and run the Ollama call. The first call after a restart takes 10 to 20 seconds to load the model; warn them before it happens so the silence doesn't look like a failure.</a:t>
+              <a:t> A model can run on your own laptop, even offline.</a:t>
+            </a:r>
+            <a:endParaRPr lang="en-US" dirty="0"/>
+          </a:p>
+          <a:p>
+            <a:r>
+              <a:rPr lang="en-US" b="1" dirty="0"/>
+              <a:t>DO:</a:t>
+            </a:r>
+            <a:r>
+              <a:rPr lang="en-US" dirty="0"/>
+              <a:t> Warn them the first call takes 10 to 20 seconds while the model loads. Then turn off Wi-Fi and run it again. It still works.</a:t>
+            </a:r>
+            <a:endParaRPr lang="en-US" dirty="0"/>
+          </a:p>
+          <a:p>
+            <a:r>
+              <a:rPr lang="en-US" b="1" dirty="0"/>
+              <a:t>WATCH OUT:</a:t>
+            </a:r>
+            <a:r>
+              <a:rPr lang="en-US" dirty="0"/>
+              <a:t> The CUDA crash is real; the CPU fix works. No model runs at all? Fine: Gemini and OpenRouter cover the rest.</a:t>
+            </a:r>
+            <a:endParaRPr lang="en-US" dirty="0"/>
+          </a:p>
+          <a:p>
+            <a:endParaRPr lang="en-US" dirty="0"/>
+          </a:p>
+          <a:p>
+            <a:r>
+              <a:rPr lang="en-US" dirty="0"/>
+              <a:t>──── INSTRUCTOR GUIDE ────</a:t>
+            </a:r>
+            <a:endParaRPr lang="en-US" dirty="0"/>
+          </a:p>
+          <a:p>
+            <a:r>
+              <a:rPr lang="en-US" dirty="0"/>
+              <a:t>A MODEL ON YOUR OWN LAPTOP</a:t>
+            </a:r>
+            <a:endParaRPr lang="en-US" dirty="0"/>
+          </a:p>
+          <a:p>
+            <a:r>
+              <a:rPr lang="en-US" dirty="0"/>
+              <a:t>Turn off your Wi-Fi on screen and run the Ollama call. The first call after a restart takes 10 to 20 seconds to load the model; warn them before it happens so the silence doesn't look like a failure.</a:t>
             </a:r>
             <a:endParaRPr lang="en-US" dirty="0"/>
           </a:p>
@@ -1878,8 +2442,34 @@
           <a:lstStyle/>
           <a:p>
             <a:r>
+              <a:rPr lang="en-US" b="1" dirty="0"/>
+              <a:t>POINT:</a:t>
+            </a:r>
+            <a:r>
               <a:rPr lang="en-US" dirty="0"/>
-              <a:t>This runs offline, nothing is sent. Before a model sees text, a tokenizer cuts it into chunks and turns each into a number. Point at 482 and 91: that's part of why models sometimes garble long numbers when they copy them. Other languages, Arabic included, usually take more tokens for the same meaning, so they cost more. Session 1 goes much deeper on this.</a:t>
+              <a:t> Models read tokens, not words. The order number is two pieces the model never sees as one.</a:t>
+            </a:r>
+            <a:endParaRPr lang="en-US" dirty="0"/>
+          </a:p>
+          <a:p>
+            <a:r>
+              <a:rPr lang="en-US" b="1" dirty="0"/>
+              <a:t>SAY:</a:t>
+            </a:r>
+            <a:r>
+              <a:rPr lang="en-US" dirty="0"/>
+              <a:t> "A tokenizer cuts text into chunks and turns each into a number." Point at 482 and 91: that's part of why models sometimes garble long numbers when copying them.</a:t>
+            </a:r>
+            <a:endParaRPr lang="en-US" dirty="0"/>
+          </a:p>
+          <a:p>
+            <a:r>
+              <a:rPr lang="en-US" b="1" dirty="0"/>
+              <a:t>IF ASKED:</a:t>
+            </a:r>
+            <a:r>
+              <a:rPr lang="en-US" dirty="0"/>
+              <a:t> It runs offline; nothing is sent. Session 1 goes deeper.</a:t>
             </a:r>
             <a:endParaRPr lang="en-US" dirty="0"/>
           </a:p>
@@ -1966,8 +2556,45 @@
           <a:lstStyle/>
           <a:p>
             <a:r>
+              <a:rPr lang="en-US" b="1" dirty="0"/>
+              <a:t>POINT:</a:t>
+            </a:r>
+            <a:r>
               <a:rPr lang="en-US" dirty="0"/>
-              <a:t>Moved here from Session 1. Ask who has built a product for Arabic-speaking users. English: 7 words, 7 tokens. Modern Standard Arabic: 4 words, 10 tokens. Lebanese dialect: 3 words, 7 tokens. So an Arabic ticket costs more, takes a little longer, and fills more of the model's space for that call. Estimate costs with your real customers' language, not English test data. Counts are from the GPT-4o tokenizer (o200k_base); other providers' tokenizers differ, and the gap has narrowed but not closed.</a:t>
+              <a:t> The same request costs more in Arabic, because the tokenizer learned mostly from English.</a:t>
+            </a:r>
+            <a:endParaRPr lang="en-US" dirty="0"/>
+          </a:p>
+          <a:p>
+            <a:r>
+              <a:rPr lang="en-US" b="1" dirty="0"/>
+              <a:t>DO:</a:t>
+            </a:r>
+            <a:r>
+              <a:rPr lang="en-US" dirty="0"/>
+              <a:t> Ask who has built a product for Arabic-speaking users.</a:t>
+            </a:r>
+            <a:endParaRPr lang="en-US" dirty="0"/>
+          </a:p>
+          <a:p>
+            <a:r>
+              <a:rPr lang="en-US" b="1" dirty="0"/>
+              <a:t>SAY:</a:t>
+            </a:r>
+            <a:r>
+              <a:rPr lang="en-US" dirty="0"/>
+              <a:t> "More tokens means more cost and a little more time. Estimate costs with your real customers' language, not English test data."</a:t>
+            </a:r>
+            <a:endParaRPr lang="en-US" dirty="0"/>
+          </a:p>
+          <a:p>
+            <a:r>
+              <a:rPr lang="en-US" b="1" dirty="0"/>
+              <a:t>IF ASKED:</a:t>
+            </a:r>
+            <a:r>
+              <a:rPr lang="en-US" dirty="0"/>
+              <a:t> Counts are from the GPT-4o tokenizer (o200k_base). Other tokenizers differ; the gap has narrowed but not closed.</a:t>
             </a:r>
             <a:endParaRPr lang="en-US" dirty="0"/>
           </a:p>
@@ -2054,8 +2681,34 @@
           <a:lstStyle/>
           <a:p>
             <a:r>
+              <a:rPr lang="en-US" b="1" dirty="0"/>
+              <a:t>POINT:</a:t>
+            </a:r>
+            <a:r>
               <a:rPr lang="en-US" dirty="0"/>
-              <a:t>The arithmetic is input tokens times input price plus output tokens times output price, divided by a million. count_tokens.py does it for them. The point isn't the exact figures; it's that the model choice dominates the bill, and the reply usually costs more than the question. compare.py then sends one ticket to every provider they've set up and prints the time each took. Times change from run to run, which is why Session 1 measures speed over many calls.</a:t>
+              <a:t> The choice of model dominates the bill, and the reply usually costs more than the question.</a:t>
+            </a:r>
+            <a:endParaRPr lang="en-US" dirty="0"/>
+          </a:p>
+          <a:p>
+            <a:r>
+              <a:rPr lang="en-US" b="1" dirty="0"/>
+              <a:t>SAY:</a:t>
+            </a:r>
+            <a:r>
+              <a:rPr lang="en-US" dirty="0"/>
+              <a:t> "Input tokens times input price, plus output tokens times output price, divided by a million." count_tokens.py does it for them.</a:t>
+            </a:r>
+            <a:endParaRPr lang="en-US" dirty="0"/>
+          </a:p>
+          <a:p>
+            <a:r>
+              <a:rPr lang="en-US" b="1" dirty="0"/>
+              <a:t>IF ASKED:</a:t>
+            </a:r>
+            <a:r>
+              <a:rPr lang="en-US" dirty="0"/>
+              <a:t> compare.py times one ticket on every provider they've set up. Times vary run to run; Session 1 measures over many calls.</a:t>
             </a:r>
             <a:endParaRPr lang="en-US" dirty="0"/>
           </a:p>
@@ -2142,8 +2795,34 @@
           <a:lstStyle/>
           <a:p>
             <a:r>
+              <a:rPr lang="en-US" b="1" dirty="0"/>
+              <a:t>ASK:</a:t>
+            </a:r>
+            <a:r>
               <a:rPr lang="en-US" dirty="0"/>
-              <a:t>Answers. 1: The address (base_url) and the key, plus the model name, which is just a string. The code that builds the request stays the same. 2: Revoke the key in the provider's dashboard right away, then make a new one. Deleting the commit isn't enough: the key is already out. 3: What the model writes (output). For gpt-4o-mini it's four times the input price.</a:t>
+              <a:t> Question 1. Answer: The address (base_url), the key and the model name, which is just a string. The request code stays the same.</a:t>
+            </a:r>
+            <a:endParaRPr lang="en-US" dirty="0"/>
+          </a:p>
+          <a:p>
+            <a:r>
+              <a:rPr lang="en-US" b="1" dirty="0"/>
+              <a:t>ASK:</a:t>
+            </a:r>
+            <a:r>
+              <a:rPr lang="en-US" dirty="0"/>
+              <a:t> Question 2. Answer: Revoke it in the provider's dashboard right away, then make a new one. Deleting the commit isn't enough: the key is already out.</a:t>
+            </a:r>
+            <a:endParaRPr lang="en-US" dirty="0"/>
+          </a:p>
+          <a:p>
+            <a:r>
+              <a:rPr lang="en-US" b="1" dirty="0"/>
+              <a:t>ASK:</a:t>
+            </a:r>
+            <a:r>
+              <a:rPr lang="en-US" dirty="0"/>
+              <a:t> Question 3. Answer: What the model writes. For gpt-4o-mini, four times the input price.</a:t>
             </a:r>
             <a:endParaRPr lang="en-US" dirty="0"/>
           </a:p>
@@ -2230,8 +2909,34 @@
           <a:lstStyle/>
           <a:p>
             <a:r>
+              <a:rPr lang="en-US" b="1" dirty="0"/>
+              <a:t>POINT:</a:t>
+            </a:r>
+            <a:r>
               <a:rPr lang="en-US" dirty="0"/>
-              <a:t>This is a small version of checkpoint 01, with the same labels: category, priority, sentiment. The prompt says "reply with ONLY a JSON object", and models still say "Sure! Here's the JSON", wrap it in a code fence, or invent a category. parse_reply in the script checks every reply. The sentence to leave them with is the title: the model suggests, your code decides. That rule runs through the whole course, especially for refunds.</a:t>
+              <a:t> The model suggests, your code decides. That rule runs through the whole course, especially for refunds.</a:t>
+            </a:r>
+            <a:endParaRPr lang="en-US" dirty="0"/>
+          </a:p>
+          <a:p>
+            <a:r>
+              <a:rPr lang="en-US" b="1" dirty="0"/>
+              <a:t>SAY:</a:t>
+            </a:r>
+            <a:r>
+              <a:rPr lang="en-US" dirty="0"/>
+              <a:t> "The prompt says reply with ONLY a JSON object, and models still say 'Sure! Here's the JSON', wrap it in a code fence, or invent a category."</a:t>
+            </a:r>
+            <a:endParaRPr lang="en-US" dirty="0"/>
+          </a:p>
+          <a:p>
+            <a:r>
+              <a:rPr lang="en-US" b="1" dirty="0"/>
+              <a:t>IF ASKED:</a:t>
+            </a:r>
+            <a:r>
+              <a:rPr lang="en-US" dirty="0"/>
+              <a:t> It's a small version of checkpoint 01, with the same labels.</a:t>
             </a:r>
             <a:endParaRPr lang="en-US" dirty="0"/>
           </a:p>
@@ -2318,11 +3023,58 @@
           <a:lstStyle/>
           <a:p>
             <a:r>
+              <a:rPr lang="en-US" b="1" dirty="0"/>
+              <a:t>POINT:</a:t>
+            </a:r>
+            <a:r>
               <a:rPr lang="en-US" dirty="0"/>
-              <a:t>This is a real run from building the kit. The reply passed every check: valid JSON, allowed values. And it's wrong. Nothing is defective, the customer got a duplicate gift and wants to return it. Code can't see that by looking at one reply. You find it by running many tickets where you already know the right answer, which is what evaluation in Session 10 is. Session 2 deals with the first kind using structured outputs.
-──── INSTRUCTOR GUIDE ────
-TWO KINDS OF WRONG
-This is the most important slide of the second half. The T-1011 result is real: llama3.2 labelled a duplicate gift as product_defect, and the reply passed every check. Ask the room what code could catch that. The honest answer is "none, by looking at one reply", which sets up Session 10.</a:t>
+              <a:t> A reply can pass every check and still be wrong. This is a real run from building the kit.</a:t>
+            </a:r>
+            <a:endParaRPr lang="en-US" dirty="0"/>
+          </a:p>
+          <a:p>
+            <a:r>
+              <a:rPr lang="en-US" b="1" dirty="0"/>
+              <a:t>ASK:</a:t>
+            </a:r>
+            <a:r>
+              <a:rPr lang="en-US" dirty="0"/>
+              <a:t> "What code could catch this?" Answer: None, by looking at one reply. You run many tickets with known answers: evaluation, Session 10.</a:t>
+            </a:r>
+            <a:endParaRPr lang="en-US" dirty="0"/>
+          </a:p>
+          <a:p>
+            <a:r>
+              <a:rPr lang="en-US" b="1" dirty="0"/>
+              <a:t>SAY:</a:t>
+            </a:r>
+            <a:r>
+              <a:rPr lang="en-US" dirty="0"/>
+              <a:t> "Nothing is defective. The customer got a duplicate gift and wants to return it."</a:t>
+            </a:r>
+            <a:endParaRPr lang="en-US" dirty="0"/>
+          </a:p>
+          <a:p>
+            <a:endParaRPr lang="en-US" dirty="0"/>
+          </a:p>
+          <a:p>
+            <a:r>
+              <a:rPr lang="en-US" dirty="0"/>
+              <a:t>──── INSTRUCTOR GUIDE ────</a:t>
+            </a:r>
+            <a:endParaRPr lang="en-US" dirty="0"/>
+          </a:p>
+          <a:p>
+            <a:r>
+              <a:rPr lang="en-US" dirty="0"/>
+              <a:t>TWO KINDS OF WRONG</a:t>
+            </a:r>
+            <a:endParaRPr lang="en-US" dirty="0"/>
+          </a:p>
+          <a:p>
+            <a:r>
+              <a:rPr lang="en-US" dirty="0"/>
+              <a:t>This is the most important slide of the second half. The T-1011 result is real: llama3.2 labelled a duplicate gift as product_defect, and the reply passed every check. Ask the room what code could catch that. The honest answer is "none, by looking at one reply", which sets up Session 10.</a:t>
             </a:r>
             <a:endParaRPr lang="en-US" dirty="0"/>
           </a:p>
@@ -2409,8 +3161,45 @@
           <a:lstStyle/>
           <a:p>
             <a:r>
+              <a:rPr lang="en-US" b="1" dirty="0"/>
+              <a:t>POINT:</a:t>
+            </a:r>
+            <a:r>
               <a:rPr lang="en-US" dirty="0"/>
-              <a:t>This is the must-do. $10 is plenty: on the default small model a typical lab run costs cents, and the slides warn them before anything costs more. Azure works if their company already has it; the common trap is the deployment name versus the model name. Anthropic works from checkpoint 01, but Session 1's bot only speaks OpenAI or Azure and Anthropic has no embeddings API, so they'd need an OpenAI key too. Embeddings are week 3; they don't need to know what they are yet.</a:t>
+              <a:t> The must-do: a paid course key with $10 credit and a monthly budget.</a:t>
+            </a:r>
+            <a:endParaRPr lang="en-US" dirty="0"/>
+          </a:p>
+          <a:p>
+            <a:r>
+              <a:rPr lang="en-US" b="1" dirty="0"/>
+              <a:t>SAY:</a:t>
+            </a:r>
+            <a:r>
+              <a:rPr lang="en-US" dirty="0"/>
+              <a:t> "$10 is plenty. On the default small model an evening's steps cost cents, and the slides warn you before anything costs more."</a:t>
+            </a:r>
+            <a:endParaRPr lang="en-US" dirty="0"/>
+          </a:p>
+          <a:p>
+            <a:r>
+              <a:rPr lang="en-US" b="1" dirty="0"/>
+              <a:t>WATCH OUT:</a:t>
+            </a:r>
+            <a:r>
+              <a:rPr lang="en-US" dirty="0"/>
+              <a:t> Azure: deployment name, not model name.</a:t>
+            </a:r>
+            <a:endParaRPr lang="en-US" dirty="0"/>
+          </a:p>
+          <a:p>
+            <a:r>
+              <a:rPr lang="en-US" b="1" dirty="0"/>
+              <a:t>IF ASKED:</a:t>
+            </a:r>
+            <a:r>
+              <a:rPr lang="en-US" dirty="0"/>
+              <a:t> Anthropic alone fails because Session 1's bot only speaks OpenAI or Azure, and Anthropic has no embeddings API (week 3).</a:t>
             </a:r>
             <a:endParaRPr lang="en-US" dirty="0"/>
           </a:p>
@@ -2497,8 +3286,45 @@
           <a:lstStyle/>
           <a:p>
             <a:r>
+              <a:rPr lang="en-US" b="1" dirty="0"/>
+              <a:t>POINT:</a:t>
+            </a:r>
+            <a:r>
               <a:rPr lang="en-US" dirty="0"/>
-              <a:t>Keep this short; Session 1 tells the story properly. The point is that every tool today shows up again in that story. The kit's data/tickets.json holds the same 60 tickets they'll use all month, so T-1001 will feel familiar on Monday.</a:t>
+              <a:t> Every tool today shows up again in the Resolvo story.</a:t>
+            </a:r>
+            <a:endParaRPr lang="en-US" dirty="0"/>
+          </a:p>
+          <a:p>
+            <a:r>
+              <a:rPr lang="en-US" b="1" dirty="0"/>
+              <a:t>SAY:</a:t>
+            </a:r>
+            <a:r>
+              <a:rPr lang="en-US" dirty="0"/>
+              <a:t> "You'll meet this ticket again on Monday." Keep it short; Session 1 tells the story properly.</a:t>
+            </a:r>
+            <a:endParaRPr lang="en-US" dirty="0"/>
+          </a:p>
+          <a:p>
+            <a:r>
+              <a:rPr lang="en-US" b="1" dirty="0"/>
+              <a:t>SAY:</a:t>
+            </a:r>
+            <a:r>
+              <a:rPr lang="en-US" dirty="0"/>
+              <a:t> "In class I drive and you steer: you pick the tickets, call the predictions, vote at the approval gate. Every session ends with a one-page 'try this tonight', and that's what today's setup is for."</a:t>
+            </a:r>
+            <a:endParaRPr lang="en-US" dirty="0"/>
+          </a:p>
+          <a:p>
+            <a:r>
+              <a:rPr lang="en-US" b="1" dirty="0"/>
+              <a:t>IF ASKED:</a:t>
+            </a:r>
+            <a:r>
+              <a:rPr lang="en-US" dirty="0"/>
+              <a:t> The kit's data/tickets.json holds the same 60 tickets they'll use all month, so T-1001 will feel familiar.</a:t>
             </a:r>
             <a:endParaRPr lang="en-US" dirty="0"/>
           </a:p>
@@ -2585,21 +3411,139 @@
           <a:lstStyle/>
           <a:p>
             <a:r>
+              <a:rPr lang="en-US" b="1" dirty="0"/>
+              <a:t>POINT:</a:t>
+            </a:r>
+            <a:r>
               <a:rPr lang="en-US" dirty="0"/>
-              <a:t>This is where students leave the kit: they clone the course repo next to it and give it its own venv. The check runs from inside the course folder with the course venv active; if they forget to switch, it says "This is the prep kit's venv" and how to fix it. The template starts with LLM_PROVIDER=azure, so the most common slip is filling in the OpenAI key and leaving that line alone; the setup check spots it and says which line to change. The check never prints a key, it only looks at which settings are filled in. --live makes one tiny real call, a fraction of a cent. Warn lines are fine; only FAIL lines need fixing, and each one prints what to do.
-──── INSTRUCTOR GUIDE ────
-COMMON PROBLEMS
-Symptom — Cause — Fix
-py not found (Windows) — Python not installed, or installed without the launcher — Reinstall from python.org with the defaults
-running scripts is disabled — PowerShell execution policy — Set-ExecutionPolicy -Scope CurrentUser RemoteSigned
-MISSING packages right after pip install — pip ran outside the venv — Activate, install again
-Gemini or OpenRouter 401 — Key pasted with a space or quotes — show_env.py flags both
-429 on Gemini or OpenRouter — Free-tier rate limit — Wait a minute; OpenRouter allows about 50 free requests a day without credit
-Ollama 500 mentioning CUDA — GPU driver problem — Quit Ollama, then $env:CUDA_VISIBLE_DEVICES="-1"; ollama serve
-check_setup.py: "This is the prep kit's venv" — Ran the check before switching venvs — deactivate, then activate resolvo-workshop/.venv and run it from there
-check_setup.py: "you filled in the openai key" — Template still says LLM_PROVIDER=azure — Change that line to openai
-Azure DeploymentNotFound (404) — Model name used instead of deployment name — Use the name chosen when deploying
-Course install takes forever — It's big: LangChain, LangGraph, RAGAS, DeepEval — Normal. Start it before the call ends</a:t>
+              <a:t> Clone the course repo next to the kit, give it its own venv, and run the check until it says Ready.</a:t>
+            </a:r>
+            <a:endParaRPr lang="en-US" dirty="0"/>
+          </a:p>
+          <a:p>
+            <a:r>
+              <a:rPr lang="en-US" b="1" dirty="0"/>
+              <a:t>WATCH OUT:</a:t>
+            </a:r>
+            <a:r>
+              <a:rPr lang="en-US" dirty="0"/>
+              <a:t> The template starts with LLM_PROVIDER=azure. Students fill in the OpenAI key and miss that line. The check names it.</a:t>
+            </a:r>
+            <a:endParaRPr lang="en-US" dirty="0"/>
+          </a:p>
+          <a:p>
+            <a:r>
+              <a:rPr lang="en-US" b="1" dirty="0"/>
+              <a:t>SAY:</a:t>
+            </a:r>
+            <a:r>
+              <a:rPr lang="en-US" dirty="0"/>
+              <a:t> "Warn lines are fine. Only FAIL lines need fixing, and each prints what to do."</a:t>
+            </a:r>
+            <a:endParaRPr lang="en-US" dirty="0"/>
+          </a:p>
+          <a:p>
+            <a:r>
+              <a:rPr lang="en-US" b="1" dirty="0"/>
+              <a:t>IF ASKED:</a:t>
+            </a:r>
+            <a:r>
+              <a:rPr lang="en-US" dirty="0"/>
+              <a:t> --live makes one tiny real call, a fraction of a cent.</a:t>
+            </a:r>
+            <a:endParaRPr lang="en-US" dirty="0"/>
+          </a:p>
+          <a:p>
+            <a:endParaRPr lang="en-US" dirty="0"/>
+          </a:p>
+          <a:p>
+            <a:r>
+              <a:rPr lang="en-US" dirty="0"/>
+              <a:t>──── INSTRUCTOR GUIDE ────</a:t>
+            </a:r>
+            <a:endParaRPr lang="en-US" dirty="0"/>
+          </a:p>
+          <a:p>
+            <a:r>
+              <a:rPr lang="en-US" dirty="0"/>
+              <a:t>COMMON PROBLEMS</a:t>
+            </a:r>
+            <a:endParaRPr lang="en-US" dirty="0"/>
+          </a:p>
+          <a:p>
+            <a:r>
+              <a:rPr lang="en-US" dirty="0"/>
+              <a:t>Symptom — Cause — Fix</a:t>
+            </a:r>
+            <a:endParaRPr lang="en-US" dirty="0"/>
+          </a:p>
+          <a:p>
+            <a:r>
+              <a:rPr lang="en-US" dirty="0"/>
+              <a:t>py not found (Windows) — Python not installed, or installed without the launcher — Reinstall from python.org with the defaults</a:t>
+            </a:r>
+            <a:endParaRPr lang="en-US" dirty="0"/>
+          </a:p>
+          <a:p>
+            <a:r>
+              <a:rPr lang="en-US" dirty="0"/>
+              <a:t>running scripts is disabled — PowerShell execution policy — Set-ExecutionPolicy -Scope CurrentUser RemoteSigned</a:t>
+            </a:r>
+            <a:endParaRPr lang="en-US" dirty="0"/>
+          </a:p>
+          <a:p>
+            <a:r>
+              <a:rPr lang="en-US" dirty="0"/>
+              <a:t>MISSING packages right after pip install — pip ran outside the venv — Activate, install again</a:t>
+            </a:r>
+            <a:endParaRPr lang="en-US" dirty="0"/>
+          </a:p>
+          <a:p>
+            <a:r>
+              <a:rPr lang="en-US" dirty="0"/>
+              <a:t>Gemini or OpenRouter 401 — Key pasted with a space or quotes — show_env.py flags both</a:t>
+            </a:r>
+            <a:endParaRPr lang="en-US" dirty="0"/>
+          </a:p>
+          <a:p>
+            <a:r>
+              <a:rPr lang="en-US" dirty="0"/>
+              <a:t>429 on Gemini or OpenRouter — Free-tier rate limit — Wait a minute; OpenRouter allows about 50 free requests a day without credit</a:t>
+            </a:r>
+            <a:endParaRPr lang="en-US" dirty="0"/>
+          </a:p>
+          <a:p>
+            <a:r>
+              <a:rPr lang="en-US" dirty="0"/>
+              <a:t>Ollama 500 mentioning CUDA — GPU driver problem — Quit Ollama, then $env:CUDA_VISIBLE_DEVICES="-1"; ollama serve</a:t>
+            </a:r>
+            <a:endParaRPr lang="en-US" dirty="0"/>
+          </a:p>
+          <a:p>
+            <a:r>
+              <a:rPr lang="en-US" dirty="0"/>
+              <a:t>check_setup.py: "This is the prep kit's venv" — Ran the check before switching venvs — deactivate, then activate resolvo-workshop/.venv and run it from there</a:t>
+            </a:r>
+            <a:endParaRPr lang="en-US" dirty="0"/>
+          </a:p>
+          <a:p>
+            <a:r>
+              <a:rPr lang="en-US" dirty="0"/>
+              <a:t>check_setup.py: "you filled in the openai key" — Template still says LLM_PROVIDER=azure — Change that line to openai</a:t>
+            </a:r>
+            <a:endParaRPr lang="en-US" dirty="0"/>
+          </a:p>
+          <a:p>
+            <a:r>
+              <a:rPr lang="en-US" dirty="0"/>
+              <a:t>Azure DeploymentNotFound (404) — Model name used instead of deployment name — Use the name chosen when deploying</a:t>
+            </a:r>
+            <a:endParaRPr lang="en-US" dirty="0"/>
+          </a:p>
+          <a:p>
+            <a:r>
+              <a:rPr lang="en-US" dirty="0"/>
+              <a:t>Course install takes forever — It's big: LangChain, LangGraph, RAGAS, DeepEval — Normal. Start it before the call ends</a:t>
             </a:r>
             <a:endParaRPr lang="en-US" dirty="0"/>
           </a:p>
@@ -2686,8 +3630,34 @@
           <a:lstStyle/>
           <a:p>
             <a:r>
+              <a:rPr lang="en-US" b="1" dirty="0"/>
+              <a:t>POINT:</a:t>
+            </a:r>
+            <a:r>
               <a:rPr lang="en-US" dirty="0"/>
-              <a:t>Leave this up at the end of the call. The order matters less than the last two items. Anything they don't finish today, they can finish this weekend from the step pages. You won't need Docker. If they already use an AI coding assistant, they should bring it; if not, they install a free one before Session 3 (step 08 of the kit says how), because that session's lab needs it from the first minute.</a:t>
+              <a:t> The last two items matter most: the setup check says Ready, and git pull on the morning of Session 1.</a:t>
+            </a:r>
+            <a:endParaRPr lang="en-US" dirty="0"/>
+          </a:p>
+          <a:p>
+            <a:r>
+              <a:rPr lang="en-US" b="1" dirty="0"/>
+              <a:t>DO:</a:t>
+            </a:r>
+            <a:r>
+              <a:rPr lang="en-US" dirty="0"/>
+              <a:t> Leave this up at the end of the call.</a:t>
+            </a:r>
+            <a:endParaRPr lang="en-US" dirty="0"/>
+          </a:p>
+          <a:p>
+            <a:r>
+              <a:rPr lang="en-US" b="1" dirty="0"/>
+              <a:t>IF ASKED:</a:t>
+            </a:r>
+            <a:r>
+              <a:rPr lang="en-US" dirty="0"/>
+              <a:t> No Docker needed. In Session 3 you watch me use an AI coding assistant; you need your own that evening to repeat it. The kit's step 08 says how to install a free one.</a:t>
             </a:r>
             <a:endParaRPr lang="en-US" dirty="0"/>
           </a:p>
@@ -2774,8 +3744,23 @@
           <a:lstStyle/>
           <a:p>
             <a:r>
+              <a:rPr lang="en-US" b="1" dirty="0"/>
+              <a:t>POINT:</a:t>
+            </a:r>
+            <a:r>
               <a:rPr lang="en-US" dirty="0"/>
-              <a:t>Thank them. Remind them where the kit lives and that the README has the checklist. Questions for five minutes, then stay on the call for anyone whose setup check still fails.</a:t>
+              <a:t> Thank them. The kit's README has the checklist and everything from today.</a:t>
+            </a:r>
+            <a:endParaRPr lang="en-US" dirty="0"/>
+          </a:p>
+          <a:p>
+            <a:r>
+              <a:rPr lang="en-US" b="1" dirty="0"/>
+              <a:t>DO:</a:t>
+            </a:r>
+            <a:r>
+              <a:rPr lang="en-US" dirty="0"/>
+              <a:t> Five minutes of questions, then stay on the call for anyone whose setup check still fails.</a:t>
             </a:r>
             <a:endParaRPr lang="en-US" dirty="0"/>
           </a:p>
@@ -2862,8 +3847,34 @@
           <a:lstStyle/>
           <a:p>
             <a:r>
+              <a:rPr lang="en-US" b="1" dirty="0"/>
+              <a:t>POINT:</a:t>
+            </a:r>
+            <a:r>
               <a:rPr lang="en-US" dirty="0"/>
-              <a:t>This is the map. Point at step 08 in bold: that's the must-do. Steps 04 and 05 are partly alternatives: a laptop that can't run a local model can skip 05, and someone who can't sign up for Google can use OpenRouter or Ollama instead. Each step page ends with a "Try this" list and an "If something went wrong" table.</a:t>
+              <a:t> Step 08 is the must-do. The rest can wait for the weekend.</a:t>
+            </a:r>
+            <a:endParaRPr lang="en-US" dirty="0"/>
+          </a:p>
+          <a:p>
+            <a:r>
+              <a:rPr lang="en-US" b="1" dirty="0"/>
+              <a:t>SAY:</a:t>
+            </a:r>
+            <a:r>
+              <a:rPr lang="en-US" dirty="0"/>
+              <a:t> "Steps 04 and 05 overlap. Laptop can't run a local model? Skip 05. Can't sign up for Google? Use OpenRouter or Ollama."</a:t>
+            </a:r>
+            <a:endParaRPr lang="en-US" dirty="0"/>
+          </a:p>
+          <a:p>
+            <a:r>
+              <a:rPr lang="en-US" b="1" dirty="0"/>
+              <a:t>IF ASKED:</a:t>
+            </a:r>
+            <a:r>
+              <a:rPr lang="en-US" dirty="0"/>
+              <a:t> Each step page ends with a "Try this" list and an "If something went wrong" table.</a:t>
             </a:r>
             <a:endParaRPr lang="en-US" dirty="0"/>
           </a:p>
@@ -2950,8 +3961,34 @@
           <a:lstStyle/>
           <a:p>
             <a:r>
+              <a:rPr lang="en-US" b="1" dirty="0"/>
+              <a:t>POINT:</a:t>
+            </a:r>
+            <a:r>
               <a:rPr lang="en-US" dirty="0"/>
-              <a:t>A terminal is a window where you type commands instead of clicking. On Windows that's PowerShell, and in VS Code Ctrl+backtick opens one inside the editor. Demo pwd, ls and cd live. The silent failure is real: Session 1's broken bot loads its policy files by relative path, so run from the repo root and it quietly answers without any policies. Tell them to look at where they are before running anything.</a:t>
+              <a:t> Check which folder you're in before you run anything.</a:t>
+            </a:r>
+            <a:endParaRPr lang="en-US" dirty="0"/>
+          </a:p>
+          <a:p>
+            <a:r>
+              <a:rPr lang="en-US" b="1" dirty="0"/>
+              <a:t>DO:</a:t>
+            </a:r>
+            <a:r>
+              <a:rPr lang="en-US" dirty="0"/>
+              <a:t> Demo pwd, ls and cd live. In VS Code, Ctrl+backtick opens a terminal.</a:t>
+            </a:r>
+            <a:endParaRPr lang="en-US" dirty="0"/>
+          </a:p>
+          <a:p>
+            <a:r>
+              <a:rPr lang="en-US" b="1" dirty="0"/>
+              <a:t>IF ASKED:</a:t>
+            </a:r>
+            <a:r>
+              <a:rPr lang="en-US" dirty="0"/>
+              <a:t> The silent failure is real. Session 1's broken bot finds its policy files by relative path. Run it from the repo root and it answers without any policies, and no error.</a:t>
             </a:r>
             <a:endParaRPr lang="en-US" dirty="0"/>
           </a:p>
@@ -3038,8 +4075,34 @@
           <a:lstStyle/>
           <a:p>
             <a:r>
+              <a:rPr lang="en-US" b="1" dirty="0"/>
+              <a:t>POINT:</a:t>
+            </a:r>
+            <a:r>
               <a:rPr lang="en-US" dirty="0"/>
-              <a:t>Packages are other people's code that your project uses, like openai or httpx. If everything goes into the one Python on your computer, projects fight over versions. A venv is a folder with its own private Python and its own packages. The analogy: a separate toolbox per job. The best property for beginners: it's disposable. If the venv gets into a bad state, delete the .venv folder and make it again. Nothing else is lost.</a:t>
+              <a:t> A venv is a private Python with its own packages, one per project.</a:t>
+            </a:r>
+            <a:endParaRPr lang="en-US" dirty="0"/>
+          </a:p>
+          <a:p>
+            <a:r>
+              <a:rPr lang="en-US" b="1" dirty="0"/>
+              <a:t>SAY:</a:t>
+            </a:r>
+            <a:r>
+              <a:rPr lang="en-US" dirty="0"/>
+              <a:t> "Packages are other people's code, like openai or httpx. In one shared Python, projects fight over versions. A venv is a separate toolbox per job."</a:t>
+            </a:r>
+            <a:endParaRPr lang="en-US" dirty="0"/>
+          </a:p>
+          <a:p>
+            <a:r>
+              <a:rPr lang="en-US" b="1" dirty="0"/>
+              <a:t>WATCH OUT:</a:t>
+            </a:r>
+            <a:r>
+              <a:rPr lang="en-US" dirty="0"/>
+              <a:t> Venv in a bad state? Delete the .venv folder and make it again. Nothing else is lost.</a:t>
             </a:r>
             <a:endParaRPr lang="en-US" dirty="0"/>
           </a:p>
@@ -3126,8 +4189,34 @@
           <a:lstStyle/>
           <a:p>
             <a:r>
+              <a:rPr lang="en-US" b="1" dirty="0"/>
+              <a:t>POINT:</a:t>
+            </a:r>
+            <a:r>
               <a:rPr lang="en-US" dirty="0"/>
-              <a:t>Three ideas: venv creates the folder, activate switches this terminal over to it, pip installs packages into it from a shopping list called requirements.txt. On Windows we use py, the Python launcher, because plain python often isn't on the PATH. The prep kit's list is small and takes a minute or two. The course gets its own venv and a much bigger list in step 08: one toolbox per project, which is the point of the previous slide.</a:t>
+              <a:t> venv makes the folder, activate switches this terminal to it, pip install fills it from a shopping list, requirements.txt.</a:t>
+            </a:r>
+            <a:endParaRPr lang="en-US" dirty="0"/>
+          </a:p>
+          <a:p>
+            <a:r>
+              <a:rPr lang="en-US" b="1" dirty="0"/>
+              <a:t>SAY:</a:t>
+            </a:r>
+            <a:r>
+              <a:rPr lang="en-US" dirty="0"/>
+              <a:t> "On Windows we use py, the Python launcher, because plain python often isn't on the PATH."</a:t>
+            </a:r>
+            <a:endParaRPr lang="en-US" dirty="0"/>
+          </a:p>
+          <a:p>
+            <a:r>
+              <a:rPr lang="en-US" b="1" dirty="0"/>
+              <a:t>IF ASKED:</a:t>
+            </a:r>
+            <a:r>
+              <a:rPr lang="en-US" dirty="0"/>
+              <a:t> The course gets its own venv and a much bigger list in step 08.</a:t>
             </a:r>
             <a:endParaRPr lang="en-US" dirty="0"/>
           </a:p>
@@ -3214,8 +4303,34 @@
           <a:lstStyle/>
           <a:p>
             <a:r>
+              <a:rPr lang="en-US" b="1" dirty="0"/>
+              <a:t>POINT:</a:t>
+            </a:r>
+            <a:r>
               <a:rPr lang="en-US" dirty="0"/>
-              <a:t>If they're following along, give them three minutes. The second run without activating is the moment it clicks: same command, different Python. If pip installed packages but the script says MISSING, the venv wasn't active when they ran pip; activate and install again.</a:t>
+              <a:t> Same command, different Python. The second run, without activating, is where it clicks.</a:t>
+            </a:r>
+            <a:endParaRPr lang="en-US" dirty="0"/>
+          </a:p>
+          <a:p>
+            <a:r>
+              <a:rPr lang="en-US" b="1" dirty="0"/>
+              <a:t>DO:</a:t>
+            </a:r>
+            <a:r>
+              <a:rPr lang="en-US" dirty="0"/>
+              <a:t> Give them three minutes if they're following along.</a:t>
+            </a:r>
+            <a:endParaRPr lang="en-US" dirty="0"/>
+          </a:p>
+          <a:p>
+            <a:r>
+              <a:rPr lang="en-US" b="1" dirty="0"/>
+              <a:t>WATCH OUT:</a:t>
+            </a:r>
+            <a:r>
+              <a:rPr lang="en-US" dirty="0"/>
+              <a:t> pip installed the packages but the script says MISSING? The venv wasn't active when they ran pip. Activate and install again.</a:t>
             </a:r>
             <a:endParaRPr lang="en-US" dirty="0"/>
           </a:p>
@@ -3302,8 +4417,23 @@
           <a:lstStyle/>
           <a:p>
             <a:r>
+              <a:rPr lang="en-US" b="1" dirty="0"/>
+              <a:t>POINT:</a:t>
+            </a:r>
+            <a:r>
               <a:rPr lang="en-US" dirty="0"/>
-              <a:t>An API is a menu another program offers you. You send a request, you get a response. Every request has a method (GET to read, POST to change), a URL, headers (notes on the envelope, like your key), and sometimes a JSON body. Every response has a status code and usually JSON. A call to a language model is exactly this shape: a POST with JSON in and JSON out. That's why we spend half an hour here.</a:t>
+              <a:t> Every API call is a request and a response. A call to a language model has exactly this shape: a POST, JSON in, JSON out.</a:t>
+            </a:r>
+            <a:endParaRPr lang="en-US" dirty="0"/>
+          </a:p>
+          <a:p>
+            <a:r>
+              <a:rPr lang="en-US" b="1" dirty="0"/>
+              <a:t>SAY:</a:t>
+            </a:r>
+            <a:r>
+              <a:rPr lang="en-US" dirty="0"/>
+              <a:t> "An API is a menu another program offers you." Headers are notes on the envelope, like your key.</a:t>
             </a:r>
             <a:endParaRPr lang="en-US" dirty="0"/>
           </a:p>
@@ -5178,7 +6308,8 @@
                 <a:ea typeface="Consolas" pitchFamily="34" charset="-122"/>
                 <a:cs typeface="Consolas" pitchFamily="34" charset="-120"/>
               </a:rPr>
-              <a:t># terminal 1, from prep-kit/ (leave it running)</a:t>
+              <a:t># terminal 1, from prep-kit/ (leave it running)
+</a:t>
             </a:r>
             <a:endParaRPr lang="en-US" sz="1350" dirty="0"/>
           </a:p>
@@ -5198,7 +6329,8 @@
                 <a:ea typeface="Consolas" pitchFamily="34" charset="-122"/>
                 <a:cs typeface="Consolas" pitchFamily="34" charset="-120"/>
               </a:rPr>
-              <a:t>uvicorn app:app --app-dir mock_api --port 9000</a:t>
+              <a:t>uvicorn app:app --app-dir mock_api --port 9000
+</a:t>
             </a:r>
             <a:endParaRPr lang="en-US" sz="1350" dirty="0"/>
           </a:p>
@@ -5218,7 +6350,8 @@
                 <a:ea typeface="Consolas" pitchFamily="34" charset="-122"/>
                 <a:cs typeface="Consolas" pitchFamily="34" charset="-120"/>
               </a:rPr>
-              <a:t> </a:t>
+              <a:t>
+</a:t>
             </a:r>
             <a:endParaRPr lang="en-US" sz="1350" dirty="0"/>
           </a:p>
@@ -5238,7 +6371,8 @@
                 <a:ea typeface="Consolas" pitchFamily="34" charset="-122"/>
                 <a:cs typeface="Consolas" pitchFamily="34" charset="-120"/>
               </a:rPr>
-              <a:t># terminal 2, from prep-kit/</a:t>
+              <a:t># terminal 2, from prep-kit/
+</a:t>
             </a:r>
             <a:endParaRPr lang="en-US" sz="1350" dirty="0"/>
           </a:p>
@@ -5670,7 +6804,8 @@
                 <a:ea typeface="Consolas" pitchFamily="34" charset="-122"/>
                 <a:cs typeface="Consolas" pitchFamily="34" charset="-120"/>
               </a:rPr>
-              <a:t>=== 3. Issue a refund</a:t>
+              <a:t>=== 3. Issue a refund
+</a:t>
             </a:r>
             <a:endParaRPr lang="en-US" sz="1350" dirty="0"/>
           </a:p>
@@ -5690,7 +6825,8 @@
                 <a:ea typeface="Consolas" pitchFamily="34" charset="-122"/>
                 <a:cs typeface="Consolas" pitchFamily="34" charset="-120"/>
               </a:rPr>
-              <a:t>POST http://localhost:9000/refunds        Idempotency-Key: prep-kit-1f2a9c3e</a:t>
+              <a:t>POST http://localhost:9000/refunds        Idempotency-Key: prep-kit-1f2a9c3e
+</a:t>
             </a:r>
             <a:endParaRPr lang="en-US" sz="1350" dirty="0"/>
           </a:p>
@@ -5710,7 +6846,8 @@
                 <a:ea typeface="Consolas" pitchFamily="34" charset="-122"/>
                 <a:cs typeface="Consolas" pitchFamily="34" charset="-120"/>
               </a:rPr>
-              <a:t>-&gt; status 200 OK      {"refund_id": "R-26762c6f", "amount_usd": 79.99}</a:t>
+              <a:t>-&gt; status 200 OK      {"refund_id": "R-26762c6f", "amount_usd": 79.99}
+</a:t>
             </a:r>
             <a:endParaRPr lang="en-US" sz="1350" dirty="0"/>
           </a:p>
@@ -5730,7 +6867,8 @@
                 <a:ea typeface="Consolas" pitchFamily="34" charset="-122"/>
                 <a:cs typeface="Consolas" pitchFamily="34" charset="-120"/>
               </a:rPr>
-              <a:t> </a:t>
+              <a:t>
+</a:t>
             </a:r>
             <a:endParaRPr lang="en-US" sz="1350" dirty="0"/>
           </a:p>
@@ -5750,7 +6888,8 @@
                 <a:ea typeface="Consolas" pitchFamily="34" charset="-122"/>
                 <a:cs typeface="Consolas" pitchFamily="34" charset="-120"/>
               </a:rPr>
-              <a:t>=== 4. Retry with the SAME key</a:t>
+              <a:t>=== 4. Retry with the SAME key
+</a:t>
             </a:r>
             <a:endParaRPr lang="en-US" sz="1350" dirty="0"/>
           </a:p>
@@ -5770,7 +6909,8 @@
                 <a:ea typeface="Consolas" pitchFamily="34" charset="-122"/>
                 <a:cs typeface="Consolas" pitchFamily="34" charset="-120"/>
               </a:rPr>
-              <a:t>POST http://localhost:9000/refunds        Idempotency-Key: prep-kit-1f2a9c3e</a:t>
+              <a:t>POST http://localhost:9000/refunds        Idempotency-Key: prep-kit-1f2a9c3e
+</a:t>
             </a:r>
             <a:endParaRPr lang="en-US" sz="1350" dirty="0"/>
           </a:p>
@@ -5805,11 +6945,11 @@
         <p:spPr>
           <a:xfrm>
             <a:off x="777240" y="3654171"/>
-            <a:ext cx="10637215" cy="1169822"/>
+            <a:ext cx="10637215" cy="868375"/>
           </a:xfrm>
           <a:prstGeom prst="roundRect">
             <a:avLst>
-              <a:gd name="adj" fmla="val 7817"/>
+              <a:gd name="adj" fmla="val 10530"/>
             </a:avLst>
           </a:prstGeom>
           <a:solidFill>
@@ -5832,7 +6972,7 @@
         <p:spPr>
           <a:xfrm>
             <a:off x="777240" y="3654171"/>
-            <a:ext cx="82296" cy="1169822"/>
+            <a:ext cx="82296" cy="868375"/>
           </a:xfrm>
           <a:prstGeom prst="rect">
             <a:avLst/>
@@ -5896,7 +7036,7 @@
         <p:spPr>
           <a:xfrm>
             <a:off x="1051560" y="4001643"/>
-            <a:ext cx="10225735" cy="657758"/>
+            <a:ext cx="10225735" cy="356311"/>
           </a:xfrm>
           <a:prstGeom prst="rect">
             <a:avLst/>
@@ -5920,7 +7060,7 @@
                 <a:ea typeface="Segoe UI" pitchFamily="34" charset="-122"/>
                 <a:cs typeface="Segoe UI" pitchFamily="34" charset="-120"/>
               </a:rPr>
-              <a:t>A receipt number on a bank transfer. Hand the clerk the same slip twice and you pay once, because they've already seen that number.</a:t>
+              <a:t>A receipt number on a bank transfer: hand the clerk the same slip twice and you pay once.</a:t>
             </a:r>
             <a:endParaRPr lang="en-US" sz="1720" dirty="0"/>
           </a:p>
@@ -5934,7 +7074,7 @@
         </p:nvSpPr>
         <p:spPr>
           <a:xfrm>
-            <a:off x="777240" y="4952009"/>
+            <a:off x="777240" y="4650562"/>
             <a:ext cx="10637215" cy="650748"/>
           </a:xfrm>
           <a:prstGeom prst="rect">
@@ -5959,7 +7099,7 @@
                 <a:ea typeface="Segoe UI" pitchFamily="34" charset="-122"/>
                 <a:cs typeface="Segoe UI" pitchFamily="34" charset="-120"/>
               </a:rPr>
-              <a:t>The caller picks a unique key for "this one refund". A retry after a timeout reuses it, so the customer is refunded </a:t>
+              <a:t>The caller picks one key for "this refund". A retry after a timeout reuses it, so the customer is refunded </a:t>
             </a:r>
             <a:pPr algn="l" indent="0" marL="0">
               <a:buNone/>
@@ -6861,7 +8001,8 @@
                 <a:ea typeface="Consolas" pitchFamily="34" charset="-122"/>
                 <a:cs typeface="Consolas" pitchFamily="34" charset="-120"/>
               </a:rPr>
-              <a:t>GEMINI_API_KEY=AIza...</a:t>
+              <a:t>GEMINI_API_KEY=AIza...
+</a:t>
             </a:r>
             <a:endParaRPr lang="en-US" sz="1350" dirty="0"/>
           </a:p>
@@ -7070,7 +8211,8 @@
                 <a:ea typeface="Consolas" pitchFamily="34" charset="-122"/>
                 <a:cs typeface="Consolas" pitchFamily="34" charset="-120"/>
               </a:rPr>
-              <a:t># Secrets</a:t>
+              <a:t># Secrets
+</a:t>
             </a:r>
             <a:endParaRPr lang="en-US" sz="1350" dirty="0"/>
           </a:p>
@@ -9342,7 +10484,8 @@
                 <a:ea typeface="Consolas" pitchFamily="34" charset="-122"/>
                 <a:cs typeface="Consolas" pitchFamily="34" charset="-120"/>
               </a:rPr>
-              <a:t>{</a:t>
+              <a:t>{
+</a:t>
             </a:r>
             <a:endParaRPr lang="en-US" sz="1350" dirty="0"/>
           </a:p>
@@ -9362,7 +10505,8 @@
                 <a:ea typeface="Consolas" pitchFamily="34" charset="-122"/>
                 <a:cs typeface="Consolas" pitchFamily="34" charset="-120"/>
               </a:rPr>
-              <a:t>  "model": "gemini-3.5-flash-lite",</a:t>
+              <a:t>  "model": "gemini-3.5-flash-lite",
+</a:t>
             </a:r>
             <a:endParaRPr lang="en-US" sz="1350" dirty="0"/>
           </a:p>
@@ -9382,7 +10526,8 @@
                 <a:ea typeface="Consolas" pitchFamily="34" charset="-122"/>
                 <a:cs typeface="Consolas" pitchFamily="34" charset="-120"/>
               </a:rPr>
-              <a:t>  "messages": [</a:t>
+              <a:t>  "messages": [
+</a:t>
             </a:r>
             <a:endParaRPr lang="en-US" sz="1350" dirty="0"/>
           </a:p>
@@ -9402,7 +10547,8 @@
                 <a:ea typeface="Consolas" pitchFamily="34" charset="-122"/>
                 <a:cs typeface="Consolas" pitchFamily="34" charset="-120"/>
               </a:rPr>
-              <a:t>    {"role": "system",</a:t>
+              <a:t>    {"role": "system",
+</a:t>
             </a:r>
             <a:endParaRPr lang="en-US" sz="1350" dirty="0"/>
           </a:p>
@@ -9422,7 +10568,8 @@
                 <a:ea typeface="Consolas" pitchFamily="34" charset="-122"/>
                 <a:cs typeface="Consolas" pitchFamily="34" charset="-120"/>
               </a:rPr>
-              <a:t>     "content": "Keep answers short."},</a:t>
+              <a:t>     "content": "Keep answers short."},
+</a:t>
             </a:r>
             <a:endParaRPr lang="en-US" sz="1350" dirty="0"/>
           </a:p>
@@ -9442,7 +10589,8 @@
                 <a:ea typeface="Consolas" pitchFamily="34" charset="-122"/>
                 <a:cs typeface="Consolas" pitchFamily="34" charset="-120"/>
               </a:rPr>
-              <a:t>    {"role": "user",</a:t>
+              <a:t>    {"role": "user",
+</a:t>
             </a:r>
             <a:endParaRPr lang="en-US" sz="1350" dirty="0"/>
           </a:p>
@@ -9462,7 +10610,8 @@
                 <a:ea typeface="Consolas" pitchFamily="34" charset="-122"/>
                 <a:cs typeface="Consolas" pitchFamily="34" charset="-120"/>
               </a:rPr>
-              <a:t>     "content": "What is an API?"}</a:t>
+              <a:t>     "content": "What is an API?"}
+</a:t>
             </a:r>
             <a:endParaRPr lang="en-US" sz="1350" dirty="0"/>
           </a:p>
@@ -9482,7 +10631,8 @@
                 <a:ea typeface="Consolas" pitchFamily="34" charset="-122"/>
                 <a:cs typeface="Consolas" pitchFamily="34" charset="-120"/>
               </a:rPr>
-              <a:t>  ],</a:t>
+              <a:t>  ],
+</a:t>
             </a:r>
             <a:endParaRPr lang="en-US" sz="1350" dirty="0"/>
           </a:p>
@@ -9502,7 +10652,8 @@
                 <a:ea typeface="Consolas" pitchFamily="34" charset="-122"/>
                 <a:cs typeface="Consolas" pitchFamily="34" charset="-120"/>
               </a:rPr>
-              <a:t>  "temperature": 0.2</a:t>
+              <a:t>  "temperature": 0.2
+</a:t>
             </a:r>
             <a:endParaRPr lang="en-US" sz="1350" dirty="0"/>
           </a:p>
@@ -9630,7 +10781,8 @@
                 <a:ea typeface="Consolas" pitchFamily="34" charset="-122"/>
                 <a:cs typeface="Consolas" pitchFamily="34" charset="-120"/>
               </a:rPr>
-              <a:t>{</a:t>
+              <a:t>{
+</a:t>
             </a:r>
             <a:endParaRPr lang="en-US" sz="1350" dirty="0"/>
           </a:p>
@@ -9650,7 +10802,8 @@
                 <a:ea typeface="Consolas" pitchFamily="34" charset="-122"/>
                 <a:cs typeface="Consolas" pitchFamily="34" charset="-120"/>
               </a:rPr>
-              <a:t>  "choices": [{"message": {</a:t>
+              <a:t>  "choices": [{"message": {
+</a:t>
             </a:r>
             <a:endParaRPr lang="en-US" sz="1350" dirty="0"/>
           </a:p>
@@ -9670,7 +10823,8 @@
                 <a:ea typeface="Consolas" pitchFamily="34" charset="-122"/>
                 <a:cs typeface="Consolas" pitchFamily="34" charset="-120"/>
               </a:rPr>
-              <a:t>    "content": "A set of rules that</a:t>
+              <a:t>    "content": "A set of rules that
+</a:t>
             </a:r>
             <a:endParaRPr lang="en-US" sz="1350" dirty="0"/>
           </a:p>
@@ -9690,7 +10844,8 @@
                 <a:ea typeface="Consolas" pitchFamily="34" charset="-122"/>
                 <a:cs typeface="Consolas" pitchFamily="34" charset="-120"/>
               </a:rPr>
-              <a:t>     lets programs talk..."}}],</a:t>
+              <a:t>     lets programs talk..."}}],
+</a:t>
             </a:r>
             <a:endParaRPr lang="en-US" sz="1350" dirty="0"/>
           </a:p>
@@ -9710,7 +10865,8 @@
                 <a:ea typeface="Consolas" pitchFamily="34" charset="-122"/>
                 <a:cs typeface="Consolas" pitchFamily="34" charset="-120"/>
               </a:rPr>
-              <a:t>  "usage": {</a:t>
+              <a:t>  "usage": {
+</a:t>
             </a:r>
             <a:endParaRPr lang="en-US" sz="1350" dirty="0"/>
           </a:p>
@@ -9730,7 +10886,8 @@
                 <a:ea typeface="Consolas" pitchFamily="34" charset="-122"/>
                 <a:cs typeface="Consolas" pitchFamily="34" charset="-120"/>
               </a:rPr>
-              <a:t>    "prompt_tokens": 31,</a:t>
+              <a:t>    "prompt_tokens": 31,
+</a:t>
             </a:r>
             <a:endParaRPr lang="en-US" sz="1350" dirty="0"/>
           </a:p>
@@ -9750,7 +10907,8 @@
                 <a:ea typeface="Consolas" pitchFamily="34" charset="-122"/>
                 <a:cs typeface="Consolas" pitchFamily="34" charset="-120"/>
               </a:rPr>
-              <a:t>    "completion_tokens": 24</a:t>
+              <a:t>    "completion_tokens": 24
+</a:t>
             </a:r>
             <a:endParaRPr lang="en-US" sz="1350" dirty="0"/>
           </a:p>
@@ -9770,7 +10928,8 @@
                 <a:ea typeface="Consolas" pitchFamily="34" charset="-122"/>
                 <a:cs typeface="Consolas" pitchFamily="34" charset="-120"/>
               </a:rPr>
-              <a:t>  }</a:t>
+              <a:t>  }
+</a:t>
             </a:r>
             <a:endParaRPr lang="en-US" sz="1350" dirty="0"/>
           </a:p>
@@ -10259,7 +11418,7 @@
                 <a:ea typeface="Segoe UI" pitchFamily="34" charset="-122"/>
                 <a:cs typeface="Segoe UI" pitchFamily="34" charset="-120"/>
               </a:rPr>
-              <a:t>. Change those two and the same code talks to a different company's model.</a:t>
+              <a:t>. Change those two, pick one of that provider's model names, and the same code talks to a different company's model.</a:t>
             </a:r>
             <a:endParaRPr lang="en-US" sz="1700" dirty="0"/>
           </a:p>
@@ -10563,7 +11722,8 @@
                 <a:ea typeface="Consolas" pitchFamily="34" charset="-122"/>
                 <a:cs typeface="Consolas" pitchFamily="34" charset="-120"/>
               </a:rPr>
-              <a:t>from openai import OpenAI</a:t>
+              <a:t>from openai import OpenAI
+</a:t>
             </a:r>
             <a:endParaRPr lang="en-US" sz="1350" dirty="0"/>
           </a:p>
@@ -10583,7 +11743,8 @@
                 <a:ea typeface="Consolas" pitchFamily="34" charset="-122"/>
                 <a:cs typeface="Consolas" pitchFamily="34" charset="-120"/>
               </a:rPr>
-              <a:t> </a:t>
+              <a:t>
+</a:t>
             </a:r>
             <a:endParaRPr lang="en-US" sz="1350" dirty="0"/>
           </a:p>
@@ -10603,7 +11764,8 @@
                 <a:ea typeface="Consolas" pitchFamily="34" charset="-122"/>
                 <a:cs typeface="Consolas" pitchFamily="34" charset="-120"/>
               </a:rPr>
-              <a:t>client = OpenAI(base_url="https://openrouter.ai/api/v1", api_key=key)</a:t>
+              <a:t>client = OpenAI(base_url="https://openrouter.ai/api/v1", api_key=key)
+</a:t>
             </a:r>
             <a:endParaRPr lang="en-US" sz="1350" dirty="0"/>
           </a:p>
@@ -10623,7 +11785,8 @@
                 <a:ea typeface="Consolas" pitchFamily="34" charset="-122"/>
                 <a:cs typeface="Consolas" pitchFamily="34" charset="-120"/>
               </a:rPr>
-              <a:t> </a:t>
+              <a:t>
+</a:t>
             </a:r>
             <a:endParaRPr lang="en-US" sz="1350" dirty="0"/>
           </a:p>
@@ -10643,7 +11806,8 @@
                 <a:ea typeface="Consolas" pitchFamily="34" charset="-122"/>
                 <a:cs typeface="Consolas" pitchFamily="34" charset="-120"/>
               </a:rPr>
-              <a:t>response = client.chat.completions.create(</a:t>
+              <a:t>response = client.chat.completions.create(
+</a:t>
             </a:r>
             <a:endParaRPr lang="en-US" sz="1350" dirty="0"/>
           </a:p>
@@ -10663,7 +11827,8 @@
                 <a:ea typeface="Consolas" pitchFamily="34" charset="-122"/>
                 <a:cs typeface="Consolas" pitchFamily="34" charset="-120"/>
               </a:rPr>
-              <a:t>    model="openrouter/free",</a:t>
+              <a:t>    model="openrouter/free",
+</a:t>
             </a:r>
             <a:endParaRPr lang="en-US" sz="1350" dirty="0"/>
           </a:p>
@@ -10683,7 +11848,8 @@
                 <a:ea typeface="Consolas" pitchFamily="34" charset="-122"/>
                 <a:cs typeface="Consolas" pitchFamily="34" charset="-120"/>
               </a:rPr>
-              <a:t>    messages=[{"role": "system", "content": "Keep answers short."},</a:t>
+              <a:t>    messages=[{"role": "system", "content": "Keep answers short."},
+</a:t>
             </a:r>
             <a:endParaRPr lang="en-US" sz="1350" dirty="0"/>
           </a:p>
@@ -10703,7 +11869,8 @@
                 <a:ea typeface="Consolas" pitchFamily="34" charset="-122"/>
                 <a:cs typeface="Consolas" pitchFamily="34" charset="-120"/>
               </a:rPr>
-              <a:t>              {"role": "user", "content": "Explain an API in one sentence."}],</a:t>
+              <a:t>              {"role": "user", "content": "Explain an API in one sentence."}],
+</a:t>
             </a:r>
             <a:endParaRPr lang="en-US" sz="1350" dirty="0"/>
           </a:p>
@@ -10723,7 +11890,8 @@
                 <a:ea typeface="Consolas" pitchFamily="34" charset="-122"/>
                 <a:cs typeface="Consolas" pitchFamily="34" charset="-120"/>
               </a:rPr>
-              <a:t>)</a:t>
+              <a:t>)
+</a:t>
             </a:r>
             <a:endParaRPr lang="en-US" sz="1350" dirty="0"/>
           </a:p>
@@ -10743,7 +11911,8 @@
                 <a:ea typeface="Consolas" pitchFamily="34" charset="-122"/>
                 <a:cs typeface="Consolas" pitchFamily="34" charset="-120"/>
               </a:rPr>
-              <a:t>print(response.choices[0].message.content)</a:t>
+              <a:t>print(response.choices[0].message.content)
+</a:t>
             </a:r>
             <a:endParaRPr lang="en-US" sz="1350" dirty="0"/>
           </a:p>
@@ -12759,7 +13928,8 @@
                 <a:ea typeface="Consolas" pitchFamily="34" charset="-122"/>
                 <a:cs typeface="Consolas" pitchFamily="34" charset="-120"/>
               </a:rPr>
-              <a:t>py code\show_env.py                  # are the keys set? (never prints them)</a:t>
+              <a:t>py code\show_env.py                  # are the keys set? (never prints them)
+</a:t>
             </a:r>
             <a:endParaRPr lang="en-US" sz="1350" dirty="0"/>
           </a:p>
@@ -12779,7 +13949,8 @@
                 <a:ea typeface="Consolas" pitchFamily="34" charset="-122"/>
                 <a:cs typeface="Consolas" pitchFamily="34" charset="-120"/>
               </a:rPr>
-              <a:t>py code\chat.py --provider gemini "Explain what an API is in one sentence."</a:t>
+              <a:t>py code\chat.py --provider gemini "Explain what an API is in one sentence."
+</a:t>
             </a:r>
             <a:endParaRPr lang="en-US" sz="1350" dirty="0"/>
           </a:p>
@@ -12799,7 +13970,8 @@
                 <a:ea typeface="Consolas" pitchFamily="34" charset="-122"/>
                 <a:cs typeface="Consolas" pitchFamily="34" charset="-120"/>
               </a:rPr>
-              <a:t>py code\chat.py --provider openrouter "Explain what an API is in one sentence."</a:t>
+              <a:t>py code\chat.py --provider openrouter "Explain what an API is in one sentence."
+</a:t>
             </a:r>
             <a:endParaRPr lang="en-US" sz="1350" dirty="0"/>
           </a:p>
@@ -12819,7 +13991,8 @@
                 <a:ea typeface="Consolas" pitchFamily="34" charset="-122"/>
                 <a:cs typeface="Consolas" pitchFamily="34" charset="-120"/>
               </a:rPr>
-              <a:t>py code\chat.py --provider ollama "Explain what an API is in one sentence."</a:t>
+              <a:t>py code\chat.py --provider ollama "Explain what an API is in one sentence."
+</a:t>
             </a:r>
             <a:endParaRPr lang="en-US" sz="1350" dirty="0"/>
           </a:p>
@@ -12839,7 +14012,8 @@
                 <a:ea typeface="Consolas" pitchFamily="34" charset="-122"/>
                 <a:cs typeface="Consolas" pitchFamily="34" charset="-120"/>
               </a:rPr>
-              <a:t> </a:t>
+              <a:t>
+</a:t>
             </a:r>
             <a:endParaRPr lang="en-US" sz="1350" dirty="0"/>
           </a:p>
@@ -12859,7 +14033,8 @@
                 <a:ea typeface="Consolas" pitchFamily="34" charset="-122"/>
                 <a:cs typeface="Consolas" pitchFamily="34" charset="-120"/>
               </a:rPr>
-              <a:t>An API is a set of rules that lets different programs talk to each other.</a:t>
+              <a:t>An API is a set of rules that lets different programs talk to each other.
+</a:t>
             </a:r>
             <a:endParaRPr lang="en-US" sz="1350" dirty="0"/>
           </a:p>
@@ -12879,7 +14054,8 @@
                 <a:ea typeface="Consolas" pitchFamily="34" charset="-122"/>
                 <a:cs typeface="Consolas" pitchFamily="34" charset="-120"/>
               </a:rPr>
-              <a:t> </a:t>
+              <a:t>
+</a:t>
             </a:r>
             <a:endParaRPr lang="en-US" sz="1350" dirty="0"/>
           </a:p>
@@ -13298,7 +14474,8 @@
                 <a:ea typeface="Consolas" pitchFamily="34" charset="-122"/>
                 <a:cs typeface="Consolas" pitchFamily="34" charset="-120"/>
               </a:rPr>
-              <a:t>ollama pull llama3.2          # about 2 GB, 3 billion parameters</a:t>
+              <a:t>ollama pull llama3.2          # about 2 GB, 3 billion parameters
+</a:t>
             </a:r>
             <a:endParaRPr lang="en-US" sz="1350" dirty="0"/>
           </a:p>
@@ -14252,7 +15429,8 @@
                 <a:ea typeface="Consolas" pitchFamily="34" charset="-122"/>
                 <a:cs typeface="Consolas" pitchFamily="34" charset="-120"/>
               </a:rPr>
-              <a:t>py code\count_tokens.py</a:t>
+              <a:t>py code\count_tokens.py
+</a:t>
             </a:r>
             <a:endParaRPr lang="en-US" sz="1350" dirty="0"/>
           </a:p>
@@ -14272,7 +15450,8 @@
                 <a:ea typeface="Consolas" pitchFamily="34" charset="-122"/>
                 <a:cs typeface="Consolas" pitchFamily="34" charset="-120"/>
               </a:rPr>
-              <a:t> </a:t>
+              <a:t>
+</a:t>
             </a:r>
             <a:endParaRPr lang="en-US" sz="1350" dirty="0"/>
           </a:p>
@@ -14292,7 +15471,8 @@
                 <a:ea typeface="Consolas" pitchFamily="34" charset="-122"/>
                 <a:cs typeface="Consolas" pitchFamily="34" charset="-120"/>
               </a:rPr>
-              <a:t>Ticket T-1001: 217 characters, 40 words, 47 tokens</a:t>
+              <a:t>Ticket T-1001: 217 characters, 40 words, 47 tokens
+</a:t>
             </a:r>
             <a:endParaRPr lang="en-US" sz="1350" dirty="0"/>
           </a:p>
@@ -14312,7 +15492,8 @@
                 <a:ea typeface="Consolas" pitchFamily="34" charset="-122"/>
                 <a:cs typeface="Consolas" pitchFamily="34" charset="-120"/>
               </a:rPr>
-              <a:t> </a:t>
+              <a:t>
+</a:t>
             </a:r>
             <a:endParaRPr lang="en-US" sz="1350" dirty="0"/>
           </a:p>
@@ -14332,7 +15513,8 @@
                 <a:ea typeface="Consolas" pitchFamily="34" charset="-122"/>
                 <a:cs typeface="Consolas" pitchFamily="34" charset="-120"/>
               </a:rPr>
-              <a:t>'I' | ' ordered' | ' the' | ' wireless' | ' headphones' | ' two' | ' weeks' |</a:t>
+              <a:t>'I' | ' ordered' | ' the' | ' wireless' | ' headphones' | ' two' | ' weeks' |
+</a:t>
             </a:r>
             <a:endParaRPr lang="en-US" sz="1350" dirty="0"/>
           </a:p>
@@ -14510,7 +15692,7 @@
                 <a:ea typeface="Segoe UI" pitchFamily="34" charset="-122"/>
                 <a:cs typeface="Segoe UI" pitchFamily="34" charset="-120"/>
               </a:rPr>
-              <a:t> is a chunk of text: often a short word, sometimes part of a word or a number. English is about 3 tokens per 4 words.</a:t>
+              <a:t> is a chunk of text: often a short word, sometimes part of a word or a number. English is about 4 tokens per 3 words.</a:t>
             </a:r>
             <a:endParaRPr lang="en-US" sz="1720" dirty="0"/>
           </a:p>
@@ -17127,7 +18309,7 @@
                 <a:ea typeface="Segoe UI" pitchFamily="34" charset="-122"/>
                 <a:cs typeface="Segoe UI" pitchFamily="34" charset="-120"/>
               </a:rPr>
-              <a:t>16×</a:t>
+              <a:t>17×</a:t>
             </a:r>
             <a:pPr indent="0" marL="0">
               <a:buNone/>
@@ -17569,7 +18751,7 @@
                 <a:ea typeface="Segoe UI" pitchFamily="34" charset="-122"/>
                 <a:cs typeface="Segoe UI" pitchFamily="34" charset="-120"/>
               </a:rPr>
-              <a:t>two</a:t>
+              <a:t>three</a:t>
             </a:r>
             <a:pPr indent="0" marL="0">
               <a:buNone/>
@@ -17931,7 +19113,8 @@
                 <a:ea typeface="Consolas" pitchFamily="34" charset="-122"/>
                 <a:cs typeface="Consolas" pitchFamily="34" charset="-120"/>
               </a:rPr>
-              <a:t>py code\taste_of_resolvo.py --provider gemini</a:t>
+              <a:t>py code\taste_of_resolvo.py --provider gemini
+</a:t>
             </a:r>
             <a:endParaRPr lang="en-US" sz="1350" dirty="0"/>
           </a:p>
@@ -17951,7 +19134,8 @@
                 <a:ea typeface="Consolas" pitchFamily="34" charset="-122"/>
                 <a:cs typeface="Consolas" pitchFamily="34" charset="-120"/>
               </a:rPr>
-              <a:t> </a:t>
+              <a:t>
+</a:t>
             </a:r>
             <a:endParaRPr lang="en-US" sz="1350" dirty="0"/>
           </a:p>
@@ -17971,7 +19155,8 @@
                 <a:ea typeface="Consolas" pitchFamily="34" charset="-122"/>
                 <a:cs typeface="Consolas" pitchFamily="34" charset="-120"/>
               </a:rPr>
-              <a:t>--- T-1002: Hi, checking on order O-58204 (SoundBar Mini). It says shipped...</a:t>
+              <a:t>--- T-1002: Hi, checking on order O-58204 (SoundBar Mini). It says shipped...
+</a:t>
             </a:r>
             <a:endParaRPr lang="en-US" sz="1350" dirty="0"/>
           </a:p>
@@ -20701,7 +21886,7 @@
                 <a:ea typeface="Segoe UI" pitchFamily="34" charset="-122"/>
                 <a:cs typeface="Segoe UI" pitchFamily="34" charset="-120"/>
               </a:rPr>
-              <a:t>What you'll build in four weeks</a:t>
+              <a:t>What the four weeks look like</a:t>
             </a:r>
             <a:endParaRPr lang="en-US" sz="3000" dirty="0"/>
           </a:p>
@@ -20716,7 +21901,7 @@
         <p:spPr>
           <a:xfrm>
             <a:off x="777240" y="1577340"/>
-            <a:ext cx="10637215" cy="1990344"/>
+            <a:ext cx="10637215" cy="2755392"/>
           </a:xfrm>
           <a:prstGeom prst="rect">
             <a:avLst/>
@@ -20793,7 +21978,7 @@
                 <a:ea typeface="Segoe UI" pitchFamily="34" charset="-122"/>
                 <a:cs typeface="Segoe UI" pitchFamily="34" charset="-120"/>
               </a:rPr>
-              <a:t> reads each ticket, works out what the customer needs, checks the order and the store's policies, and drafts the fix.</a:t>
+              <a:t> reads each ticket, checks the order and the store's policies, and drafts the fix.</a:t>
             </a:r>
             <a:endParaRPr lang="en-US" sz="2000" dirty="0"/>
           </a:p>
@@ -20814,10 +21999,31 @@
                 <a:ea typeface="Segoe UI" pitchFamily="34" charset="-122"/>
                 <a:cs typeface="Segoe UI" pitchFamily="34" charset="-120"/>
               </a:rPr>
-              <a:t>The first version, which you inherit on Monday, is broken in 10 ways. You fix one at a time.</a:t>
+              <a:t>The first version is broken in 10 ways. Each session fixes one or two, live on the screen.</a:t>
             </a:r>
             <a:endParaRPr lang="en-US" sz="2000" dirty="0"/>
           </a:p>
+          <a:p>
+            <a:pPr marL="279400" indent="-279400">
+              <a:spcAft>
+                <a:spcPts val="500"/>
+              </a:spcAft>
+              <a:buSzPct val="100000"/>
+              <a:buChar char="•"/>
+            </a:pPr>
+            <a:r>
+              <a:rPr lang="en-US" sz="2000" dirty="0">
+                <a:solidFill>
+                  <a:srgbClr val="EEF6F3"/>
+                </a:solidFill>
+                <a:latin typeface="Segoe UI" pitchFamily="34" charset="0"/>
+                <a:ea typeface="Segoe UI" pitchFamily="34" charset="-122"/>
+                <a:cs typeface="Segoe UI" pitchFamily="34" charset="-120"/>
+              </a:rPr>
+              <a:t>No coding in class: you predict and vote before every run. Each evening you run the same thing yourself.</a:t>
+            </a:r>
+            <a:endParaRPr lang="en-US" sz="2000" dirty="0"/>
+          </a:p>
         </p:txBody>
       </p:sp>
       <p:sp>
@@ -20828,7 +22034,7 @@
         </p:nvSpPr>
         <p:spPr>
           <a:xfrm>
-            <a:off x="777240" y="3695700"/>
+            <a:off x="777240" y="4460748"/>
             <a:ext cx="10637215" cy="1169822"/>
           </a:xfrm>
           <a:prstGeom prst="roundRect">
@@ -20855,7 +22061,7 @@
         </p:nvSpPr>
         <p:spPr>
           <a:xfrm>
-            <a:off x="777240" y="3695700"/>
+            <a:off x="777240" y="4460748"/>
             <a:ext cx="82296" cy="1169822"/>
           </a:xfrm>
           <a:prstGeom prst="rect">
@@ -20880,7 +22086,7 @@
         </p:nvSpPr>
         <p:spPr>
           <a:xfrm>
-            <a:off x="1051560" y="3805428"/>
+            <a:off x="1051560" y="4570476"/>
             <a:ext cx="10225735" cy="237744"/>
           </a:xfrm>
           <a:prstGeom prst="rect">
@@ -20919,7 +22125,7 @@
         </p:nvSpPr>
         <p:spPr>
           <a:xfrm>
-            <a:off x="1051560" y="4043172"/>
+            <a:off x="1051560" y="4808220"/>
             <a:ext cx="10225735" cy="657758"/>
           </a:xfrm>
           <a:prstGeom prst="rect">
@@ -21248,7 +22454,8 @@
                 <a:ea typeface="Consolas" pitchFamily="34" charset="-122"/>
                 <a:cs typeface="Consolas" pitchFamily="34" charset="-120"/>
               </a:rPr>
-              <a:t># from the folder that holds prep-kit</a:t>
+              <a:t># from the folder that holds prep-kit
+</a:t>
             </a:r>
             <a:endParaRPr lang="en-US" sz="1350" dirty="0"/>
           </a:p>
@@ -21268,7 +22475,8 @@
                 <a:ea typeface="Consolas" pitchFamily="34" charset="-122"/>
                 <a:cs typeface="Consolas" pitchFamily="34" charset="-120"/>
               </a:rPr>
-              <a:t>git clone https://github.com/hasankanaan26/resolvo-workshop.git</a:t>
+              <a:t>git clone https://github.com/hasankanaan26/resolvo-workshop.git
+</a:t>
             </a:r>
             <a:endParaRPr lang="en-US" sz="1350" dirty="0"/>
           </a:p>
@@ -21288,7 +22496,8 @@
                 <a:ea typeface="Consolas" pitchFamily="34" charset="-122"/>
                 <a:cs typeface="Consolas" pitchFamily="34" charset="-120"/>
               </a:rPr>
-              <a:t>cd resolvo-workshop</a:t>
+              <a:t>cd resolvo-workshop
+</a:t>
             </a:r>
             <a:endParaRPr lang="en-US" sz="1350" dirty="0"/>
           </a:p>
@@ -21308,7 +22517,8 @@
                 <a:ea typeface="Consolas" pitchFamily="34" charset="-122"/>
                 <a:cs typeface="Consolas" pitchFamily="34" charset="-120"/>
               </a:rPr>
-              <a:t>deactivate; py -3.12 -m venv .venv; .venv\Scripts\activate   # the course's own venv</a:t>
+              <a:t>deactivate; py -3.12 -m venv .venv; .venv\Scripts\activate   # the course's own venv
+</a:t>
             </a:r>
             <a:endParaRPr lang="en-US" sz="1350" dirty="0"/>
           </a:p>
@@ -21328,7 +22538,8 @@
                 <a:ea typeface="Consolas" pitchFamily="34" charset="-122"/>
                 <a:cs typeface="Consolas" pitchFamily="34" charset="-120"/>
               </a:rPr>
-              <a:t>pip install -r requirements.txt     # the full course list: 10 to 20 minutes</a:t>
+              <a:t>pip install -r requirements.txt     # the full course list: 10 to 20 minutes
+</a:t>
             </a:r>
             <a:endParaRPr lang="en-US" sz="1350" dirty="0"/>
           </a:p>
@@ -21348,7 +22559,8 @@
                 <a:ea typeface="Consolas" pitchFamily="34" charset="-122"/>
                 <a:cs typeface="Consolas" pitchFamily="34" charset="-120"/>
               </a:rPr>
-              <a:t>copy .env.example .env              # then set LLM_PROVIDER=openai and OPENAI_API_KEY=</a:t>
+              <a:t>copy .env.example .env              # then set LLM_PROVIDER=openai and OPENAI_API_KEY=
+</a:t>
             </a:r>
             <a:endParaRPr lang="en-US" sz="1350" dirty="0"/>
           </a:p>
@@ -21368,7 +22580,8 @@
                 <a:ea typeface="Consolas" pitchFamily="34" charset="-122"/>
                 <a:cs typeface="Consolas" pitchFamily="34" charset="-120"/>
               </a:rPr>
-              <a:t>python ..\prep-kit\code\check_setup.py --live</a:t>
+              <a:t>python ..\prep-kit\code\check_setup.py --live
+</a:t>
             </a:r>
             <a:endParaRPr lang="en-US" sz="1350" dirty="0"/>
           </a:p>
@@ -21388,7 +22601,8 @@
                 <a:ea typeface="Consolas" pitchFamily="34" charset="-122"/>
                 <a:cs typeface="Consolas" pitchFamily="34" charset="-120"/>
               </a:rPr>
-              <a:t> </a:t>
+              <a:t>
+</a:t>
             </a:r>
             <a:endParaRPr lang="en-US" sz="1350" dirty="0"/>
           </a:p>
@@ -21408,7 +22622,8 @@
                 <a:ea typeface="Consolas" pitchFamily="34" charset="-122"/>
                 <a:cs typeface="Consolas" pitchFamily="34" charset="-120"/>
               </a:rPr>
-              <a:t>[ ok ] Course repo found: C:\...\resolvo-workshop</a:t>
+              <a:t>[ ok ] Course repo found: C:\...\resolvo-workshop
+</a:t>
             </a:r>
             <a:endParaRPr lang="en-US" sz="1350" dirty="0"/>
           </a:p>
@@ -21428,7 +22643,8 @@
                 <a:ea typeface="Consolas" pitchFamily="34" charset="-122"/>
                 <a:cs typeface="Consolas" pitchFamily="34" charset="-120"/>
               </a:rPr>
-              <a:t>[ ok ] The course's virtual environment is active</a:t>
+              <a:t>[ ok ] The course's virtual environment is active
+</a:t>
             </a:r>
             <a:endParaRPr lang="en-US" sz="1350" dirty="0"/>
           </a:p>
@@ -21448,7 +22664,8 @@
                 <a:ea typeface="Consolas" pitchFamily="34" charset="-122"/>
                 <a:cs typeface="Consolas" pitchFamily="34" charset="-120"/>
               </a:rPr>
-              <a:t>[ ok ] Course provider: openai (key filled in)</a:t>
+              <a:t>[ ok ] Course provider: openai (key filled in)
+</a:t>
             </a:r>
             <a:endParaRPr lang="en-US" sz="1350" dirty="0"/>
           </a:p>
@@ -21468,7 +22685,8 @@
                 <a:ea typeface="Consolas" pitchFamily="34" charset="-122"/>
                 <a:cs typeface="Consolas" pitchFamily="34" charset="-120"/>
               </a:rPr>
-              <a:t>[ ok ] Live call to openai (gpt-4o-mini) answered: 'ready'</a:t>
+              <a:t>[ ok ] Live call to openai (gpt-4o-mini) answered: 'ready'
+</a:t>
             </a:r>
             <a:endParaRPr lang="en-US" sz="1350" dirty="0"/>
           </a:p>
@@ -21488,7 +22706,8 @@
                 <a:ea typeface="Consolas" pitchFamily="34" charset="-122"/>
                 <a:cs typeface="Consolas" pitchFamily="34" charset="-120"/>
               </a:rPr>
-              <a:t> </a:t>
+              <a:t>
+</a:t>
             </a:r>
             <a:endParaRPr lang="en-US" sz="1350" dirty="0"/>
           </a:p>
@@ -22485,7 +23704,7 @@
                 <a:ea typeface="Segoe UI" pitchFamily="34" charset="-122"/>
                 <a:cs typeface="Segoe UI" pitchFamily="34" charset="-120"/>
               </a:rPr>
-              <a:t>Session 1: What Changed, and What Didn't. Bring the laptop that passed the check.</a:t>
+              <a:t>Session 1: What Changed, and What Didn't. The laptop that passed the check is for the evenings.</a:t>
             </a:r>
             <a:endParaRPr lang="en-US" sz="2200" dirty="0"/>
           </a:p>
@@ -26912,7 +28131,8 @@
                 <a:ea typeface="Consolas" pitchFamily="34" charset="-122"/>
                 <a:cs typeface="Consolas" pitchFamily="34" charset="-120"/>
               </a:rPr>
-              <a:t># from prep-kit/</a:t>
+              <a:t># from prep-kit/
+</a:t>
             </a:r>
             <a:endParaRPr lang="en-US" sz="1350" dirty="0"/>
           </a:p>
@@ -26932,7 +28152,8 @@
                 <a:ea typeface="Consolas" pitchFamily="34" charset="-122"/>
                 <a:cs typeface="Consolas" pitchFamily="34" charset="-120"/>
               </a:rPr>
-              <a:t>py -3.12 -m venv .venv</a:t>
+              <a:t>py -3.12 -m venv .venv
+</a:t>
             </a:r>
             <a:endParaRPr lang="en-US" sz="1350" dirty="0"/>
           </a:p>
@@ -26952,7 +28173,8 @@
                 <a:ea typeface="Consolas" pitchFamily="34" charset="-122"/>
                 <a:cs typeface="Consolas" pitchFamily="34" charset="-120"/>
               </a:rPr>
-              <a:t>.venv\Scripts\activate</a:t>
+              <a:t>.venv\Scripts\activate
+</a:t>
             </a:r>
             <a:endParaRPr lang="en-US" sz="1350" dirty="0"/>
           </a:p>
@@ -27080,7 +28302,8 @@
                 <a:ea typeface="Consolas" pitchFamily="34" charset="-122"/>
                 <a:cs typeface="Consolas" pitchFamily="34" charset="-120"/>
               </a:rPr>
-              <a:t># from prep-kit/</a:t>
+              <a:t># from prep-kit/
+</a:t>
             </a:r>
             <a:endParaRPr lang="en-US" sz="1350" dirty="0"/>
           </a:p>
@@ -27100,7 +28323,8 @@
                 <a:ea typeface="Consolas" pitchFamily="34" charset="-122"/>
                 <a:cs typeface="Consolas" pitchFamily="34" charset="-120"/>
               </a:rPr>
-              <a:t>python3.12 -m venv .venv</a:t>
+              <a:t>python3.12 -m venv .venv
+</a:t>
             </a:r>
             <a:endParaRPr lang="en-US" sz="1350" dirty="0"/>
           </a:p>
@@ -27120,7 +28344,8 @@
                 <a:ea typeface="Consolas" pitchFamily="34" charset="-122"/>
                 <a:cs typeface="Consolas" pitchFamily="34" charset="-120"/>
               </a:rPr>
-              <a:t>source .venv/bin/activate</a:t>
+              <a:t>source .venv/bin/activate
+</a:t>
             </a:r>
             <a:endParaRPr lang="en-US" sz="1350" dirty="0"/>
           </a:p>
@@ -27723,7 +28948,8 @@
                 <a:ea typeface="Consolas" pitchFamily="34" charset="-122"/>
                 <a:cs typeface="Consolas" pitchFamily="34" charset="-120"/>
               </a:rPr>
-              <a:t>py code\where_am_i.py</a:t>
+              <a:t>py code\where_am_i.py
+</a:t>
             </a:r>
             <a:endParaRPr lang="en-US" sz="1350" dirty="0"/>
           </a:p>
@@ -27743,7 +28969,8 @@
                 <a:ea typeface="Consolas" pitchFamily="34" charset="-122"/>
                 <a:cs typeface="Consolas" pitchFamily="34" charset="-120"/>
               </a:rPr>
-              <a:t> </a:t>
+              <a:t>
+</a:t>
             </a:r>
             <a:endParaRPr lang="en-US" sz="1350" dirty="0"/>
           </a:p>
@@ -27763,7 +28990,8 @@
                 <a:ea typeface="Consolas" pitchFamily="34" charset="-122"/>
                 <a:cs typeface="Consolas" pitchFamily="34" charset="-120"/>
               </a:rPr>
-              <a:t>Python version : 3.12.7</a:t>
+              <a:t>Python version : 3.12.7
+</a:t>
             </a:r>
             <a:endParaRPr lang="en-US" sz="1350" dirty="0"/>
           </a:p>
@@ -27783,7 +29011,8 @@
                 <a:ea typeface="Consolas" pitchFamily="34" charset="-122"/>
                 <a:cs typeface="Consolas" pitchFamily="34" charset="-120"/>
               </a:rPr>
-              <a:t>Running from   : C:\...\prep-kit\.venv\Scripts\python.exe</a:t>
+              <a:t>Running from   : C:\...\prep-kit\.venv\Scripts\python.exe
+</a:t>
             </a:r>
             <a:endParaRPr lang="en-US" sz="1350" dirty="0"/>
           </a:p>
@@ -27803,7 +29032,8 @@
                 <a:ea typeface="Consolas" pitchFamily="34" charset="-122"/>
                 <a:cs typeface="Consolas" pitchFamily="34" charset="-120"/>
               </a:rPr>
-              <a:t>Virtual env    : YES  (C:\...\prep-kit\.venv)</a:t>
+              <a:t>Virtual env    : YES  (C:\...\prep-kit\.venv)
+</a:t>
             </a:r>
             <a:endParaRPr lang="en-US" sz="1350" dirty="0"/>
           </a:p>
@@ -27823,7 +29053,8 @@
                 <a:ea typeface="Consolas" pitchFamily="34" charset="-122"/>
                 <a:cs typeface="Consolas" pitchFamily="34" charset="-120"/>
               </a:rPr>
-              <a:t> </a:t>
+              <a:t>
+</a:t>
             </a:r>
             <a:endParaRPr lang="en-US" sz="1350" dirty="0"/>
           </a:p>
@@ -27843,7 +29074,8 @@
                 <a:ea typeface="Consolas" pitchFamily="34" charset="-122"/>
                 <a:cs typeface="Consolas" pitchFamily="34" charset="-120"/>
               </a:rPr>
-              <a:t>Packages the prep kit needs:</a:t>
+              <a:t>Packages the prep kit needs:
+</a:t>
             </a:r>
             <a:endParaRPr lang="en-US" sz="1350" dirty="0"/>
           </a:p>
@@ -27863,7 +29095,8 @@
                 <a:ea typeface="Consolas" pitchFamily="34" charset="-122"/>
                 <a:cs typeface="Consolas" pitchFamily="34" charset="-120"/>
               </a:rPr>
-              <a:t>  ok       openai</a:t>
+              <a:t>  ok       openai
+</a:t>
             </a:r>
             <a:endParaRPr lang="en-US" sz="1350" dirty="0"/>
           </a:p>
@@ -27883,7 +29116,8 @@
                 <a:ea typeface="Consolas" pitchFamily="34" charset="-122"/>
                 <a:cs typeface="Consolas" pitchFamily="34" charset="-120"/>
               </a:rPr>
-              <a:t>  ok       httpx</a:t>
+              <a:t>  ok       httpx
+</a:t>
             </a:r>
             <a:endParaRPr lang="en-US" sz="1350" dirty="0"/>
           </a:p>
@@ -27903,7 +29137,8 @@
                 <a:ea typeface="Consolas" pitchFamily="34" charset="-122"/>
                 <a:cs typeface="Consolas" pitchFamily="34" charset="-120"/>
               </a:rPr>
-              <a:t>  ok       dotenv</a:t>
+              <a:t>  ok       dotenv
+</a:t>
             </a:r>
             <a:endParaRPr lang="en-US" sz="1350" dirty="0"/>
           </a:p>

</xml_diff>

<commit_message>
Sync the mock API and session-00 deck with the workshop; clearer steps 07 and 08
mock_api/app.py, slides/deck.css, deck.js, session-00.html and
session-00.pptx are byte copies of the workshop originals again.
Steps 07 and 08 describe the walkthrough format: watch in class,
repeat it that evening with your own assistant.

Co-Authored-By: Claude Opus 5.5 <noreply@anthropic.com>
</commit_message>
<xml_diff>
--- a/slides/session-00.pptx
+++ b/slides/session-00.pptx
@@ -532,162 +532,15 @@
           <a:lstStyle/>
           <a:p>
             <a:r>
-              <a:rPr lang="en-US" b="1" dirty="0"/>
-              <a:t>POINT:</a:t>
-            </a:r>
-            <a:r>
               <a:rPr lang="en-US" dirty="0"/>
-              <a:t> Today is optional and nothing is graded. The goal: on Monday, nothing on the screen is completely new.</a:t>
+              <a:t>Welcome. Today is optional and nothing is graded. The whole goal is simple: on Monday, nothing on the screen should be completely new to you. Nobody needs to master any of this before then. We'll walk through the kit together and get as many laptops working as we can.</a:t>
             </a:r>
             <a:endParaRPr lang="en-US" dirty="0"/>
           </a:p>
           <a:p>
             <a:r>
-              <a:rPr lang="en-US" b="1" dirty="0"/>
-              <a:t>SAY:</a:t>
-            </a:r>
-            <a:r>
-              <a:rPr lang="en-US" dirty="0"/>
-              <a:t> "Nobody needs to master this before Monday. We'll walk through the kit and get as many laptops working as we can."</a:t>
-            </a:r>
-            <a:endParaRPr lang="en-US" dirty="0"/>
-          </a:p>
-          <a:p>
-            <a:r>
-              <a:rPr lang="en-US" b="1" dirty="0"/>
-              <a:t>IF ASKED:</a:t>
-            </a:r>
-            <a:r>
-              <a:rPr lang="en-US" dirty="0"/>
-              <a:t> The kit is a folder called prep-kit: eight short steps, three to four hours alone.</a:t>
-            </a:r>
-            <a:endParaRPr lang="en-US" dirty="0"/>
-          </a:p>
-          <a:p>
-            <a:endParaRPr lang="en-US" dirty="0"/>
-          </a:p>
-          <a:p>
-            <a:r>
-              <a:rPr lang="en-US" dirty="0"/>
-              <a:t>──── INSTRUCTOR GUIDE ────</a:t>
-            </a:r>
-            <a:endParaRPr lang="en-US" dirty="0"/>
-          </a:p>
-          <a:p>
-            <a:r>
-              <a:rPr lang="en-US" dirty="0"/>
-              <a:t>TIMING (75 MINUTES)</a:t>
-            </a:r>
-            <a:endParaRPr lang="en-US" dirty="0"/>
-          </a:p>
-          <a:p>
-            <a:r>
-              <a:rPr lang="en-US" dirty="0"/>
-              <a:t>Block — Slides — Minutes — If you're running late</a:t>
-            </a:r>
-            <a:endParaRPr lang="en-US" dirty="0"/>
-          </a:p>
-          <a:p>
-            <a:r>
-              <a:rPr lang="en-US" dirty="0"/>
-              <a:t>Welcome and the route — 1–4 — 8 — Skip slide 3; Session 1 tells the story anyway</a:t>
-            </a:r>
-            <a:endParaRPr lang="en-US" dirty="0"/>
-          </a:p>
-          <a:p>
-            <a:r>
-              <a:rPr lang="en-US" dirty="0"/>
-              <a:t>Terminal and venv — 5–8 — 12 — Show slide 6, then point at the step 01 page</a:t>
-            </a:r>
-            <a:endParaRPr lang="en-US" dirty="0"/>
-          </a:p>
-          <a:p>
-            <a:r>
-              <a:rPr lang="en-US" dirty="0"/>
-              <a:t>APIs — 9–13 — 13 — Demo the /docs page only, skip hello_api.py</a:t>
-            </a:r>
-            <a:endParaRPr lang="en-US" dirty="0"/>
-          </a:p>
-          <a:p>
-            <a:r>
-              <a:rPr lang="en-US" dirty="0"/>
-              <a:t>Secrets — 14–15 — 5 — Read the four habits, move on</a:t>
-            </a:r>
-            <a:endParaRPr lang="en-US" dirty="0"/>
-          </a:p>
-          <a:p>
-            <a:r>
-              <a:rPr lang="en-US" dirty="0"/>
-              <a:t>Where LLMs came from, LLM calls, three providers — 16–22 — 17 — Skip 16 (it's in the extra reading); one live call, not three</a:t>
-            </a:r>
-            <a:endParaRPr lang="en-US" dirty="0"/>
-          </a:p>
-          <a:p>
-            <a:r>
-              <a:rPr lang="en-US" dirty="0"/>
-              <a:t>Tokens, cost, taste of Resolvo — 23–28 — 10 — Keep 28 (two kinds of wrong); skip 24 and 25</a:t>
-            </a:r>
-            <a:endParaRPr lang="en-US" dirty="0"/>
-          </a:p>
-          <a:p>
-            <a:r>
-              <a:rPr lang="en-US" dirty="0"/>
-              <a:t>Course key and setup check — 29–32 — 10 — Never cut this block</a:t>
-            </a:r>
-            <a:endParaRPr lang="en-US" dirty="0"/>
-          </a:p>
-          <a:p>
-            <a:endParaRPr lang="en-US" dirty="0"/>
-          </a:p>
-          <a:p>
-            <a:r>
-              <a:rPr lang="en-US" dirty="0"/>
-              <a:t>Leave the call open for 15 minutes afterwards for anyone whose setup check fails.</a:t>
-            </a:r>
-            <a:endParaRPr lang="en-US" dirty="0"/>
-          </a:p>
-          <a:p>
-            <a:endParaRPr lang="en-US" dirty="0"/>
-          </a:p>
-          <a:p>
-            <a:r>
-              <a:rPr lang="en-US" dirty="0"/>
-              <a:t>──── INSTRUCTOR GUIDE ────</a:t>
-            </a:r>
-            <a:endParaRPr lang="en-US" dirty="0"/>
-          </a:p>
-          <a:p>
-            <a:r>
-              <a:rPr lang="en-US" dirty="0"/>
-              <a:t>BEFORE THE CALL</a:t>
-            </a:r>
-            <a:endParaRPr lang="en-US" dirty="0"/>
-          </a:p>
-          <a:p>
-            <a:r>
-              <a:rPr lang="en-US" dirty="0"/>
-              <a:t>• [ ] Run every command in the deck once on your own machine, today. Model names on free tiers change, and a retired model gives a 404.</a:t>
-            </a:r>
-            <a:endParaRPr lang="en-US" dirty="0"/>
-          </a:p>
-          <a:p>
-            <a:r>
-              <a:rPr lang="en-US" dirty="0"/>
-              <a:t>• [ ] Have Ollama running with llama3.2 pulled, so you have one demo that needs no network and no key.</a:t>
-            </a:r>
-            <a:endParaRPr lang="en-US" dirty="0"/>
-          </a:p>
-          <a:p>
-            <a:r>
-              <a:rPr lang="en-US" dirty="0"/>
-              <a:t>• [ ] Start the mock order API in a terminal you can share.</a:t>
-            </a:r>
-            <a:endParaRPr lang="en-US" dirty="0"/>
-          </a:p>
-          <a:p>
-            <a:r>
-              <a:rPr lang="en-US" dirty="0"/>
-              <a:t>• [ ] Have &lt;https://github.com/hasankanaan26/prep-kit&gt; ready to paste into the chat.</a:t>
+              <a:rPr lang="en-US" i="1" dirty="0"/>
+              <a:t>[If asked: the kit is a folder called prep-kit: eight short steps, three to four hours alone.]</a:t>
             </a:r>
             <a:endParaRPr lang="en-US" dirty="0"/>
           </a:p>
@@ -774,34 +627,22 @@
           <a:lstStyle/>
           <a:p>
             <a:r>
-              <a:rPr lang="en-US" b="1" dirty="0"/>
-              <a:t>POINT:</a:t>
-            </a:r>
-            <a:r>
               <a:rPr lang="en-US" dirty="0"/>
-              <a:t> Good code reads the status code and decides what to do.</a:t>
+              <a:t>Four status codes, and you'll see all four this month. 200 means here's what you asked for. 404 means I understood you, but that thing doesn't exist. That's not a crash: the server answered perfectly well, it's telling you something. 429 means slow down, and you'll meet it on the free LLM tiers; the right move is to wait, not to hammer it. 500 means the other side broke, not you.</a:t>
             </a:r>
             <a:endParaRPr lang="en-US" dirty="0"/>
           </a:p>
           <a:p>
             <a:r>
-              <a:rPr lang="en-US" b="1" dirty="0"/>
-              <a:t>SAY:</a:t>
-            </a:r>
-            <a:r>
               <a:rPr lang="en-US" dirty="0"/>
-              <a:t> "429 on a free tier means wait, don't hammer it. 500 means the other side broke. Real APIs do, and the course makes them fail on purpose so you can practise."</a:t>
+              <a:t>Real APIs do break, and the course makes its APIs fail on purpose so you get to practise handling it. Good code reads the status and decides what to do.</a:t>
             </a:r>
             <a:endParaRPr lang="en-US" dirty="0"/>
           </a:p>
           <a:p>
             <a:r>
-              <a:rPr lang="en-US" b="1" dirty="0"/>
-              <a:t>IF ASKED:</a:t>
-            </a:r>
-            <a:r>
-              <a:rPr lang="en-US" dirty="0"/>
-              <a:t> The mock API fails on demand: an X-Chaos header for one request, or MOCK_CHAOS for all. Session 5 uses MOCK_CHAOS.</a:t>
+              <a:rPr lang="en-US" i="1" dirty="0"/>
+              <a:t>[If asked: the mock API fails on demand: an X-Chaos header for one request, or MOCK_CHAOS for all. Session 5 uses MOCK_CHAOS.]</a:t>
             </a:r>
             <a:endParaRPr lang="en-US" dirty="0"/>
           </a:p>
@@ -888,58 +729,22 @@
           <a:lstStyle/>
           <a:p>
             <a:r>
-              <a:rPr lang="en-US" b="1" dirty="0"/>
-              <a:t>POINT:</a:t>
-            </a:r>
-            <a:r>
               <a:rPr lang="en-US" dirty="0"/>
-              <a:t> They make real API calls to a small fake Nimbus order system, which the course uses every week.</a:t>
+              <a:t>Now a real API, running on your laptop. The first command starts a small fake Nimbus order system, the same one the course uses every week. Leave it running. Open localhost:9000/docs in a browser and you get every endpoint with a "Try it out" button. That's the gentlest first API call there is, and the response panel shows the status code and the JSON together.</a:t>
             </a:r>
             <a:endParaRPr lang="en-US" dirty="0"/>
           </a:p>
           <a:p>
             <a:r>
-              <a:rPr lang="en-US" b="1" dirty="0"/>
-              <a:t>DO:</a:t>
-            </a:r>
-            <a:r>
               <a:rPr lang="en-US" dirty="0"/>
-              <a:t> On /docs: GET /orders/{order_id}, Try it out, O-48291, Execute. Then run hello_api.py and read the output aloud.</a:t>
+              <a:t>Then run hello_api.py from a second terminal. It sends five requests: an order, a missing order, a refund, the same refund again, and a forced failure. Quick question before I explain: is the 404 a bug? [Answer: no. The server answered: that order doesn't exist.]</a:t>
             </a:r>
             <a:endParaRPr lang="en-US" dirty="0"/>
           </a:p>
           <a:p>
             <a:r>
-              <a:rPr lang="en-US" b="1" dirty="0"/>
-              <a:t>ASK:</a:t>
-            </a:r>
-            <a:r>
-              <a:rPr lang="en-US" dirty="0"/>
-              <a:t> "Is the 404 a bug?" Answer: No. The server answered: that order doesn't exist.</a:t>
-            </a:r>
-            <a:endParaRPr lang="en-US" dirty="0"/>
-          </a:p>
-          <a:p>
-            <a:endParaRPr lang="en-US" dirty="0"/>
-          </a:p>
-          <a:p>
-            <a:r>
-              <a:rPr lang="en-US" dirty="0"/>
-              <a:t>──── INSTRUCTOR GUIDE ────</a:t>
-            </a:r>
-            <a:endParaRPr lang="en-US" dirty="0"/>
-          </a:p>
-          <a:p>
-            <a:r>
-              <a:rPr lang="en-US" dirty="0"/>
-              <a:t>A REAL API, RUNNING ON YOUR LAPTOP</a:t>
-            </a:r>
-            <a:endParaRPr lang="en-US" dirty="0"/>
-          </a:p>
-          <a:p>
-            <a:r>
-              <a:rPr lang="en-US" dirty="0"/>
-              <a:t>Open http://localhost:9000/docs first. Clicking "Try it out" on GET /orders/{order_id} is the gentlest possible first API call, and the response panel shows the status code and the JSON together. Then run hello_api.py and read the five blocks aloud. Ask "is the 404 a bug?" before you explain it.</a:t>
+              <a:rPr lang="en-US" i="1" dirty="0"/>
+              <a:t>[Do: on /docs: GET /orders/{order_id}, Try it out, O-48291, Execute. Then run hello_api.py and read the output aloud.]</a:t>
             </a:r>
             <a:endParaRPr lang="en-US" dirty="0"/>
           </a:p>
@@ -1026,34 +831,22 @@
           <a:lstStyle/>
           <a:p>
             <a:r>
-              <a:rPr lang="en-US" b="1" dirty="0"/>
-              <a:t>POINT:</a:t>
-            </a:r>
-            <a:r>
               <a:rPr lang="en-US" dirty="0"/>
-              <a:t> The same Idempotency-Key means the customer is refunded once, however many times you retry.</a:t>
+              <a:t>Look at blocks 3 and 4. Same refund request, sent twice, same refund ID back. Here's why that matters. Your code asks for a refund and the request times out. Did it happen or not? You don't know. So you retry. Without a key, that retry can refund the customer twice. With the same Idempotency-Key, the server recognises the slip and returns the first refund instead of making a new one.</a:t>
             </a:r>
             <a:endParaRPr lang="en-US" dirty="0"/>
           </a:p>
           <a:p>
             <a:r>
-              <a:rPr lang="en-US" b="1" dirty="0"/>
-              <a:t>SAY:</a:t>
-            </a:r>
-            <a:r>
               <a:rPr lang="en-US" dirty="0"/>
-              <a:t> "A refund times out. Did it happen? You don't know, so you retry. Without a key, that can refund twice. With it, the server returns the first refund."</a:t>
+              <a:t>It's like a receipt number on a bank transfer: hand the clerk the same slip twice and you pay once. The caller picks one key, then reuses it on every retry of the same refund. That's idempotency.</a:t>
             </a:r>
             <a:endParaRPr lang="en-US" dirty="0"/>
           </a:p>
           <a:p>
             <a:r>
-              <a:rPr lang="en-US" b="1" dirty="0"/>
-              <a:t>IF ASKED:</a:t>
-            </a:r>
-            <a:r>
-              <a:rPr lang="en-US" dirty="0"/>
-              <a:t> Session 5 builds the real refund tool on this. Don't go deeper today.</a:t>
+              <a:rPr lang="en-US" i="1" dirty="0"/>
+              <a:t>[If asked: Session 5 builds the real refund tool on this. Don't go deeper today.]</a:t>
             </a:r>
             <a:endParaRPr lang="en-US" dirty="0"/>
           </a:p>
@@ -1140,34 +933,15 @@
           <a:lstStyle/>
           <a:p>
             <a:r>
-              <a:rPr lang="en-US" b="1" dirty="0"/>
-              <a:t>ASK:</a:t>
-            </a:r>
-            <a:r>
               <a:rPr lang="en-US" dirty="0"/>
-              <a:t> Question 1. Answer: No. The server answered correctly: that order doesn't exist. A 404 is information, not a failure.</a:t>
+              <a:t>Three quick ones; shout the answers out. First: you ask for order O-00000 and get a 404. What is the 404 telling you? [Answer: that order doesn't exist. The server answered correctly; the API isn't broken.] Second: a refund request times out. Why is it safe to retry with the same Idempotency-Key? [Answer: the server remembers the key. If the first request went through, it returns that refund; if not, the retry does it. Refunded exactly once.] Third: your script prints Virtual env NO. What did you forget? [Answer: activating the venv in this terminal.]</a:t>
             </a:r>
             <a:endParaRPr lang="en-US" dirty="0"/>
           </a:p>
           <a:p>
             <a:r>
-              <a:rPr lang="en-US" b="1" dirty="0"/>
-              <a:t>ASK:</a:t>
-            </a:r>
-            <a:r>
               <a:rPr lang="en-US" dirty="0"/>
-              <a:t> Question 2. Answer: The server remembers the key. If the first request went through, it returns that refund; if not, the retry does it. Refunded exactly once.</a:t>
-            </a:r>
-            <a:endParaRPr lang="en-US" dirty="0"/>
-          </a:p>
-          <a:p>
-            <a:r>
-              <a:rPr lang="en-US" b="1" dirty="0"/>
-              <a:t>ASK:</a:t>
-            </a:r>
-            <a:r>
-              <a:rPr lang="en-US" dirty="0"/>
-              <a:t> Question 3. Answer: Activating the venv in this terminal.</a:t>
+              <a:t>The tempting mistake on the first one is treating anything that isn't 200 as an error. A 404 is information, not a failure: your code should read it and decide. On the third, the giveaway is that it worked a minute ago. A new terminal always starts without the venv.</a:t>
             </a:r>
             <a:endParaRPr lang="en-US" dirty="0"/>
           </a:p>
@@ -1254,34 +1028,22 @@
           <a:lstStyle/>
           <a:p>
             <a:r>
-              <a:rPr lang="en-US" b="1" dirty="0"/>
-              <a:t>POINT:</a:t>
-            </a:r>
-            <a:r>
               <a:rPr lang="en-US" dirty="0"/>
-              <a:t> A key is your username and password in one string, tied to your credit card. It lives in .env, never in code.</a:t>
+              <a:t>Think of an API key: it's your username and password in one string, with your credit card attached. So it never goes in your code. It lives in a file called .env, one line per value, and python-dotenv reads that file when your program starts. Python then sees each line as an environment variable, which is a named value the operating system hands to each program.</a:t>
             </a:r>
             <a:endParaRPr lang="en-US" dirty="0"/>
           </a:p>
           <a:p>
             <a:r>
-              <a:rPr lang="en-US" b="1" dirty="0"/>
-              <a:t>SAY:</a:t>
-            </a:r>
-            <a:r>
               <a:rPr lang="en-US" dirty="0"/>
-              <a:t> "Environment variables are named values the operating system hands to each program."</a:t>
+              <a:t>The other half is .gitignore. It tells Git to never even look at .env, so you can't commit it by accident. The warning at the bottom is not an exaggeration: bots scan public GitHub for leaked keys within minutes.</a:t>
             </a:r>
             <a:endParaRPr lang="en-US" dirty="0"/>
           </a:p>
           <a:p>
             <a:r>
-              <a:rPr lang="en-US" b="1" dirty="0"/>
-              <a:t>DO:</a:t>
-            </a:r>
-            <a:r>
-              <a:rPr lang="en-US" dirty="0"/>
-              <a:t> Show show_env.py: which keys are set and how long, never the value. It flags a trailing space and quote marks.</a:t>
+              <a:rPr lang="en-US" i="1" dirty="0"/>
+              <a:t>[Do: show show_env.py: which keys are set and how long, never the value. It flags a trailing space and quote marks.]</a:t>
             </a:r>
             <a:endParaRPr lang="en-US" dirty="0"/>
           </a:p>
@@ -1368,34 +1130,22 @@
           <a:lstStyle/>
           <a:p>
             <a:r>
-              <a:rPr lang="en-US" b="1" dirty="0"/>
-              <a:t>POINT:</a:t>
-            </a:r>
-            <a:r>
               <a:rPr lang="en-US" dirty="0"/>
-              <a:t> Set a spending limit the day you create a paid key.</a:t>
+              <a:t>Four habits, and the second is the one I'd nag you about. Set a monthly spending limit on the day you create a paid key. A loop with a bug can make thousands of calls while you're at lunch. A limit turns that into an annoyance instead of a bill. The first habit covers chats too: pasting one into an AI assistant counts as pasting it on the internet.</a:t>
             </a:r>
             <a:endParaRPr lang="en-US" dirty="0"/>
           </a:p>
           <a:p>
             <a:r>
-              <a:rPr lang="en-US" b="1" dirty="0"/>
-              <a:t>SAY:</a:t>
-            </a:r>
-            <a:r>
               <a:rPr lang="en-US" dirty="0"/>
-              <a:t> "A loop with a bug can make thousands of calls while you're at lunch. A limit turns that into an annoyance instead of a bill." Leaked keys are common; revoking is fast.</a:t>
+              <a:t>The third: leaked keys are common and revoking is fast, so just revoke and make a new one. The fourth, one key, one project, is what makes revoking painless.</a:t>
             </a:r>
             <a:endParaRPr lang="en-US" dirty="0"/>
           </a:p>
           <a:p>
             <a:r>
-              <a:rPr lang="en-US" b="1" dirty="0"/>
-              <a:t>IF ASKED:</a:t>
-            </a:r>
-            <a:r>
-              <a:rPr lang="en-US" dirty="0"/>
-              <a:t> Two .env files keep practice and course separate.</a:t>
+              <a:rPr lang="en-US" i="1" dirty="0"/>
+              <a:t>[If asked: two .env files keep practice and course separate: prep-kit/.env for free practice keys, deskhand-workshop/.env for the course key.]</a:t>
             </a:r>
             <a:endParaRPr lang="en-US" dirty="0"/>
           </a:p>
@@ -1482,34 +1232,29 @@
           <a:lstStyle/>
           <a:p>
             <a:r>
-              <a:rPr lang="en-US" b="1" dirty="0"/>
-              <a:t>POINT:</a:t>
-            </a:r>
-            <a:r>
               <a:rPr lang="en-US" dirty="0"/>
-              <a:t> Behind the API is a text predictor trained to be helpful. Optional: skip it if short on time and point at prep-kit/extra-how-llms-work.md.</a:t>
+              <a:t>Classic machine learning: a person picks the clues, like how often the word "free" appears, and the computer learns how much each clue counts. Deep learning: give it millions of examples and it finds the clues itself. Transformers, 2017: every word can look at every other word, so a model knows "them" means the headphones. Instruction tuning, around 2022: train it on questions and good answers.</a:t>
             </a:r>
             <a:endParaRPr lang="en-US" dirty="0"/>
           </a:p>
           <a:p>
             <a:r>
-              <a:rPr lang="en-US" b="1" dirty="0"/>
-              <a:t>SAY:</a:t>
-            </a:r>
-            <a:r>
               <a:rPr lang="en-US" dirty="0"/>
-              <a:t> "Ask a raw model 'What is your refund window?' and it may continue 'What is your shipping time?' It thinks it's on an FAQ page. An instruction-tuned model answers."</a:t>
+              <a:t>That last step is the difference between a text predictor and ChatGPT. Ask a raw model for its refund window and it may carry on with the next question, as if it were on an FAQ page. An instruction-tuned model answers.</a:t>
             </a:r>
             <a:endParaRPr lang="en-US" dirty="0"/>
           </a:p>
           <a:p>
             <a:r>
-              <a:rPr lang="en-US" b="1" dirty="0"/>
-              <a:t>IF ASKED:</a:t>
-            </a:r>
-            <a:r>
-              <a:rPr lang="en-US" dirty="0"/>
-              <a:t> ML is machine learning: the computer learns rules from examples.</a:t>
+              <a:rPr lang="en-US" i="1" dirty="0"/>
+              <a:t>[Do: this is extra reading. Short on time? Skip it and point at prep-kit/extra-how-llms-work.md.]</a:t>
+            </a:r>
+            <a:endParaRPr lang="en-US" dirty="0"/>
+          </a:p>
+          <a:p>
+            <a:r>
+              <a:rPr lang="en-US" i="1" dirty="0"/>
+              <a:t>[If asked: an LLM is a large language model. Session 1 starts from this idea, a text predictor trained to be helpful.]</a:t>
             </a:r>
             <a:endParaRPr lang="en-US" dirty="0"/>
           </a:p>
@@ -1596,34 +1341,22 @@
           <a:lstStyle/>
           <a:p>
             <a:r>
-              <a:rPr lang="en-US" b="1" dirty="0"/>
-              <a:t>POINT:</a:t>
-            </a:r>
-            <a:r>
               <a:rPr lang="en-US" dirty="0"/>
-              <a:t> An LLM call is the same POST as step 02: JSON in, JSON out.</a:t>
+              <a:t>Here's the payoff from step 02. A call to a large language model, an LLM, is the same POST: JSON in, JSON out. On the left is what you send: a model name and a list of messages. The system message sets the rules, the user message asks the question.</a:t>
             </a:r>
             <a:endParaRPr lang="en-US" dirty="0"/>
           </a:p>
           <a:p>
             <a:r>
-              <a:rPr lang="en-US" b="1" dirty="0"/>
-              <a:t>SAY:</a:t>
-            </a:r>
-            <a:r>
               <a:rPr lang="en-US" dirty="0"/>
-              <a:t> "System sets the rules, user asks. Temperature near 0 gives the same answer most times; higher gives variety. Usage is the token count, and the bill is based on it."</a:t>
+              <a:t>On the right is what you get back. The reply is tucked inside choices, and then there's usage: two token counts, what you sent and what the model wrote. That's what the bill is based on. For now, a token is a chunk of text; step 06 shows exactly what that means.</a:t>
             </a:r>
             <a:endParaRPr lang="en-US" dirty="0"/>
           </a:p>
           <a:p>
             <a:r>
-              <a:rPr lang="en-US" b="1" dirty="0"/>
-              <a:t>IF ASKED:</a:t>
-            </a:r>
-            <a:r>
-              <a:rPr lang="en-US" dirty="0"/>
-              <a:t> What a token is comes in step 06.</a:t>
+              <a:rPr lang="en-US" i="1" dirty="0"/>
+              <a:t>[If asked: there's also a temperature setting. It's on the "Try it" slide, where you turn the dial yourself.]</a:t>
             </a:r>
             <a:endParaRPr lang="en-US" dirty="0"/>
           </a:p>
@@ -1710,58 +1443,22 @@
           <a:lstStyle/>
           <a:p>
             <a:r>
-              <a:rPr lang="en-US" b="1" dirty="0"/>
-              <a:t>POINT:</a:t>
-            </a:r>
-            <a:r>
               <a:rPr lang="en-US" dirty="0"/>
-              <a:t> A provider is an address plus a key. The openai package talks to all three; only base_url, the key and the model name change.</a:t>
+              <a:t>This is the sentence I want you to leave with: a provider is an address plus a key. Here's why. Most providers copied OpenAI's request shape, so the one openai package can talk to all of them. Look at the diagram: chat.py hands the SDK a base_url and an api_key, and that's all that changes between Google's cloud, OpenRouter, and Ollama on your own laptop.</a:t>
             </a:r>
             <a:endParaRPr lang="en-US" dirty="0"/>
           </a:p>
           <a:p>
             <a:r>
-              <a:rPr lang="en-US" b="1" dirty="0"/>
-              <a:t>SAY:</a:t>
-            </a:r>
-            <a:r>
               <a:rPr lang="en-US" dirty="0"/>
-              <a:t> "Most providers copy OpenAI's request shape, so one package works for all of them."</a:t>
+              <a:t>Swap the address, swap the key, pick one of that provider's model names, and the same code talks to a different company's model. That's how the course can let you bring your own provider.</a:t>
             </a:r>
             <a:endParaRPr lang="en-US" dirty="0"/>
           </a:p>
           <a:p>
             <a:r>
-              <a:rPr lang="en-US" b="1" dirty="0"/>
-              <a:t>DO:</a:t>
-            </a:r>
-            <a:r>
-              <a:rPr lang="en-US" dirty="0"/>
-              <a:t> Open prep-kit/code/providers.py, a three-row table. Run chat.py with two --provider values: only the bracket line changes.</a:t>
-            </a:r>
-            <a:endParaRPr lang="en-US" dirty="0"/>
-          </a:p>
-          <a:p>
-            <a:endParaRPr lang="en-US" dirty="0"/>
-          </a:p>
-          <a:p>
-            <a:r>
-              <a:rPr lang="en-US" dirty="0"/>
-              <a:t>──── INSTRUCTOR GUIDE ────</a:t>
-            </a:r>
-            <a:endParaRPr lang="en-US" dirty="0"/>
-          </a:p>
-          <a:p>
-            <a:r>
-              <a:rPr lang="en-US" dirty="0"/>
-              <a:t>ONE SDK, THREE ADDRESSES</a:t>
-            </a:r>
-            <a:endParaRPr lang="en-US" dirty="0"/>
-          </a:p>
-          <a:p>
-            <a:r>
-              <a:rPr lang="en-US" dirty="0"/>
-              <a:t>Open prep-kit/code/providers.py next to the slide. The whole provider table is three entries with a URL, a key name and a default model. Then run chat.py twice with two different --provider values and point out that only the bracket line changes.</a:t>
+              <a:rPr lang="en-US" i="1" dirty="0"/>
+              <a:t>[Do: open prep-kit/code/providers.py, a three-row table. Run chat.py with two --provider values: only the bracket line changes.]</a:t>
             </a:r>
             <a:endParaRPr lang="en-US" dirty="0"/>
           </a:p>
@@ -1848,34 +1545,22 @@
           <a:lstStyle/>
           <a:p>
             <a:r>
-              <a:rPr lang="en-US" b="1" dirty="0"/>
-              <a:t>POINT:</a:t>
-            </a:r>
-            <a:r>
               <a:rPr lang="en-US" dirty="0"/>
-              <a:t> Everything clever in the next four weeks happens around this call, not inside it.</a:t>
+              <a:t>Here's all the code it takes; follow the numbered comments. One: a client, which is an address and a key. The key comes from .env, the way the secrets slide showed. Two: one call, with a model name and a list of messages, the system rule and the user question. Three: you print the reply, and two token counts. That's it.</a:t>
             </a:r>
             <a:endParaRPr lang="en-US" dirty="0"/>
           </a:p>
           <a:p>
             <a:r>
-              <a:rPr lang="en-US" b="1" dirty="0"/>
-              <a:t>DO:</a:t>
-            </a:r>
-            <a:r>
               <a:rPr lang="en-US" dirty="0"/>
-              <a:t> Read it line by line: a client with an address and a key, a model name and messages, then the reply and two token counts.</a:t>
+              <a:t>Everything clever in the next four weeks happens around this call, not inside it: what goes into the messages, what you do with the reply, and how you check it. The kit wraps this in chat.py so you get a provider switch and readable error messages.</a:t>
             </a:r>
             <a:endParaRPr lang="en-US" dirty="0"/>
           </a:p>
           <a:p>
             <a:r>
-              <a:rPr lang="en-US" b="1" dirty="0"/>
-              <a:t>IF ASKED:</a:t>
-            </a:r>
-            <a:r>
-              <a:rPr lang="en-US" dirty="0"/>
-              <a:t> chat.py adds a timer and turns the usual errors (missing key, 401, 429, 404) into a sentence with a fix.</a:t>
+              <a:rPr lang="en-US" i="1" dirty="0"/>
+              <a:t>[If asked: chat.py adds a timer and turns the usual errors (missing key, 401, 429, 404) into a sentence with a fix.]</a:t>
             </a:r>
             <a:endParaRPr lang="en-US" dirty="0"/>
           </a:p>
@@ -1962,34 +1647,22 @@
           <a:lstStyle/>
           <a:p>
             <a:r>
-              <a:rPr lang="en-US" b="1" dirty="0"/>
-              <a:t>POINT:</a:t>
-            </a:r>
-            <a:r>
               <a:rPr lang="en-US" dirty="0"/>
-              <a:t> Only step 08 must be done before Monday: a paid course key and the full install.</a:t>
+              <a:t>Here's the deal for today. The course uses a handful of tools: a terminal, a virtual environment, APIs, and API keys. This session is a first touch of each one, so Monday doesn't start with a wall of new words. If you already use a terminal and APIs every day, go straight to steps 04, 05 and 08.</a:t>
             </a:r>
             <a:endParaRPr lang="en-US" dirty="0"/>
           </a:p>
           <a:p>
             <a:r>
-              <a:rPr lang="en-US" b="1" dirty="0"/>
-              <a:t>SAY:</a:t>
-            </a:r>
-            <a:r>
               <a:rPr lang="en-US" dirty="0"/>
-              <a:t> Keep it relaxed. "Already use a terminal and APIs? Go straight to steps 04, 05 and 08."</a:t>
+              <a:t>And this isn't a test. If a step doesn't work, write down what you saw and move on. The only step that must be done before Monday is step 08: a paid course key, and the full install. We don't want to spend class time on installing.</a:t>
             </a:r>
             <a:endParaRPr lang="en-US" dirty="0"/>
           </a:p>
           <a:p>
             <a:r>
-              <a:rPr lang="en-US" b="1" dirty="0"/>
-              <a:t>IF ASKED:</a:t>
-            </a:r>
-            <a:r>
-              <a:rPr lang="en-US" dirty="0"/>
-              <a:t> The install takes 10 to 20 minutes, and we don't want to spend class time on it.</a:t>
+              <a:rPr lang="en-US" i="1" dirty="0"/>
+              <a:t>[If asked: the install takes 10 to 20 minutes, which is why it has to happen before Monday.]</a:t>
             </a:r>
             <a:endParaRPr lang="en-US" dirty="0"/>
           </a:p>
@@ -2076,34 +1749,15 @@
           <a:lstStyle/>
           <a:p>
             <a:r>
-              <a:rPr lang="en-US" b="1" dirty="0"/>
-              <a:t>POINT:</a:t>
-            </a:r>
-            <a:r>
               <a:rPr lang="en-US" dirty="0"/>
-              <a:t> Three free ways to practise. None of them is wired into the course code.</a:t>
+              <a:t>Three free ways to practise, and none of them is wired into the course code; the course needs a paid key, which is step 08. Gemini is the easiest: keys come from aistudio.google.com/apikey, no card needed. One warning: on the free tier, Google may use what you send, so practise only on the Nimbus tickets. Never send anything personal or from work.</a:t>
             </a:r>
             <a:endParaRPr lang="en-US" dirty="0"/>
           </a:p>
           <a:p>
             <a:r>
-              <a:rPr lang="en-US" b="1" dirty="0"/>
-              <a:t>WATCH OUT:</a:t>
-            </a:r>
-            <a:r>
               <a:rPr lang="en-US" dirty="0"/>
-              <a:t> Gemini's free tier may use what you send. Never send anything personal or from work.</a:t>
-            </a:r>
-            <a:endParaRPr lang="en-US" dirty="0"/>
-          </a:p>
-          <a:p>
-            <a:r>
-              <a:rPr lang="en-US" b="1" dirty="0"/>
-              <a:t>SAY:</a:t>
-            </a:r>
-            <a:r>
-              <a:rPr lang="en-US" dirty="0"/>
-              <a:t> "OpenRouter shows how many models exist: the model name in the output changes as openrouter/free picks one. Ollama shows that a model is just a file of numbers."</a:t>
+              <a:t>OpenRouter is one key, hundreds of models. Watch the model name in the output change as openrouter/free picks a different one. Ollama runs on your laptop, no key. It's much weaker, but it shows you that a model is just a file of numbers you can download.</a:t>
             </a:r>
             <a:endParaRPr lang="en-US" dirty="0"/>
           </a:p>
@@ -2190,34 +1844,22 @@
           <a:lstStyle/>
           <a:p>
             <a:r>
-              <a:rPr lang="en-US" b="1" dirty="0"/>
-              <a:t>POINT:</a:t>
-            </a:r>
-            <a:r>
               <a:rPr lang="en-US" dirty="0"/>
-              <a:t> Everyone gets one working call, and sees temperature change the answers.</a:t>
+              <a:t>Time for your first calls. Start with show_env.py: it tells you which keys are set without ever printing them. Then run chat.py with whichever provider you've set up. Everyone should get one working call. Now look at the bracket line under the answer: the model, tokens in, tokens out, milliseconds. Those four numbers come back every session, so get used to reading them. Yours will differ from the slide.</a:t>
             </a:r>
             <a:endParaRPr lang="en-US" dirty="0"/>
           </a:p>
           <a:p>
             <a:r>
-              <a:rPr lang="en-US" b="1" dirty="0"/>
-              <a:t>DO:</a:t>
-            </a:r>
-            <a:r>
               <a:rPr lang="en-US" dirty="0"/>
-              <a:t> Point at the bracket line: model, tokens in, tokens out, milliseconds. Those four numbers come back every session. Theirs will differ from the slide.</a:t>
+              <a:t>Then the second half: temperature, a randomness dial. Ask for the same printer joke three times at 1.5, then three times at 0. High gives you a different joke most runs; near 0, mostly the same one.</a:t>
             </a:r>
             <a:endParaRPr lang="en-US" dirty="0"/>
           </a:p>
           <a:p>
             <a:r>
-              <a:rPr lang="en-US" b="1" dirty="0"/>
-              <a:t>WATCH OUT:</a:t>
-            </a:r>
-            <a:r>
-              <a:rPr lang="en-US" dirty="0"/>
-              <a:t> 429 is the free tier: wait a minute. 401: show_env.py usually spots a stray space or quote mark.</a:t>
+              <a:rPr lang="en-US" i="1" dirty="0"/>
+              <a:t>[Watch out: 429 is the free tier: wait a minute. 401: show_env.py usually spots a stray space or quote mark. The Ollama line needs step 05 first.]</a:t>
             </a:r>
             <a:endParaRPr lang="en-US" dirty="0"/>
           </a:p>
@@ -2304,58 +1946,29 @@
           <a:lstStyle/>
           <a:p>
             <a:r>
-              <a:rPr lang="en-US" b="1" dirty="0"/>
-              <a:t>POINT:</a:t>
-            </a:r>
-            <a:r>
               <a:rPr lang="en-US" dirty="0"/>
-              <a:t> A model can run on your own laptop, even offline.</a:t>
+              <a:t>Now the model on your own laptop. ollama pull downloads llama3.2, about 2 gigabytes, 3 billion parameters. Those parameters are the numbers the model is made of, and that's the whole download. Then the same chat.py, just a different provider. Before I run it, a warning: the first call after a restart takes 10 to 20 seconds while the model loads, so the silence isn't a failure.</a:t>
             </a:r>
             <a:endParaRPr lang="en-US" dirty="0"/>
           </a:p>
           <a:p>
             <a:r>
-              <a:rPr lang="en-US" b="1" dirty="0"/>
-              <a:t>DO:</a:t>
-            </a:r>
-            <a:r>
               <a:rPr lang="en-US" dirty="0"/>
-              <a:t> Warn them the first call takes 10 to 20 seconds while the model loads. Then turn off Wi-Fi and run it again. It still works.</a:t>
+              <a:t>Now I'll turn off Wi-Fi and run it again. It still works. The table tells you which model fits your memory: with 8 gigabytes stick to llama3.2; with 16 or more, try gemma3:4b too and compare.</a:t>
             </a:r>
             <a:endParaRPr lang="en-US" dirty="0"/>
           </a:p>
           <a:p>
             <a:r>
-              <a:rPr lang="en-US" b="1" dirty="0"/>
-              <a:t>WATCH OUT:</a:t>
-            </a:r>
-            <a:r>
-              <a:rPr lang="en-US" dirty="0"/>
-              <a:t> The CUDA crash is real; the CPU fix works. No model runs at all? Fine: Gemini and OpenRouter cover the rest.</a:t>
+              <a:rPr lang="en-US" i="1" dirty="0"/>
+              <a:t>[Do: turn off Wi-Fi on screen and run the call again.]</a:t>
             </a:r>
             <a:endParaRPr lang="en-US" dirty="0"/>
           </a:p>
           <a:p>
-            <a:endParaRPr lang="en-US" dirty="0"/>
-          </a:p>
-          <a:p>
-            <a:r>
-              <a:rPr lang="en-US" dirty="0"/>
-              <a:t>──── INSTRUCTOR GUIDE ────</a:t>
-            </a:r>
-            <a:endParaRPr lang="en-US" dirty="0"/>
-          </a:p>
-          <a:p>
-            <a:r>
-              <a:rPr lang="en-US" dirty="0"/>
-              <a:t>A MODEL ON YOUR OWN LAPTOP</a:t>
-            </a:r>
-            <a:endParaRPr lang="en-US" dirty="0"/>
-          </a:p>
-          <a:p>
-            <a:r>
-              <a:rPr lang="en-US" dirty="0"/>
-              <a:t>Turn off your Wi-Fi on screen and run the Ollama call. The first call after a restart takes 10 to 20 seconds to load the model; warn them before it happens so the silence doesn't look like a failure.</a:t>
+            <a:r>
+              <a:rPr lang="en-US" i="1" dirty="0"/>
+              <a:t>[Watch out: the CUDA crash is real; the CPU fix on the slide works. No model runs at all? Fine: Gemini and OpenRouter cover the rest.]</a:t>
             </a:r>
             <a:endParaRPr lang="en-US" dirty="0"/>
           </a:p>
@@ -2442,34 +2055,22 @@
           <a:lstStyle/>
           <a:p>
             <a:r>
-              <a:rPr lang="en-US" b="1" dirty="0"/>
-              <a:t>POINT:</a:t>
-            </a:r>
-            <a:r>
               <a:rPr lang="en-US" dirty="0"/>
-              <a:t> Models read tokens, not words. The order number is two pieces the model never sees as one.</a:t>
+              <a:t>Here's what a token is. Models don't read words; they read tokens. A tokenizer cuts text into chunks and turns each chunk into a number, and the model only ever sees those numbers. Often a chunk is a short word with its leading space, sometimes it's part of a word or a number. Ticket T-1001 is 40 words but 47 tokens.</a:t>
             </a:r>
             <a:endParaRPr lang="en-US" dirty="0"/>
           </a:p>
           <a:p>
             <a:r>
-              <a:rPr lang="en-US" b="1" dirty="0"/>
-              <a:t>SAY:</a:t>
-            </a:r>
-            <a:r>
               <a:rPr lang="en-US" dirty="0"/>
-              <a:t> "A tokenizer cuts text into chunks and turns each into a number." Point at 482 and 91: that's part of why models sometimes garble long numbers when copying them.</a:t>
+              <a:t>Now look at the highlighted bit: the order number 48291 became two tokens, 482 and 91. The model never sees that number as one thing. That's part of why models sometimes garble long numbers when copying them. Keep that in mind every time Deskhand handles an order ID.</a:t>
             </a:r>
             <a:endParaRPr lang="en-US" dirty="0"/>
           </a:p>
           <a:p>
             <a:r>
-              <a:rPr lang="en-US" b="1" dirty="0"/>
-              <a:t>IF ASKED:</a:t>
-            </a:r>
-            <a:r>
-              <a:rPr lang="en-US" dirty="0"/>
-              <a:t> It runs offline; nothing is sent. Session 1 goes deeper.</a:t>
+              <a:rPr lang="en-US" i="1" dirty="0"/>
+              <a:t>[If asked: count_tokens.py runs offline; nothing is sent. Session 1 goes deeper.]</a:t>
             </a:r>
             <a:endParaRPr lang="en-US" dirty="0"/>
           </a:p>
@@ -2556,45 +2157,22 @@
           <a:lstStyle/>
           <a:p>
             <a:r>
-              <a:rPr lang="en-US" b="1" dirty="0"/>
-              <a:t>POINT:</a:t>
-            </a:r>
-            <a:r>
               <a:rPr lang="en-US" dirty="0"/>
-              <a:t> The same request costs more in Arabic, because the tokenizer learned mostly from English.</a:t>
+              <a:t>Same request, three languages, three prices. The English sentence is 7 words and 7 tokens. The formal Arabic is 4 words but 10 tokens. The shorter, informal one is 3 words and 7 tokens. The reason is that the tokenizer learned mostly from English, so English words tend to be one token each, while other languages get cut into more pieces. Refund is one token; استرداد is three.</a:t>
             </a:r>
             <a:endParaRPr lang="en-US" dirty="0"/>
           </a:p>
           <a:p>
             <a:r>
-              <a:rPr lang="en-US" b="1" dirty="0"/>
-              <a:t>DO:</a:t>
-            </a:r>
-            <a:r>
               <a:rPr lang="en-US" dirty="0"/>
-              <a:t> Ask who has built a product for Arabic-speaking users.</a:t>
+              <a:t>More tokens means more cost and a little more time per call. So if you build for Arabic-speaking users, estimate your costs with your real customers' language, not English test data. Who here has built a product for Arabic-speaking users?</a:t>
             </a:r>
             <a:endParaRPr lang="en-US" dirty="0"/>
           </a:p>
           <a:p>
             <a:r>
-              <a:rPr lang="en-US" b="1" dirty="0"/>
-              <a:t>SAY:</a:t>
-            </a:r>
-            <a:r>
-              <a:rPr lang="en-US" dirty="0"/>
-              <a:t> "More tokens means more cost and a little more time. Estimate costs with your real customers' language, not English test data."</a:t>
-            </a:r>
-            <a:endParaRPr lang="en-US" dirty="0"/>
-          </a:p>
-          <a:p>
-            <a:r>
-              <a:rPr lang="en-US" b="1" dirty="0"/>
-              <a:t>IF ASKED:</a:t>
-            </a:r>
-            <a:r>
-              <a:rPr lang="en-US" dirty="0"/>
-              <a:t> Counts are from the GPT-4o tokenizer (o200k_base). Other tokenizers differ; the gap has narrowed but not closed.</a:t>
+              <a:rPr lang="en-US" i="1" dirty="0"/>
+              <a:t>[If asked: counts are from the GPT-4o tokenizer (o200k_base). Other tokenizers differ; the gap has narrowed but not closed.]</a:t>
             </a:r>
             <a:endParaRPr lang="en-US" dirty="0"/>
           </a:p>
@@ -2681,34 +2259,22 @@
           <a:lstStyle/>
           <a:p>
             <a:r>
-              <a:rPr lang="en-US" b="1" dirty="0"/>
-              <a:t>POINT:</a:t>
-            </a:r>
-            <a:r>
               <a:rPr lang="en-US" dirty="0"/>
-              <a:t> The choice of model dominates the bill, and the reply usually costs more than the question.</a:t>
+              <a:t>Let's put a price on one ticket. Read T-1001, 47 tokens, and write a 150-token reply. The sum is simple: input tokens times the input price, plus output tokens times the output price, divided by a million, because prices are quoted per million tokens. count_tokens.py does that sum for you.</a:t>
             </a:r>
             <a:endParaRPr lang="en-US" dirty="0"/>
           </a:p>
           <a:p>
             <a:r>
-              <a:rPr lang="en-US" b="1" dirty="0"/>
-              <a:t>SAY:</a:t>
-            </a:r>
-            <a:r>
               <a:rPr lang="en-US" dirty="0"/>
-              <a:t> "Input tokens times input price, plus output tokens times output price, divided by a million." count_tokens.py does it for them.</a:t>
+              <a:t>Two things to notice. One call is a fraction of a cent, so a single ticket never matters. What does matter is the model: 97 cents for ten thousand tickets on gpt-4o-mini, $16.18 on gpt-4o, a 17 times difference. And output costs more than input, so the reply usually costs more than the question.</a:t>
             </a:r>
             <a:endParaRPr lang="en-US" dirty="0"/>
           </a:p>
           <a:p>
             <a:r>
-              <a:rPr lang="en-US" b="1" dirty="0"/>
-              <a:t>IF ASKED:</a:t>
-            </a:r>
-            <a:r>
-              <a:rPr lang="en-US" dirty="0"/>
-              <a:t> compare.py times one ticket on every provider they've set up. Times vary run to run; Session 1 measures over many calls.</a:t>
+              <a:rPr lang="en-US" i="1" dirty="0"/>
+              <a:t>[If asked: compare.py times one ticket on every provider they've set up. Times vary run to run; Session 1 measures over many calls.]</a:t>
             </a:r>
             <a:endParaRPr lang="en-US" dirty="0"/>
           </a:p>
@@ -2795,34 +2361,15 @@
           <a:lstStyle/>
           <a:p>
             <a:r>
-              <a:rPr lang="en-US" b="1" dirty="0"/>
-              <a:t>ASK:</a:t>
-            </a:r>
-            <a:r>
               <a:rPr lang="en-US" dirty="0"/>
-              <a:t> Question 1. Answer: The address (base_url), the key and the model name, which is just a string. The request code stays the same.</a:t>
+              <a:t>Three more. First: to switch chat.py from Gemini to OpenRouter, which three things change? [Answer: the address (base_url), the API key, and the model name. The request code stays the same.] Second: one of your keys ends up on GitHub by mistake. What do you do first? [Answer: revoke it in the provider's dashboard right away, then make a new one.] Third: which costs more per token, what you send or what the model writes? [Answer: what the model writes. For gpt-4o-mini, four times the input price.]</a:t>
             </a:r>
             <a:endParaRPr lang="en-US" dirty="0"/>
           </a:p>
           <a:p>
             <a:r>
-              <a:rPr lang="en-US" b="1" dirty="0"/>
-              <a:t>ASK:</a:t>
-            </a:r>
-            <a:r>
               <a:rPr lang="en-US" dirty="0"/>
-              <a:t> Question 2. Answer: Revoke it in the provider's dashboard right away, then make a new one. Deleting the commit isn't enough: the key is already out.</a:t>
-            </a:r>
-            <a:endParaRPr lang="en-US" dirty="0"/>
-          </a:p>
-          <a:p>
-            <a:r>
-              <a:rPr lang="en-US" b="1" dirty="0"/>
-              <a:t>ASK:</a:t>
-            </a:r>
-            <a:r>
-              <a:rPr lang="en-US" dirty="0"/>
-              <a:t> Question 3. Answer: What the model writes. For gpt-4o-mini, four times the input price.</a:t>
+              <a:t>On the second one, the tempting answer is to delete the commit. That isn't enough: the bots already have it. Revoke first, tidy up after. On the third, remember that the reply usually costs more than the question.</a:t>
             </a:r>
             <a:endParaRPr lang="en-US" dirty="0"/>
           </a:p>
@@ -2909,34 +2456,22 @@
           <a:lstStyle/>
           <a:p>
             <a:r>
-              <a:rPr lang="en-US" b="1" dirty="0"/>
-              <a:t>POINT:</a:t>
-            </a:r>
-            <a:r>
               <a:rPr lang="en-US" dirty="0"/>
-              <a:t> The model suggests, your code decides. That rule runs through the whole course, especially for refunds.</a:t>
+              <a:t>This is the rule the whole course runs on: the model suggests, your code decides. taste_of_resolvo.py asks a model to sort real tickets into a category, priority and sentiment, and asks for only a JSON object back. Then the code checks the reply three ways before trusting it. Is it valid JSON? Models still say "Sure! Here's the JSON", or wrap it in a code fence. Is it an object, not a list or a string? And is every value from the allowed list? Models invent categories.</a:t>
             </a:r>
             <a:endParaRPr lang="en-US" dirty="0"/>
           </a:p>
           <a:p>
             <a:r>
-              <a:rPr lang="en-US" b="1" dirty="0"/>
-              <a:t>SAY:</a:t>
-            </a:r>
-            <a:r>
               <a:rPr lang="en-US" dirty="0"/>
-              <a:t> "The prompt says reply with ONLY a JSON object, and models still say 'Sure! Here's the JSON', wrap it in a code fence, or invent a category."</a:t>
+              <a:t>Anything that fails is printed as REJECTED, and it's never used. That matters most later, when the action is a refund.</a:t>
             </a:r>
             <a:endParaRPr lang="en-US" dirty="0"/>
           </a:p>
           <a:p>
             <a:r>
-              <a:rPr lang="en-US" b="1" dirty="0"/>
-              <a:t>IF ASKED:</a:t>
-            </a:r>
-            <a:r>
-              <a:rPr lang="en-US" dirty="0"/>
-              <a:t> It's a small version of checkpoint 01, with the same labels.</a:t>
+              <a:rPr lang="en-US" i="1" dirty="0"/>
+              <a:t>[If asked: it's a small version of checkpoint 01, with the same labels. The file name uses Resolvo, Deskhand's earlier name.]</a:t>
             </a:r>
             <a:endParaRPr lang="en-US" dirty="0"/>
           </a:p>
@@ -3023,58 +2558,22 @@
           <a:lstStyle/>
           <a:p>
             <a:r>
-              <a:rPr lang="en-US" b="1" dirty="0"/>
-              <a:t>POINT:</a:t>
-            </a:r>
-            <a:r>
               <a:rPr lang="en-US" dirty="0"/>
-              <a:t> A reply can pass every check and still be wrong. This is a real run from building the kit.</a:t>
+              <a:t>This is the most important slide of the second half, and it's a real run from building the kit. Read the ticket: a customer got a Nimbus smart speaker as a gift and already owns one. Nothing is defective. They want to return a duplicate gift. llama3.2 said product_defect, and that reply passed every check: valid JSON, an object, a label from the list.</a:t>
             </a:r>
             <a:endParaRPr lang="en-US" dirty="0"/>
           </a:p>
           <a:p>
             <a:r>
-              <a:rPr lang="en-US" b="1" dirty="0"/>
-              <a:t>ASK:</a:t>
-            </a:r>
-            <a:r>
               <a:rPr lang="en-US" dirty="0"/>
-              <a:t> "What code could catch this?" Answer: None, by looking at one reply. You run many tickets with known answers: evaluation, Session 10.</a:t>
+              <a:t>So there are two kinds of wrong. Wrong shape, which your code catches every time. And wrong answer: perfect JSON, wrong label. Looking at this one reply, nothing tells you it's wrong. So how would you ever find out? [Answer: run many tickets whose right answer you already know, and count the matches. "A person checks them" is a fair first answer.]</a:t>
             </a:r>
             <a:endParaRPr lang="en-US" dirty="0"/>
           </a:p>
           <a:p>
             <a:r>
-              <a:rPr lang="en-US" b="1" dirty="0"/>
-              <a:t>SAY:</a:t>
-            </a:r>
-            <a:r>
-              <a:rPr lang="en-US" dirty="0"/>
-              <a:t> "Nothing is defective. The customer got a duplicate gift and wants to return it."</a:t>
-            </a:r>
-            <a:endParaRPr lang="en-US" dirty="0"/>
-          </a:p>
-          <a:p>
-            <a:endParaRPr lang="en-US" dirty="0"/>
-          </a:p>
-          <a:p>
-            <a:r>
-              <a:rPr lang="en-US" dirty="0"/>
-              <a:t>──── INSTRUCTOR GUIDE ────</a:t>
-            </a:r>
-            <a:endParaRPr lang="en-US" dirty="0"/>
-          </a:p>
-          <a:p>
-            <a:r>
-              <a:rPr lang="en-US" dirty="0"/>
-              <a:t>TWO KINDS OF WRONG</a:t>
-            </a:r>
-            <a:endParaRPr lang="en-US" dirty="0"/>
-          </a:p>
-          <a:p>
-            <a:r>
-              <a:rPr lang="en-US" dirty="0"/>
-              <a:t>This is the most important slide of the second half. The T-1011 result is real: llama3.2 labelled a duplicate gift as product_defect, and the reply passed every check. Ask the room what code could catch that. The honest answer is "none, by looking at one reply", which sets up Session 10.</a:t>
+              <a:rPr lang="en-US" i="1" dirty="0"/>
+              <a:t>[If asked: Session 2 makes wrong shapes nearly impossible. Session 10 is the known-answers testing, called evaluation.]</a:t>
             </a:r>
             <a:endParaRPr lang="en-US" dirty="0"/>
           </a:p>
@@ -3161,45 +2660,29 @@
           <a:lstStyle/>
           <a:p>
             <a:r>
-              <a:rPr lang="en-US" b="1" dirty="0"/>
-              <a:t>POINT:</a:t>
-            </a:r>
-            <a:r>
               <a:rPr lang="en-US" dirty="0"/>
-              <a:t> The must-do: a paid course key with $10 credit and a monthly budget.</a:t>
+              <a:t>Now the must-do: a paid course key, with $10 of credit and a monthly budget. OpenAI is the recommendation: one key, everything covered, embeddings included, for week 3. Azure works if your employer gives it to you. Anthropic alone doesn't, because Session 1's bot only speaks OpenAI or Azure, and Anthropic has no embeddings API.</a:t>
             </a:r>
             <a:endParaRPr lang="en-US" dirty="0"/>
           </a:p>
           <a:p>
             <a:r>
-              <a:rPr lang="en-US" b="1" dirty="0"/>
-              <a:t>SAY:</a:t>
-            </a:r>
-            <a:r>
               <a:rPr lang="en-US" dirty="0"/>
-              <a:t> "$10 is plenty. On the default small model an evening's steps cost cents, and the slides warn you before anything costs more."</a:t>
+              <a:t>The three steps are on the slide: add $10 prepaid, set a monthly budget, create one API key, named resolvo, as step 08 says. You only see it once, so paste it into .env. And $10 is plenty: on the default small model an evening's steps cost cents, and the slides warn you before anything costs more.</a:t>
             </a:r>
             <a:endParaRPr lang="en-US" dirty="0"/>
           </a:p>
           <a:p>
             <a:r>
-              <a:rPr lang="en-US" b="1" dirty="0"/>
-              <a:t>WATCH OUT:</a:t>
-            </a:r>
-            <a:r>
-              <a:rPr lang="en-US" dirty="0"/>
-              <a:t> Azure: deployment name, not model name.</a:t>
+              <a:rPr lang="en-US" i="1" dirty="0"/>
+              <a:t>[Watch out: Azure: deployment name, not model name.]</a:t>
             </a:r>
             <a:endParaRPr lang="en-US" dirty="0"/>
           </a:p>
           <a:p>
             <a:r>
-              <a:rPr lang="en-US" b="1" dirty="0"/>
-              <a:t>IF ASKED:</a:t>
-            </a:r>
-            <a:r>
-              <a:rPr lang="en-US" dirty="0"/>
-              <a:t> Anthropic alone fails because Session 1's bot only speaks OpenAI or Azure, and Anthropic has no embeddings API (week 3).</a:t>
+              <a:rPr lang="en-US" i="1" dirty="0"/>
+              <a:t>[If asked: ChatGPT Plus and Claude Pro don't include API access. They're separate products.]</a:t>
             </a:r>
             <a:endParaRPr lang="en-US" dirty="0"/>
           </a:p>
@@ -3286,45 +2769,29 @@
           <a:lstStyle/>
           <a:p>
             <a:r>
-              <a:rPr lang="en-US" b="1" dirty="0"/>
-              <a:t>POINT:</a:t>
-            </a:r>
-            <a:r>
               <a:rPr lang="en-US" dirty="0"/>
-              <a:t> Every tool today shows up again in the Resolvo story.</a:t>
+              <a:t>Here's the story the whole month hangs on. Nimbus Electronics is a small online store, and customers send it support tickets. Deskhand is the bot we're building: it reads each ticket, checks the order and the store's policies, and drafts the fix. The first version is broken in ten ways, and each session fixes one or two.</a:t>
             </a:r>
             <a:endParaRPr lang="en-US" dirty="0"/>
           </a:p>
           <a:p>
             <a:r>
-              <a:rPr lang="en-US" b="1" dirty="0"/>
-              <a:t>SAY:</a:t>
-            </a:r>
-            <a:r>
               <a:rPr lang="en-US" dirty="0"/>
-              <a:t> "You'll meet this ticket again on Monday." Keep it short; Session 1 tells the story properly.</a:t>
+              <a:t>In class I drive and you steer: you pick the tickets, call the predictions, and vote on whether a refund goes out. Every session ends with a one-page list of things to try that evening, and today's setup is what makes that possible. You'll meet this ticket again on Monday.</a:t>
             </a:r>
             <a:endParaRPr lang="en-US" dirty="0"/>
           </a:p>
           <a:p>
             <a:r>
-              <a:rPr lang="en-US" b="1" dirty="0"/>
-              <a:t>SAY:</a:t>
-            </a:r>
-            <a:r>
-              <a:rPr lang="en-US" dirty="0"/>
-              <a:t> "In class I drive and you steer: you pick the tickets, call the predictions, vote at the approval gate. Every session ends with a one-page 'try this tonight', and that's what today's setup is for."</a:t>
+              <a:rPr lang="en-US" i="1" dirty="0"/>
+              <a:t>[Do: keep this short; Session 1 tells the story properly.]</a:t>
             </a:r>
             <a:endParaRPr lang="en-US" dirty="0"/>
           </a:p>
           <a:p>
             <a:r>
-              <a:rPr lang="en-US" b="1" dirty="0"/>
-              <a:t>IF ASKED:</a:t>
-            </a:r>
-            <a:r>
-              <a:rPr lang="en-US" dirty="0"/>
-              <a:t> The kit's data/tickets.json holds the same 60 tickets they'll use all month, so T-1001 will feel familiar.</a:t>
+              <a:rPr lang="en-US" i="1" dirty="0"/>
+              <a:t>[If asked: the kit's data/tickets.json holds the same 60 tickets they'll use all month, so T-1001 will feel familiar.]</a:t>
             </a:r>
             <a:endParaRPr lang="en-US" dirty="0"/>
           </a:p>
@@ -3411,139 +2878,22 @@
           <a:lstStyle/>
           <a:p>
             <a:r>
-              <a:rPr lang="en-US" b="1" dirty="0"/>
-              <a:t>POINT:</a:t>
-            </a:r>
-            <a:r>
               <a:rPr lang="en-US" dirty="0"/>
-              <a:t> Clone the course repo next to the kit, give it its own venv, and run the check until it says Ready.</a:t>
+              <a:t>The last step, and the one that takes longest. Clone the course repo next to the kit, not inside it. Give it its own venv: if the kit's one is still active, deactivate it first, then make and activate a new one. The install is the full course list, so expect 10 to 20 minutes; start it and let it run. Copy .env.example to .env, set LLM_PROVIDER=openai, and paste in your key. Then run check_setup.py --live and keep going until it says Ready. Warn lines are fine. Only FAIL lines need fixing, and each one prints what to do.</a:t>
             </a:r>
             <a:endParaRPr lang="en-US" dirty="0"/>
           </a:p>
           <a:p>
             <a:r>
-              <a:rPr lang="en-US" b="1" dirty="0"/>
-              <a:t>WATCH OUT:</a:t>
-            </a:r>
-            <a:r>
-              <a:rPr lang="en-US" dirty="0"/>
-              <a:t> The template starts with LLM_PROVIDER=azure. Students fill in the OpenAI key and miss that line. The check names it.</a:t>
+              <a:rPr lang="en-US" i="1" dirty="0"/>
+              <a:t>[Watch out: the template starts with LLM_PROVIDER=azure. Students fill in the OpenAI key, then miss that line. The check names it.]</a:t>
             </a:r>
             <a:endParaRPr lang="en-US" dirty="0"/>
           </a:p>
           <a:p>
             <a:r>
-              <a:rPr lang="en-US" b="1" dirty="0"/>
-              <a:t>SAY:</a:t>
-            </a:r>
-            <a:r>
-              <a:rPr lang="en-US" dirty="0"/>
-              <a:t> "Warn lines are fine. Only FAIL lines need fixing, and each prints what to do."</a:t>
-            </a:r>
-            <a:endParaRPr lang="en-US" dirty="0"/>
-          </a:p>
-          <a:p>
-            <a:r>
-              <a:rPr lang="en-US" b="1" dirty="0"/>
-              <a:t>IF ASKED:</a:t>
-            </a:r>
-            <a:r>
-              <a:rPr lang="en-US" dirty="0"/>
-              <a:t> --live makes one tiny real call, a fraction of a cent.</a:t>
-            </a:r>
-            <a:endParaRPr lang="en-US" dirty="0"/>
-          </a:p>
-          <a:p>
-            <a:endParaRPr lang="en-US" dirty="0"/>
-          </a:p>
-          <a:p>
-            <a:r>
-              <a:rPr lang="en-US" dirty="0"/>
-              <a:t>──── INSTRUCTOR GUIDE ────</a:t>
-            </a:r>
-            <a:endParaRPr lang="en-US" dirty="0"/>
-          </a:p>
-          <a:p>
-            <a:r>
-              <a:rPr lang="en-US" dirty="0"/>
-              <a:t>COMMON PROBLEMS</a:t>
-            </a:r>
-            <a:endParaRPr lang="en-US" dirty="0"/>
-          </a:p>
-          <a:p>
-            <a:r>
-              <a:rPr lang="en-US" dirty="0"/>
-              <a:t>Symptom — Cause — Fix</a:t>
-            </a:r>
-            <a:endParaRPr lang="en-US" dirty="0"/>
-          </a:p>
-          <a:p>
-            <a:r>
-              <a:rPr lang="en-US" dirty="0"/>
-              <a:t>py not found (Windows) — Python not installed, or installed without the launcher — Reinstall from python.org with the defaults</a:t>
-            </a:r>
-            <a:endParaRPr lang="en-US" dirty="0"/>
-          </a:p>
-          <a:p>
-            <a:r>
-              <a:rPr lang="en-US" dirty="0"/>
-              <a:t>running scripts is disabled — PowerShell execution policy — Set-ExecutionPolicy -Scope CurrentUser RemoteSigned</a:t>
-            </a:r>
-            <a:endParaRPr lang="en-US" dirty="0"/>
-          </a:p>
-          <a:p>
-            <a:r>
-              <a:rPr lang="en-US" dirty="0"/>
-              <a:t>MISSING packages right after pip install — pip ran outside the venv — Activate, install again</a:t>
-            </a:r>
-            <a:endParaRPr lang="en-US" dirty="0"/>
-          </a:p>
-          <a:p>
-            <a:r>
-              <a:rPr lang="en-US" dirty="0"/>
-              <a:t>Gemini or OpenRouter 401 — Key pasted with a space or quotes — show_env.py flags both</a:t>
-            </a:r>
-            <a:endParaRPr lang="en-US" dirty="0"/>
-          </a:p>
-          <a:p>
-            <a:r>
-              <a:rPr lang="en-US" dirty="0"/>
-              <a:t>429 on Gemini or OpenRouter — Free-tier rate limit — Wait a minute; OpenRouter allows about 50 free requests a day without credit</a:t>
-            </a:r>
-            <a:endParaRPr lang="en-US" dirty="0"/>
-          </a:p>
-          <a:p>
-            <a:r>
-              <a:rPr lang="en-US" dirty="0"/>
-              <a:t>Ollama 500 mentioning CUDA — GPU driver problem — Quit Ollama, then $env:CUDA_VISIBLE_DEVICES="-1"; ollama serve</a:t>
-            </a:r>
-            <a:endParaRPr lang="en-US" dirty="0"/>
-          </a:p>
-          <a:p>
-            <a:r>
-              <a:rPr lang="en-US" dirty="0"/>
-              <a:t>check_setup.py: "This is the prep kit's venv" — Ran the check before switching venvs — deactivate, then activate resolvo-workshop/.venv and run it from there</a:t>
-            </a:r>
-            <a:endParaRPr lang="en-US" dirty="0"/>
-          </a:p>
-          <a:p>
-            <a:r>
-              <a:rPr lang="en-US" dirty="0"/>
-              <a:t>check_setup.py: "you filled in the openai key" — Template still says LLM_PROVIDER=azure — Change that line to openai</a:t>
-            </a:r>
-            <a:endParaRPr lang="en-US" dirty="0"/>
-          </a:p>
-          <a:p>
-            <a:r>
-              <a:rPr lang="en-US" dirty="0"/>
-              <a:t>Azure DeploymentNotFound (404) — Model name used instead of deployment name — Use the name chosen when deploying</a:t>
-            </a:r>
-            <a:endParaRPr lang="en-US" dirty="0"/>
-          </a:p>
-          <a:p>
-            <a:r>
-              <a:rPr lang="en-US" dirty="0"/>
-              <a:t>Course install takes forever — It's big: LangChain, LangGraph, RAGAS, DeepEval — Normal. Start it before the call ends</a:t>
+              <a:rPr lang="en-US" i="1" dirty="0"/>
+              <a:t>[If asked: --live makes one tiny real call, a fraction of a cent.]</a:t>
             </a:r>
             <a:endParaRPr lang="en-US" dirty="0"/>
           </a:p>
@@ -3630,34 +2980,22 @@
           <a:lstStyle/>
           <a:p>
             <a:r>
-              <a:rPr lang="en-US" b="1" dirty="0"/>
-              <a:t>POINT:</a:t>
-            </a:r>
-            <a:r>
               <a:rPr lang="en-US" dirty="0"/>
-              <a:t> The last two items matter most: the setup check says Ready, and git pull on the morning of Session 1.</a:t>
+              <a:t>Here's the checklist for Monday. Most of it you've seen today. The last two items matter most: the setup check says Ready, and git pull on the morning of Session 1, so you start with the latest code. If you're stuck on the check, don't lose your weekend to it. Come 20 minutes early on Monday with the output and we'll fix it together. Everything else on this list is a bonus.</a:t>
             </a:r>
             <a:endParaRPr lang="en-US" dirty="0"/>
           </a:p>
           <a:p>
             <a:r>
-              <a:rPr lang="en-US" b="1" dirty="0"/>
-              <a:t>DO:</a:t>
-            </a:r>
-            <a:r>
-              <a:rPr lang="en-US" dirty="0"/>
-              <a:t> Leave this up at the end of the call.</a:t>
+              <a:rPr lang="en-US" i="1" dirty="0"/>
+              <a:t>[Do: leave this up at the end of the call.]</a:t>
             </a:r>
             <a:endParaRPr lang="en-US" dirty="0"/>
           </a:p>
           <a:p>
             <a:r>
-              <a:rPr lang="en-US" b="1" dirty="0"/>
-              <a:t>IF ASKED:</a:t>
-            </a:r>
-            <a:r>
-              <a:rPr lang="en-US" dirty="0"/>
-              <a:t> No Docker needed. In Session 3 you watch me use an AI coding assistant; you need your own that evening to repeat it. The kit's step 08 says how to install a free one.</a:t>
+              <a:rPr lang="en-US" i="1" dirty="0"/>
+              <a:t>[If asked: no Docker needed. In Session 3 you watch me use an AI coding assistant; you need your own that evening to repeat it. The kit's step 08 says how to install a free one.]</a:t>
             </a:r>
             <a:endParaRPr lang="en-US" dirty="0"/>
           </a:p>
@@ -3744,23 +3082,15 @@
           <a:lstStyle/>
           <a:p>
             <a:r>
-              <a:rPr lang="en-US" b="1" dirty="0"/>
-              <a:t>POINT:</a:t>
-            </a:r>
-            <a:r>
               <a:rPr lang="en-US" dirty="0"/>
-              <a:t> Thank them. The kit's README has the checklist and everything from today.</a:t>
+              <a:t>That's it for today. Thank you for giving up part of your weekend. Everything from today is in the kit's README, checklist included, so you don't need to take notes. Session 1 is "What Changed, and What Didn't". In class you watch and vote; in the evenings you run the same thing on the laptop that passed the check. See you on Monday.</a:t>
             </a:r>
             <a:endParaRPr lang="en-US" dirty="0"/>
           </a:p>
           <a:p>
             <a:r>
-              <a:rPr lang="en-US" b="1" dirty="0"/>
-              <a:t>DO:</a:t>
-            </a:r>
-            <a:r>
-              <a:rPr lang="en-US" dirty="0"/>
-              <a:t> Five minutes of questions, then stay on the call for anyone whose setup check still fails.</a:t>
+              <a:rPr lang="en-US" i="1" dirty="0"/>
+              <a:t>[Do: five minutes of questions, then stay on the call for anyone whose setup check still fails.]</a:t>
             </a:r>
             <a:endParaRPr lang="en-US" dirty="0"/>
           </a:p>
@@ -3847,34 +3177,22 @@
           <a:lstStyle/>
           <a:p>
             <a:r>
-              <a:rPr lang="en-US" b="1" dirty="0"/>
-              <a:t>POINT:</a:t>
-            </a:r>
-            <a:r>
               <a:rPr lang="en-US" dirty="0"/>
-              <a:t> Step 08 is the must-do. The rest can wait for the weekend.</a:t>
+              <a:t>This is the route: eight steps, just under four hours if you do them alone. Step 08 is the must-do. The rest can wait for the weekend. Steps 04 and 05 overlap: both give you a first call to a language model, one in the cloud and one on your own laptop. If your laptop can't run a local model, skip 05. If you can't sign up for Google, use OpenRouter or Ollama instead. Each step is one short Markdown page, so none of this is heavy reading.</a:t>
             </a:r>
             <a:endParaRPr lang="en-US" dirty="0"/>
           </a:p>
           <a:p>
             <a:r>
-              <a:rPr lang="en-US" b="1" dirty="0"/>
-              <a:t>SAY:</a:t>
-            </a:r>
-            <a:r>
-              <a:rPr lang="en-US" dirty="0"/>
-              <a:t> "Steps 04 and 05 overlap. Laptop can't run a local model? Skip 05. Can't sign up for Google? Use OpenRouter or Ollama."</a:t>
+              <a:rPr lang="en-US" i="1" dirty="0"/>
+              <a:t>[Watch out: the kit still says Resolvo, the bot's earlier name, in step 07 (07-taste-of-resolvo.md, code\taste_of_resolvo.py), in step 08's key name and in its README. It's the same bot as Deskhand.]</a:t>
             </a:r>
             <a:endParaRPr lang="en-US" dirty="0"/>
           </a:p>
           <a:p>
             <a:r>
-              <a:rPr lang="en-US" b="1" dirty="0"/>
-              <a:t>IF ASKED:</a:t>
-            </a:r>
-            <a:r>
-              <a:rPr lang="en-US" dirty="0"/>
-              <a:t> Each step page ends with a "Try this" list and an "If something went wrong" table.</a:t>
+              <a:rPr lang="en-US" i="1" dirty="0"/>
+              <a:t>[If asked: each step page ends with a "Try this" list and an "If something went wrong" table.]</a:t>
             </a:r>
             <a:endParaRPr lang="en-US" dirty="0"/>
           </a:p>
@@ -3961,34 +3279,22 @@
           <a:lstStyle/>
           <a:p>
             <a:r>
-              <a:rPr lang="en-US" b="1" dirty="0"/>
-              <a:t>POINT:</a:t>
-            </a:r>
-            <a:r>
               <a:rPr lang="en-US" dirty="0"/>
-              <a:t> Check which folder you're in before you run anything.</a:t>
+              <a:t>Five commands are all you need for the whole course. pwd tells you where you are, ls shows what's in the folder, cd moves you around. The one habit I want you to build is this: check which folder you're in before you run anything. Running a script from the wrong folder is the most common first-week mistake, and the nasty part is that some scripts don't complain. They just do the wrong thing quietly. That's why the red box is on the slide.</a:t>
             </a:r>
             <a:endParaRPr lang="en-US" dirty="0"/>
           </a:p>
           <a:p>
             <a:r>
-              <a:rPr lang="en-US" b="1" dirty="0"/>
-              <a:t>DO:</a:t>
-            </a:r>
-            <a:r>
-              <a:rPr lang="en-US" dirty="0"/>
-              <a:t> Demo pwd, ls and cd live. In VS Code, Ctrl+backtick opens a terminal.</a:t>
+              <a:rPr lang="en-US" i="1" dirty="0"/>
+              <a:t>[Do: demo pwd, ls and cd live. In VS Code, Ctrl+backtick opens a terminal.]</a:t>
             </a:r>
             <a:endParaRPr lang="en-US" dirty="0"/>
           </a:p>
           <a:p>
             <a:r>
-              <a:rPr lang="en-US" b="1" dirty="0"/>
-              <a:t>IF ASKED:</a:t>
-            </a:r>
-            <a:r>
-              <a:rPr lang="en-US" dirty="0"/>
-              <a:t> The silent failure is real. Session 1's broken bot finds its policy files by relative path. Run it from the repo root and it answers without any policies, and no error.</a:t>
+              <a:rPr lang="en-US" i="1" dirty="0"/>
+              <a:t>[If asked: the silent failure is real. Session 1's broken bot finds its policy files by relative path. Run it from the repo root and it answers without any policies, and no error.]</a:t>
             </a:r>
             <a:endParaRPr lang="en-US" dirty="0"/>
           </a:p>
@@ -4075,34 +3381,22 @@
           <a:lstStyle/>
           <a:p>
             <a:r>
-              <a:rPr lang="en-US" b="1" dirty="0"/>
-              <a:t>POINT:</a:t>
-            </a:r>
-            <a:r>
               <a:rPr lang="en-US" dirty="0"/>
-              <a:t> A venv is a private Python with its own packages, one per project.</a:t>
+              <a:t>A quick word on packages first. Packages are other people's code, like openai or httpx, that you install and then import. Now look at the left box. If you install everything into the one Python on your computer, every project shares one shelf. Project A wants openai 2, project B wants openai 1, and one of them breaks.</a:t>
             </a:r>
             <a:endParaRPr lang="en-US" dirty="0"/>
           </a:p>
           <a:p>
             <a:r>
-              <a:rPr lang="en-US" b="1" dirty="0"/>
-              <a:t>SAY:</a:t>
-            </a:r>
-            <a:r>
               <a:rPr lang="en-US" dirty="0"/>
-              <a:t> "Packages are other people's code, like openai or httpx. In one shared Python, projects fight over versions. A venv is a separate toolbox per job."</a:t>
+              <a:t>A virtual environment, a venv, fixes that. It's a private copy of Python with its own shelf of packages, one per project. Think of it as a separate toolbox for each job. And because it's just a folder, there's nothing precious about it.</a:t>
             </a:r>
             <a:endParaRPr lang="en-US" dirty="0"/>
           </a:p>
           <a:p>
             <a:r>
-              <a:rPr lang="en-US" b="1" dirty="0"/>
-              <a:t>WATCH OUT:</a:t>
-            </a:r>
-            <a:r>
-              <a:rPr lang="en-US" dirty="0"/>
-              <a:t> Venv in a bad state? Delete the .venv folder and make it again. Nothing else is lost.</a:t>
+              <a:rPr lang="en-US" i="1" dirty="0"/>
+              <a:t>[Watch out: venv in a bad state? Delete the .venv folder and make it again. Nothing else is lost.]</a:t>
             </a:r>
             <a:endParaRPr lang="en-US" dirty="0"/>
           </a:p>
@@ -4189,34 +3483,29 @@
           <a:lstStyle/>
           <a:p>
             <a:r>
-              <a:rPr lang="en-US" b="1" dirty="0"/>
-              <a:t>POINT:</a:t>
-            </a:r>
-            <a:r>
               <a:rPr lang="en-US" dirty="0"/>
-              <a:t> venv makes the folder, activate switches this terminal to it, pip install fills it from a shopping list, requirements.txt.</a:t>
+              <a:t>Three commands, three different jobs. The first, venv, makes the folder. The second, activate, switches this terminal over to it, which is why your prompt starts showing (.venv). The third, pip install, fills it from a shopping list, the file requirements.txt.</a:t>
             </a:r>
             <a:endParaRPr lang="en-US" dirty="0"/>
           </a:p>
           <a:p>
             <a:r>
-              <a:rPr lang="en-US" b="1" dirty="0"/>
-              <a:t>SAY:</a:t>
-            </a:r>
-            <a:r>
               <a:rPr lang="en-US" dirty="0"/>
-              <a:t> "On Windows we use py, the Python launcher, because plain python often isn't on the PATH."</a:t>
+              <a:t>One thing catches everyone: activating only applies to the terminal you're in. Open a new terminal and you have to activate again. On Windows we type py rather than python. That's the Python launcher, and we use it because plain python often isn't on the PATH.</a:t>
             </a:r>
             <a:endParaRPr lang="en-US" dirty="0"/>
           </a:p>
           <a:p>
             <a:r>
-              <a:rPr lang="en-US" b="1" dirty="0"/>
-              <a:t>IF ASKED:</a:t>
-            </a:r>
-            <a:r>
-              <a:rPr lang="en-US" dirty="0"/>
-              <a:t> The course gets its own venv and a much bigger list in step 08.</a:t>
+              <a:rPr lang="en-US" i="1" dirty="0"/>
+              <a:t>[Watch out: PowerShell says "running scripts is disabled"? The fix is on the slide, and you run it once.]</a:t>
+            </a:r>
+            <a:endParaRPr lang="en-US" dirty="0"/>
+          </a:p>
+          <a:p>
+            <a:r>
+              <a:rPr lang="en-US" i="1" dirty="0"/>
+              <a:t>[If asked: the course gets its own venv and a much bigger list in step 08.]</a:t>
             </a:r>
             <a:endParaRPr lang="en-US" dirty="0"/>
           </a:p>
@@ -4303,34 +3592,15 @@
           <a:lstStyle/>
           <a:p>
             <a:r>
-              <a:rPr lang="en-US" b="1" dirty="0"/>
-              <a:t>POINT:</a:t>
-            </a:r>
-            <a:r>
               <a:rPr lang="en-US" dirty="0"/>
-              <a:t> Same command, different Python. The second run, without activating, is where it clicks.</a:t>
+              <a:t>Here's the first thing to try. Run where_am_i.py and it tells you which Python is running, whether a venv is active, and whether the four packages the kit needs are installed. Then do the part that makes it click: open a second terminal, don't activate, and run the same command. You get a different Python and missing packages. Same command, different Python, and the only difference is one activate. If you're following along, take three minutes now.</a:t>
             </a:r>
             <a:endParaRPr lang="en-US" dirty="0"/>
           </a:p>
           <a:p>
             <a:r>
-              <a:rPr lang="en-US" b="1" dirty="0"/>
-              <a:t>DO:</a:t>
-            </a:r>
-            <a:r>
-              <a:rPr lang="en-US" dirty="0"/>
-              <a:t> Give them three minutes if they're following along.</a:t>
-            </a:r>
-            <a:endParaRPr lang="en-US" dirty="0"/>
-          </a:p>
-          <a:p>
-            <a:r>
-              <a:rPr lang="en-US" b="1" dirty="0"/>
-              <a:t>WATCH OUT:</a:t>
-            </a:r>
-            <a:r>
-              <a:rPr lang="en-US" dirty="0"/>
-              <a:t> pip installed the packages but the script says MISSING? The venv wasn't active when they ran pip. Activate and install again.</a:t>
+              <a:rPr lang="en-US" i="1" dirty="0"/>
+              <a:t>[Watch out: pip installed the packages but the script says MISSING? The venv wasn't active when they ran pip. Activate and install again.]</a:t>
             </a:r>
             <a:endParaRPr lang="en-US" dirty="0"/>
           </a:p>
@@ -4417,23 +3687,15 @@
           <a:lstStyle/>
           <a:p>
             <a:r>
-              <a:rPr lang="en-US" b="1" dirty="0"/>
-              <a:t>POINT:</a:t>
-            </a:r>
-            <a:r>
               <a:rPr lang="en-US" dirty="0"/>
-              <a:t> Every API call is a request and a response. A call to a language model has exactly this shape: a POST, JSON in, JSON out.</a:t>
+              <a:t>An API is a menu another program offers you. Here's the whole shape of a call. Your code, on the left, sends a request: a method like GET, a URL, some headers, and for a POST a JSON body. The order API on the right sends back a response: a status code and some JSON. Headers are the notes on the envelope, and later that's where the API key, the password for the service, travels.</a:t>
             </a:r>
             <a:endParaRPr lang="en-US" dirty="0"/>
           </a:p>
           <a:p>
             <a:r>
-              <a:rPr lang="en-US" b="1" dirty="0"/>
-              <a:t>SAY:</a:t>
-            </a:r>
-            <a:r>
               <a:rPr lang="en-US" dirty="0"/>
-              <a:t> "An API is a menu another program offers you." Headers are notes on the envelope, like your key.</a:t>
+              <a:t>The reason we spend time on this today is that a call to a language model has exactly this shape. It's a POST, JSON in, JSON out. Nothing magic about the transport.</a:t>
             </a:r>
             <a:endParaRPr lang="en-US" dirty="0"/>
           </a:p>
@@ -4507,7 +3769,7 @@
 
 <file path=ppt/slideLayouts/slideLayout2.xml><?xml version="1.0" encoding="utf-8"?>
 <p:sldLayout xmlns:a="http://schemas.openxmlformats.org/drawingml/2006/main" xmlns:r="http://schemas.openxmlformats.org/officeDocument/2006/relationships" xmlns:p="http://schemas.openxmlformats.org/presentationml/2006/main" preserve="1">
-  <p:cSld name="RESOLVO">
+  <p:cSld name="DESKHAND">
     <p:bg>
       <p:bgPr>
         <a:solidFill>
@@ -5090,7 +4352,7 @@
                 <a:ea typeface="Segoe UI" pitchFamily="34" charset="-122"/>
                 <a:cs typeface="Segoe UI" pitchFamily="34" charset="-120"/>
               </a:rPr>
-              <a:t>Applied AI Engineering · SE Factory · Resolvo</a:t>
+              <a:t>Applied AI Engineering · SE Factory · Deskhand</a:t>
             </a:r>
             <a:endParaRPr lang="en-US" sz="1000" dirty="0"/>
           </a:p>
@@ -5975,7 +5237,7 @@
                 <a:ea typeface="Segoe UI" pitchFamily="34" charset="-122"/>
                 <a:cs typeface="Segoe UI" pitchFamily="34" charset="-120"/>
               </a:rPr>
-              <a:t>Applied AI Engineering · SE Factory · Resolvo</a:t>
+              <a:t>Applied AI Engineering · SE Factory · Deskhand</a:t>
             </a:r>
             <a:endParaRPr lang="en-US" sz="1000" dirty="0"/>
           </a:p>
@@ -6308,8 +5570,7 @@
                 <a:ea typeface="Consolas" pitchFamily="34" charset="-122"/>
                 <a:cs typeface="Consolas" pitchFamily="34" charset="-120"/>
               </a:rPr>
-              <a:t># terminal 1, from prep-kit/ (leave it running)
-</a:t>
+              <a:t># terminal 1, from prep-kit/ (leave it running)</a:t>
             </a:r>
             <a:endParaRPr lang="en-US" sz="1350" dirty="0"/>
           </a:p>
@@ -6329,8 +5590,7 @@
                 <a:ea typeface="Consolas" pitchFamily="34" charset="-122"/>
                 <a:cs typeface="Consolas" pitchFamily="34" charset="-120"/>
               </a:rPr>
-              <a:t>uvicorn app:app --app-dir mock_api --port 9000
-</a:t>
+              <a:t>uvicorn app:app --app-dir mock_api --port 9000</a:t>
             </a:r>
             <a:endParaRPr lang="en-US" sz="1350" dirty="0"/>
           </a:p>
@@ -6350,8 +5610,7 @@
                 <a:ea typeface="Consolas" pitchFamily="34" charset="-122"/>
                 <a:cs typeface="Consolas" pitchFamily="34" charset="-120"/>
               </a:rPr>
-              <a:t>
-</a:t>
+              <a:t> </a:t>
             </a:r>
             <a:endParaRPr lang="en-US" sz="1350" dirty="0"/>
           </a:p>
@@ -6371,8 +5630,7 @@
                 <a:ea typeface="Consolas" pitchFamily="34" charset="-122"/>
                 <a:cs typeface="Consolas" pitchFamily="34" charset="-120"/>
               </a:rPr>
-              <a:t># terminal 2, from prep-kit/
-</a:t>
+              <a:t># terminal 2, from prep-kit/</a:t>
             </a:r>
             <a:endParaRPr lang="en-US" sz="1350" dirty="0"/>
           </a:p>
@@ -6539,7 +5797,7 @@
                 <a:ea typeface="Segoe UI" pitchFamily="34" charset="-122"/>
                 <a:cs typeface="Segoe UI" pitchFamily="34" charset="-120"/>
               </a:rPr>
-              <a:t>Applied AI Engineering · SE Factory · Resolvo</a:t>
+              <a:t>Applied AI Engineering · SE Factory · Deskhand</a:t>
             </a:r>
             <a:endParaRPr lang="en-US" sz="1000" dirty="0"/>
           </a:p>
@@ -6735,7 +5993,7 @@
                 <a:ea typeface="Segoe UI" pitchFamily="34" charset="-122"/>
                 <a:cs typeface="Segoe UI" pitchFamily="34" charset="-120"/>
               </a:rPr>
-              <a:t>Same key, same refund</a:t>
+              <a:t>Sending the same refund twice pays out once</a:t>
             </a:r>
             <a:endParaRPr lang="en-US" sz="3000" dirty="0"/>
           </a:p>
@@ -6750,11 +6008,11 @@
         <p:spPr>
           <a:xfrm>
             <a:off x="777240" y="1577340"/>
-            <a:ext cx="10637215" cy="1948815"/>
+            <a:ext cx="10637215" cy="2185416"/>
           </a:xfrm>
           <a:prstGeom prst="roundRect">
             <a:avLst>
-              <a:gd name="adj" fmla="val 5630"/>
+              <a:gd name="adj" fmla="val 5021"/>
             </a:avLst>
           </a:prstGeom>
           <a:solidFill>
@@ -6777,7 +6035,7 @@
         <p:spPr>
           <a:xfrm>
             <a:off x="960120" y="1687068"/>
-            <a:ext cx="10271455" cy="1765935"/>
+            <a:ext cx="10271455" cy="2002536"/>
           </a:xfrm>
           <a:prstGeom prst="rect">
             <a:avLst/>
@@ -6804,8 +6062,7 @@
                 <a:ea typeface="Consolas" pitchFamily="34" charset="-122"/>
                 <a:cs typeface="Consolas" pitchFamily="34" charset="-120"/>
               </a:rPr>
-              <a:t>=== 3. Issue a refund
-</a:t>
+              <a:t># hello_api.py, blocks 3 and 4, trimmed. The key on the right is set in the code.</a:t>
             </a:r>
             <a:endParaRPr lang="en-US" sz="1350" dirty="0"/>
           </a:p>
@@ -6825,8 +6082,7 @@
                 <a:ea typeface="Consolas" pitchFamily="34" charset="-122"/>
                 <a:cs typeface="Consolas" pitchFamily="34" charset="-120"/>
               </a:rPr>
-              <a:t>POST http://localhost:9000/refunds        Idempotency-Key: prep-kit-1f2a9c3e
-</a:t>
+              <a:t>=== 3. Issue a refund</a:t>
             </a:r>
             <a:endParaRPr lang="en-US" sz="1350" dirty="0"/>
           </a:p>
@@ -6846,8 +6102,7 @@
                 <a:ea typeface="Consolas" pitchFamily="34" charset="-122"/>
                 <a:cs typeface="Consolas" pitchFamily="34" charset="-120"/>
               </a:rPr>
-              <a:t>-&gt; status 200 OK      {"refund_id": "R-26762c6f", "amount_usd": 79.99}
-</a:t>
+              <a:t>POST http://localhost:9000/refunds        Idempotency-Key: prep-kit-1f2a9c3e</a:t>
             </a:r>
             <a:endParaRPr lang="en-US" sz="1350" dirty="0"/>
           </a:p>
@@ -6867,8 +6122,7 @@
                 <a:ea typeface="Consolas" pitchFamily="34" charset="-122"/>
                 <a:cs typeface="Consolas" pitchFamily="34" charset="-120"/>
               </a:rPr>
-              <a:t>
-</a:t>
+              <a:t>-&gt; status 200 OK      {"refund_id": "R-26762c6f", "amount_usd": 79.99}</a:t>
             </a:r>
             <a:endParaRPr lang="en-US" sz="1350" dirty="0"/>
           </a:p>
@@ -6888,8 +6142,7 @@
                 <a:ea typeface="Consolas" pitchFamily="34" charset="-122"/>
                 <a:cs typeface="Consolas" pitchFamily="34" charset="-120"/>
               </a:rPr>
-              <a:t>=== 4. Retry with the SAME key
-</a:t>
+              <a:t> </a:t>
             </a:r>
             <a:endParaRPr lang="en-US" sz="1350" dirty="0"/>
           </a:p>
@@ -6909,8 +6162,7 @@
                 <a:ea typeface="Consolas" pitchFamily="34" charset="-122"/>
                 <a:cs typeface="Consolas" pitchFamily="34" charset="-120"/>
               </a:rPr>
-              <a:t>POST http://localhost:9000/refunds        Idempotency-Key: prep-kit-1f2a9c3e
-</a:t>
+              <a:t>=== 4. Retry with the SAME key</a:t>
             </a:r>
             <a:endParaRPr lang="en-US" sz="1350" dirty="0"/>
           </a:p>
@@ -6930,6 +6182,26 @@
                 <a:ea typeface="Consolas" pitchFamily="34" charset="-122"/>
                 <a:cs typeface="Consolas" pitchFamily="34" charset="-120"/>
               </a:rPr>
+              <a:t>POST http://localhost:9000/refunds        Idempotency-Key: prep-kit-1f2a9c3e</a:t>
+            </a:r>
+            <a:endParaRPr lang="en-US" sz="1350" dirty="0"/>
+          </a:p>
+          <a:p>
+            <a:pPr indent="0" marL="0">
+              <a:lnSpc>
+                <a:spcPct val="115000"/>
+              </a:lnSpc>
+              <a:buNone/>
+            </a:pPr>
+            <a:r>
+              <a:rPr lang="en-US" sz="1350" dirty="0">
+                <a:solidFill>
+                  <a:srgbClr val="D8FFF0"/>
+                </a:solidFill>
+                <a:latin typeface="Consolas" pitchFamily="34" charset="0"/>
+                <a:ea typeface="Consolas" pitchFamily="34" charset="-122"/>
+                <a:cs typeface="Consolas" pitchFamily="34" charset="-120"/>
+              </a:rPr>
               <a:t>-&gt; status 200 OK      {"refund_id": "R-26762c6f", "amount_usd": 79.99}</a:t>
             </a:r>
             <a:endParaRPr lang="en-US" sz="1350" dirty="0"/>
@@ -6944,7 +6216,7 @@
         </p:nvSpPr>
         <p:spPr>
           <a:xfrm>
-            <a:off x="777240" y="3654171"/>
+            <a:off x="777240" y="3890772"/>
             <a:ext cx="10637215" cy="868375"/>
           </a:xfrm>
           <a:prstGeom prst="roundRect">
@@ -6971,7 +6243,7 @@
         </p:nvSpPr>
         <p:spPr>
           <a:xfrm>
-            <a:off x="777240" y="3654171"/>
+            <a:off x="777240" y="3890772"/>
             <a:ext cx="82296" cy="868375"/>
           </a:xfrm>
           <a:prstGeom prst="rect">
@@ -6996,7 +6268,7 @@
         </p:nvSpPr>
         <p:spPr>
           <a:xfrm>
-            <a:off x="1051560" y="3763899"/>
+            <a:off x="1051560" y="4000500"/>
             <a:ext cx="10225735" cy="237744"/>
           </a:xfrm>
           <a:prstGeom prst="rect">
@@ -7035,7 +6307,7 @@
         </p:nvSpPr>
         <p:spPr>
           <a:xfrm>
-            <a:off x="1051560" y="4001643"/>
+            <a:off x="1051560" y="4238244"/>
             <a:ext cx="10225735" cy="356311"/>
           </a:xfrm>
           <a:prstGeom prst="rect">
@@ -7074,7 +6346,7 @@
         </p:nvSpPr>
         <p:spPr>
           <a:xfrm>
-            <a:off x="777240" y="4650562"/>
+            <a:off x="777240" y="4887163"/>
             <a:ext cx="10637215" cy="650748"/>
           </a:xfrm>
           <a:prstGeom prst="rect">
@@ -7194,7 +6466,7 @@
                 <a:ea typeface="Segoe UI" pitchFamily="34" charset="-122"/>
                 <a:cs typeface="Segoe UI" pitchFamily="34" charset="-120"/>
               </a:rPr>
-              <a:t>Applied AI Engineering · SE Factory · Resolvo</a:t>
+              <a:t>Applied AI Engineering · SE Factory · Deskhand</a:t>
             </a:r>
             <a:endParaRPr lang="en-US" sz="1000" dirty="0"/>
           </a:p>
@@ -7458,7 +6730,7 @@
                 <a:ea typeface="Segoe UI" pitchFamily="34" charset="-122"/>
                 <a:cs typeface="Segoe UI" pitchFamily="34" charset="-120"/>
               </a:rPr>
-              <a:t>APIs</a:t>
+              <a:t>APIs and venvs</a:t>
             </a:r>
             <a:endParaRPr lang="en-US" sz="3000" dirty="0"/>
           </a:p>
@@ -7530,7 +6802,7 @@
                 <a:ea typeface="Segoe UI" pitchFamily="34" charset="-122"/>
                 <a:cs typeface="Segoe UI" pitchFamily="34" charset="-120"/>
               </a:rPr>
-              <a:t>. Is the API broken?</a:t>
+              <a:t>. What is the 404 telling you?</a:t>
             </a:r>
             <a:endParaRPr lang="en-US" sz="2000" dirty="0"/>
           </a:p>
@@ -7669,7 +6941,7 @@
                 <a:ea typeface="Segoe UI" pitchFamily="34" charset="-122"/>
                 <a:cs typeface="Segoe UI" pitchFamily="34" charset="-120"/>
               </a:rPr>
-              <a:t>Applied AI Engineering · SE Factory · Resolvo</a:t>
+              <a:t>Applied AI Engineering · SE Factory · Deskhand</a:t>
             </a:r>
             <a:endParaRPr lang="en-US" sz="1000" dirty="0"/>
           </a:p>
@@ -8001,8 +7273,7 @@
                 <a:ea typeface="Consolas" pitchFamily="34" charset="-122"/>
                 <a:cs typeface="Consolas" pitchFamily="34" charset="-120"/>
               </a:rPr>
-              <a:t>GEMINI_API_KEY=AIza...
-</a:t>
+              <a:t>GEMINI_API_KEY=AIza...</a:t>
             </a:r>
             <a:endParaRPr lang="en-US" sz="1350" dirty="0"/>
           </a:p>
@@ -8157,11 +7428,11 @@
         <p:spPr>
           <a:xfrm>
             <a:off x="6278728" y="2091690"/>
-            <a:ext cx="5135728" cy="765810"/>
+            <a:ext cx="5135728" cy="529209"/>
           </a:xfrm>
           <a:prstGeom prst="roundRect">
             <a:avLst>
-              <a:gd name="adj" fmla="val 14328"/>
+              <a:gd name="adj" fmla="val 20734"/>
             </a:avLst>
           </a:prstGeom>
           <a:solidFill>
@@ -8184,7 +7455,7 @@
         <p:spPr>
           <a:xfrm>
             <a:off x="6461608" y="2201418"/>
-            <a:ext cx="4769968" cy="582930"/>
+            <a:ext cx="4769968" cy="346329"/>
           </a:xfrm>
           <a:prstGeom prst="rect">
             <a:avLst/>
@@ -8211,20 +7482,52 @@
                 <a:ea typeface="Consolas" pitchFamily="34" charset="-122"/>
                 <a:cs typeface="Consolas" pitchFamily="34" charset="-120"/>
               </a:rPr>
-              <a:t># Secrets
-</a:t>
+              <a:t>.env</a:t>
             </a:r>
             <a:endParaRPr lang="en-US" sz="1350" dirty="0"/>
           </a:p>
-          <a:p>
-            <a:pPr indent="0" marL="0">
-              <a:lnSpc>
-                <a:spcPct val="115000"/>
-              </a:lnSpc>
-              <a:buNone/>
-            </a:pPr>
-            <a:r>
-              <a:rPr lang="en-US" sz="1350" dirty="0">
+        </p:txBody>
+      </p:sp>
+      <p:sp>
+        <p:nvSpPr>
+          <p:cNvPr id="13" name="Text 11"/>
+          <p:cNvSpPr/>
+          <p:nvPr/>
+        </p:nvSpPr>
+        <p:spPr>
+          <a:xfrm>
+            <a:off x="6278728" y="2712339"/>
+            <a:ext cx="5135728" cy="948690"/>
+          </a:xfrm>
+          <a:prstGeom prst="rect">
+            <a:avLst/>
+          </a:prstGeom>
+          <a:noFill/>
+          <a:ln/>
+        </p:spPr>
+        <p:txBody>
+          <a:bodyPr wrap="square" lIns="0" tIns="0" rIns="0" bIns="0" rtlCol="0" anchor="t"/>
+          <a:lstStyle/>
+          <a:p>
+            <a:pPr algn="l" indent="0" marL="0">
+              <a:buNone/>
+            </a:pPr>
+            <a:r>
+              <a:rPr lang="en-US" sz="1700" dirty="0">
+                <a:solidFill>
+                  <a:srgbClr val="EEF6F3"/>
+                </a:solidFill>
+                <a:latin typeface="Segoe UI" pitchFamily="34" charset="0"/>
+                <a:ea typeface="Segoe UI" pitchFamily="34" charset="-122"/>
+                <a:cs typeface="Segoe UI" pitchFamily="34" charset="-120"/>
+              </a:rPr>
+              <a:t>Git never sees </a:t>
+            </a:r>
+            <a:pPr algn="l" indent="0" marL="0">
+              <a:buNone/>
+            </a:pPr>
+            <a:r>
+              <a:rPr lang="en-US" sz="1500" dirty="0">
                 <a:solidFill>
                   <a:srgbClr val="D8FFF0"/>
                 </a:solidFill>
@@ -8234,31 +7537,6 @@
               </a:rPr>
               <a:t>.env</a:t>
             </a:r>
-            <a:endParaRPr lang="en-US" sz="1350" dirty="0"/>
-          </a:p>
-        </p:txBody>
-      </p:sp>
-      <p:sp>
-        <p:nvSpPr>
-          <p:cNvPr id="13" name="Text 11"/>
-          <p:cNvSpPr/>
-          <p:nvPr/>
-        </p:nvSpPr>
-        <p:spPr>
-          <a:xfrm>
-            <a:off x="6278728" y="2948940"/>
-            <a:ext cx="5135728" cy="948690"/>
-          </a:xfrm>
-          <a:prstGeom prst="rect">
-            <a:avLst/>
-          </a:prstGeom>
-          <a:noFill/>
-          <a:ln/>
-        </p:spPr>
-        <p:txBody>
-          <a:bodyPr wrap="square" lIns="0" tIns="0" rIns="0" bIns="0" rtlCol="0" anchor="t"/>
-          <a:lstStyle/>
-          <a:p>
             <a:pPr algn="l" indent="0" marL="0">
               <a:buNone/>
             </a:pPr>
@@ -8271,7 +7549,7 @@
                 <a:ea typeface="Segoe UI" pitchFamily="34" charset="-122"/>
                 <a:cs typeface="Segoe UI" pitchFamily="34" charset="-120"/>
               </a:rPr>
-              <a:t>Git never sees </a:t>
+              <a:t>, so you can't commit it by accident. The repo ships </a:t>
             </a:r>
             <a:pPr algn="l" indent="0" marL="0">
               <a:buNone/>
@@ -8285,7 +7563,7 @@
                 <a:ea typeface="Consolas" pitchFamily="34" charset="-122"/>
                 <a:cs typeface="Consolas" pitchFamily="34" charset="-120"/>
               </a:rPr>
-              <a:t>.env</a:t>
+              <a:t>.env.example</a:t>
             </a:r>
             <a:pPr algn="l" indent="0" marL="0">
               <a:buNone/>
@@ -8299,34 +7577,6 @@
                 <a:ea typeface="Segoe UI" pitchFamily="34" charset="-122"/>
                 <a:cs typeface="Segoe UI" pitchFamily="34" charset="-120"/>
               </a:rPr>
-              <a:t>, so you can't commit it by accident. The repo ships </a:t>
-            </a:r>
-            <a:pPr algn="l" indent="0" marL="0">
-              <a:buNone/>
-            </a:pPr>
-            <a:r>
-              <a:rPr lang="en-US" sz="1500" dirty="0">
-                <a:solidFill>
-                  <a:srgbClr val="D8FFF0"/>
-                </a:solidFill>
-                <a:latin typeface="Consolas" pitchFamily="34" charset="0"/>
-                <a:ea typeface="Consolas" pitchFamily="34" charset="-122"/>
-                <a:cs typeface="Consolas" pitchFamily="34" charset="-120"/>
-              </a:rPr>
-              <a:t>.env.example</a:t>
-            </a:r>
-            <a:pPr algn="l" indent="0" marL="0">
-              <a:buNone/>
-            </a:pPr>
-            <a:r>
-              <a:rPr lang="en-US" sz="1700" dirty="0">
-                <a:solidFill>
-                  <a:srgbClr val="EEF6F3"/>
-                </a:solidFill>
-                <a:latin typeface="Segoe UI" pitchFamily="34" charset="0"/>
-                <a:ea typeface="Segoe UI" pitchFamily="34" charset="-122"/>
-                <a:cs typeface="Segoe UI" pitchFamily="34" charset="-120"/>
-              </a:rPr>
               <a:t> with the values empty.</a:t>
             </a:r>
             <a:endParaRPr lang="en-US" sz="1700" dirty="0"/>
@@ -8341,7 +7591,7 @@
         </p:nvSpPr>
         <p:spPr>
           <a:xfrm>
-            <a:off x="777240" y="4117086"/>
+            <a:off x="777240" y="3880485"/>
             <a:ext cx="10637215" cy="1169822"/>
           </a:xfrm>
           <a:prstGeom prst="roundRect">
@@ -8368,7 +7618,7 @@
         </p:nvSpPr>
         <p:spPr>
           <a:xfrm>
-            <a:off x="777240" y="4117086"/>
+            <a:off x="777240" y="3880485"/>
             <a:ext cx="82296" cy="1169822"/>
           </a:xfrm>
           <a:prstGeom prst="rect">
@@ -8393,7 +7643,7 @@
         </p:nvSpPr>
         <p:spPr>
           <a:xfrm>
-            <a:off x="1051560" y="4226814"/>
+            <a:off x="1051560" y="3990213"/>
             <a:ext cx="10225735" cy="237744"/>
           </a:xfrm>
           <a:prstGeom prst="rect">
@@ -8432,7 +7682,7 @@
         </p:nvSpPr>
         <p:spPr>
           <a:xfrm>
-            <a:off x="1051560" y="4464558"/>
+            <a:off x="1051560" y="4227957"/>
             <a:ext cx="10225735" cy="657758"/>
           </a:xfrm>
           <a:prstGeom prst="rect">
@@ -8496,7 +7746,7 @@
                 <a:ea typeface="Segoe UI" pitchFamily="34" charset="-122"/>
                 <a:cs typeface="Segoe UI" pitchFamily="34" charset="-120"/>
               </a:rPr>
-              <a:t>Applied AI Engineering · SE Factory · Resolvo</a:t>
+              <a:t>Applied AI Engineering · SE Factory · Deskhand</a:t>
             </a:r>
             <a:endParaRPr lang="en-US" sz="1000" dirty="0"/>
           </a:p>
@@ -9030,7 +8280,7 @@
                 <a:ea typeface="Consolas" pitchFamily="34" charset="-122"/>
                 <a:cs typeface="Consolas" pitchFamily="34" charset="-120"/>
               </a:rPr>
-              <a:t>resolvo-workshop/.env</a:t>
+              <a:t>deskhand-workshop/.env</a:t>
             </a:r>
             <a:pPr algn="l" indent="0" marL="0">
               <a:buNone/>
@@ -9083,7 +8333,7 @@
                 <a:ea typeface="Segoe UI" pitchFamily="34" charset="-122"/>
                 <a:cs typeface="Segoe UI" pitchFamily="34" charset="-120"/>
               </a:rPr>
-              <a:t>Applied AI Engineering · SE Factory · Resolvo</a:t>
+              <a:t>Applied AI Engineering · SE Factory · Deskhand</a:t>
             </a:r>
             <a:endParaRPr lang="en-US" sz="1000" dirty="0"/>
           </a:p>
@@ -9255,7 +8505,7 @@
         <p:spPr>
           <a:xfrm>
             <a:off x="777240" y="841248"/>
-            <a:ext cx="10637215" cy="571500"/>
+            <a:ext cx="10637215" cy="1097280"/>
           </a:xfrm>
           <a:prstGeom prst="rect">
             <a:avLst/>
@@ -9279,7 +8529,7 @@
                 <a:ea typeface="Segoe UI" pitchFamily="34" charset="-122"/>
                 <a:cs typeface="Segoe UI" pitchFamily="34" charset="-120"/>
               </a:rPr>
-              <a:t>Where LLMs came from, in four steps</a:t>
+              <a:t>Where LLMs (large language models) came from, in four steps</a:t>
             </a:r>
             <a:endParaRPr lang="en-US" sz="3000" dirty="0"/>
           </a:p>
@@ -9293,8 +8543,8 @@
         </p:nvSpPr>
         <p:spPr>
           <a:xfrm>
-            <a:off x="777240" y="1577340"/>
-            <a:ext cx="2487854" cy="2626271"/>
+            <a:off x="777240" y="2103120"/>
+            <a:ext cx="2487854" cy="2939110"/>
           </a:xfrm>
           <a:prstGeom prst="roundRect">
             <a:avLst>
@@ -9320,7 +8570,7 @@
         </p:nvSpPr>
         <p:spPr>
           <a:xfrm>
-            <a:off x="777240" y="1577340"/>
+            <a:off x="777240" y="2103120"/>
             <a:ext cx="2487854" cy="64008"/>
           </a:xfrm>
           <a:prstGeom prst="rect">
@@ -9345,8 +8595,8 @@
         </p:nvSpPr>
         <p:spPr>
           <a:xfrm>
-            <a:off x="905256" y="1769364"/>
-            <a:ext cx="2231822" cy="367703"/>
+            <a:off x="905256" y="2295144"/>
+            <a:ext cx="2231822" cy="680542"/>
           </a:xfrm>
           <a:prstGeom prst="rect">
             <a:avLst/>
@@ -9370,7 +8620,7 @@
                 <a:ea typeface="Segoe UI" pitchFamily="34" charset="-122"/>
                 <a:cs typeface="Segoe UI" pitchFamily="34" charset="-120"/>
               </a:rPr>
-              <a:t>Classic ML</a:t>
+              <a:t>Classic machine learning</a:t>
             </a:r>
             <a:endParaRPr lang="en-US" sz="1785" dirty="0"/>
           </a:p>
@@ -9384,7 +8634,7 @@
         </p:nvSpPr>
         <p:spPr>
           <a:xfrm>
-            <a:off x="905256" y="2173643"/>
+            <a:off x="905256" y="3012262"/>
             <a:ext cx="2231822" cy="1176528"/>
           </a:xfrm>
           <a:prstGeom prst="rect">
@@ -9423,7 +8673,7 @@
         </p:nvSpPr>
         <p:spPr>
           <a:xfrm>
-            <a:off x="905256" y="3405035"/>
+            <a:off x="905256" y="4243654"/>
             <a:ext cx="2231822" cy="615696"/>
           </a:xfrm>
           <a:prstGeom prst="rect">
@@ -9462,8 +8712,8 @@
         </p:nvSpPr>
         <p:spPr>
           <a:xfrm>
-            <a:off x="3493694" y="1577340"/>
-            <a:ext cx="2487854" cy="2626271"/>
+            <a:off x="3493694" y="2103120"/>
+            <a:ext cx="2487854" cy="2939110"/>
           </a:xfrm>
           <a:prstGeom prst="roundRect">
             <a:avLst>
@@ -9489,7 +8739,7 @@
         </p:nvSpPr>
         <p:spPr>
           <a:xfrm>
-            <a:off x="3493694" y="1577340"/>
+            <a:off x="3493694" y="2103120"/>
             <a:ext cx="2487854" cy="64008"/>
           </a:xfrm>
           <a:prstGeom prst="rect">
@@ -9514,7 +8764,7 @@
         </p:nvSpPr>
         <p:spPr>
           <a:xfrm>
-            <a:off x="3621710" y="1769364"/>
+            <a:off x="3621710" y="2295144"/>
             <a:ext cx="2231822" cy="367703"/>
           </a:xfrm>
           <a:prstGeom prst="rect">
@@ -9553,7 +8803,7 @@
         </p:nvSpPr>
         <p:spPr>
           <a:xfrm>
-            <a:off x="3621710" y="2173643"/>
+            <a:off x="3621710" y="2699423"/>
             <a:ext cx="2231822" cy="896112"/>
           </a:xfrm>
           <a:prstGeom prst="rect">
@@ -9592,7 +8842,7 @@
         </p:nvSpPr>
         <p:spPr>
           <a:xfrm>
-            <a:off x="3621710" y="3124619"/>
+            <a:off x="3621710" y="3650399"/>
             <a:ext cx="2231822" cy="615696"/>
           </a:xfrm>
           <a:prstGeom prst="rect">
@@ -9631,8 +8881,8 @@
         </p:nvSpPr>
         <p:spPr>
           <a:xfrm>
-            <a:off x="6210148" y="1577340"/>
-            <a:ext cx="2487854" cy="2626271"/>
+            <a:off x="6210148" y="2103120"/>
+            <a:ext cx="2487854" cy="2939110"/>
           </a:xfrm>
           <a:prstGeom prst="roundRect">
             <a:avLst>
@@ -9658,7 +8908,7 @@
         </p:nvSpPr>
         <p:spPr>
           <a:xfrm>
-            <a:off x="6210148" y="1577340"/>
+            <a:off x="6210148" y="2103120"/>
             <a:ext cx="2487854" cy="64008"/>
           </a:xfrm>
           <a:prstGeom prst="rect">
@@ -9683,7 +8933,7 @@
         </p:nvSpPr>
         <p:spPr>
           <a:xfrm>
-            <a:off x="6338164" y="1769364"/>
+            <a:off x="6338164" y="2295144"/>
             <a:ext cx="2231822" cy="367703"/>
           </a:xfrm>
           <a:prstGeom prst="rect">
@@ -9722,7 +8972,7 @@
         </p:nvSpPr>
         <p:spPr>
           <a:xfrm>
-            <a:off x="6338164" y="2173643"/>
+            <a:off x="6338164" y="2699423"/>
             <a:ext cx="2231822" cy="896112"/>
           </a:xfrm>
           <a:prstGeom prst="rect">
@@ -9761,7 +9011,7 @@
         </p:nvSpPr>
         <p:spPr>
           <a:xfrm>
-            <a:off x="6338164" y="3124619"/>
+            <a:off x="6338164" y="3650399"/>
             <a:ext cx="2231822" cy="896112"/>
           </a:xfrm>
           <a:prstGeom prst="rect">
@@ -9828,8 +9078,8 @@
         </p:nvSpPr>
         <p:spPr>
           <a:xfrm>
-            <a:off x="8926601" y="1577340"/>
-            <a:ext cx="2487854" cy="2626271"/>
+            <a:off x="8926601" y="2103120"/>
+            <a:ext cx="2487854" cy="2939110"/>
           </a:xfrm>
           <a:prstGeom prst="roundRect">
             <a:avLst>
@@ -9855,7 +9105,7 @@
         </p:nvSpPr>
         <p:spPr>
           <a:xfrm>
-            <a:off x="8926601" y="1577340"/>
+            <a:off x="8926601" y="2103120"/>
             <a:ext cx="2487854" cy="64008"/>
           </a:xfrm>
           <a:prstGeom prst="rect">
@@ -9880,7 +9130,7 @@
         </p:nvSpPr>
         <p:spPr>
           <a:xfrm>
-            <a:off x="9054617" y="1769364"/>
+            <a:off x="9054617" y="2295144"/>
             <a:ext cx="2231822" cy="367703"/>
           </a:xfrm>
           <a:prstGeom prst="rect">
@@ -9919,7 +9169,7 @@
         </p:nvSpPr>
         <p:spPr>
           <a:xfrm>
-            <a:off x="9054617" y="2173643"/>
+            <a:off x="9054617" y="2699423"/>
             <a:ext cx="2231822" cy="896112"/>
           </a:xfrm>
           <a:prstGeom prst="rect">
@@ -9958,7 +9208,7 @@
         </p:nvSpPr>
         <p:spPr>
           <a:xfrm>
-            <a:off x="9054617" y="3124619"/>
+            <a:off x="9054617" y="3650399"/>
             <a:ext cx="2231822" cy="335280"/>
           </a:xfrm>
           <a:prstGeom prst="rect">
@@ -9997,7 +9247,7 @@
         </p:nvSpPr>
         <p:spPr>
           <a:xfrm>
-            <a:off x="777240" y="4331627"/>
+            <a:off x="777240" y="5170246"/>
             <a:ext cx="10637215" cy="868375"/>
           </a:xfrm>
           <a:prstGeom prst="roundRect">
@@ -10024,7 +9274,7 @@
         </p:nvSpPr>
         <p:spPr>
           <a:xfrm>
-            <a:off x="777240" y="4331627"/>
+            <a:off x="777240" y="5170246"/>
             <a:ext cx="82296" cy="868375"/>
           </a:xfrm>
           <a:prstGeom prst="rect">
@@ -10049,7 +9299,7 @@
         </p:nvSpPr>
         <p:spPr>
           <a:xfrm>
-            <a:off x="1051560" y="4441355"/>
+            <a:off x="1051560" y="5279974"/>
             <a:ext cx="10225735" cy="237744"/>
           </a:xfrm>
           <a:prstGeom prst="rect">
@@ -10088,7 +9338,7 @@
         </p:nvSpPr>
         <p:spPr>
           <a:xfrm>
-            <a:off x="1051560" y="4679099"/>
+            <a:off x="1051560" y="5517718"/>
             <a:ext cx="10225735" cy="356311"/>
           </a:xfrm>
           <a:prstGeom prst="rect">
@@ -10113,7 +9363,7 @@
                 <a:ea typeface="Segoe UI" pitchFamily="34" charset="-122"/>
                 <a:cs typeface="Segoe UI" pitchFamily="34" charset="-120"/>
               </a:rPr>
-              <a:t>Behind the API is a </a:t>
+              <a:t>Behind the API is a model that </a:t>
             </a:r>
             <a:pPr algn="l" indent="0" marL="0">
               <a:buNone/>
@@ -10127,7 +9377,7 @@
                 <a:ea typeface="Segoe UI" pitchFamily="34" charset="-122"/>
                 <a:cs typeface="Segoe UI" pitchFamily="34" charset="-120"/>
               </a:rPr>
-              <a:t>text predictor trained to be helpful</a:t>
+              <a:t>predicts the next bit of text</a:t>
             </a:r>
             <a:pPr algn="l" indent="0" marL="0">
               <a:buNone/>
@@ -10141,7 +9391,7 @@
                 <a:ea typeface="Segoe UI" pitchFamily="34" charset="-122"/>
                 <a:cs typeface="Segoe UI" pitchFamily="34" charset="-120"/>
               </a:rPr>
-              <a:t>. Session 1 starts from exactly that.</a:t>
+              <a:t>, trained to be helpful.</a:t>
             </a:r>
             <a:endParaRPr lang="en-US" sz="1720" dirty="0"/>
           </a:p>
@@ -10180,7 +9430,7 @@
                 <a:ea typeface="Segoe UI" pitchFamily="34" charset="-122"/>
                 <a:cs typeface="Segoe UI" pitchFamily="34" charset="-120"/>
               </a:rPr>
-              <a:t>Applied AI Engineering · SE Factory · Resolvo</a:t>
+              <a:t>Applied AI Engineering · SE Factory · Deskhand</a:t>
             </a:r>
             <a:endParaRPr lang="en-US" sz="1000" dirty="0"/>
           </a:p>
@@ -10430,11 +9680,11 @@
         <p:spPr>
           <a:xfrm>
             <a:off x="777240" y="2091690"/>
-            <a:ext cx="5135728" cy="2658618"/>
+            <a:ext cx="5135728" cy="2422017"/>
           </a:xfrm>
           <a:prstGeom prst="roundRect">
             <a:avLst>
-              <a:gd name="adj" fmla="val 4127"/>
+              <a:gd name="adj" fmla="val 4530"/>
             </a:avLst>
           </a:prstGeom>
           <a:solidFill>
@@ -10457,7 +9707,7 @@
         <p:spPr>
           <a:xfrm>
             <a:off x="960120" y="2201418"/>
-            <a:ext cx="4769968" cy="2475738"/>
+            <a:ext cx="4769968" cy="2239137"/>
           </a:xfrm>
           <a:prstGeom prst="rect">
             <a:avLst/>
@@ -10484,8 +9734,7 @@
                 <a:ea typeface="Consolas" pitchFamily="34" charset="-122"/>
                 <a:cs typeface="Consolas" pitchFamily="34" charset="-120"/>
               </a:rPr>
-              <a:t>{
-</a:t>
+              <a:t>{</a:t>
             </a:r>
             <a:endParaRPr lang="en-US" sz="1350" dirty="0"/>
           </a:p>
@@ -10505,8 +9754,7 @@
                 <a:ea typeface="Consolas" pitchFamily="34" charset="-122"/>
                 <a:cs typeface="Consolas" pitchFamily="34" charset="-120"/>
               </a:rPr>
-              <a:t>  "model": "gemini-3.5-flash-lite",
-</a:t>
+              <a:t>  "model": "gemini-3.5-flash-lite",</a:t>
             </a:r>
             <a:endParaRPr lang="en-US" sz="1350" dirty="0"/>
           </a:p>
@@ -10526,8 +9774,7 @@
                 <a:ea typeface="Consolas" pitchFamily="34" charset="-122"/>
                 <a:cs typeface="Consolas" pitchFamily="34" charset="-120"/>
               </a:rPr>
-              <a:t>  "messages": [
-</a:t>
+              <a:t>  "messages": [</a:t>
             </a:r>
             <a:endParaRPr lang="en-US" sz="1350" dirty="0"/>
           </a:p>
@@ -10547,8 +9794,7 @@
                 <a:ea typeface="Consolas" pitchFamily="34" charset="-122"/>
                 <a:cs typeface="Consolas" pitchFamily="34" charset="-120"/>
               </a:rPr>
-              <a:t>    {"role": "system",
-</a:t>
+              <a:t>    {"role": "system",</a:t>
             </a:r>
             <a:endParaRPr lang="en-US" sz="1350" dirty="0"/>
           </a:p>
@@ -10568,8 +9814,7 @@
                 <a:ea typeface="Consolas" pitchFamily="34" charset="-122"/>
                 <a:cs typeface="Consolas" pitchFamily="34" charset="-120"/>
               </a:rPr>
-              <a:t>     "content": "Keep answers short."},
-</a:t>
+              <a:t>     "content": "Keep answers short."},</a:t>
             </a:r>
             <a:endParaRPr lang="en-US" sz="1350" dirty="0"/>
           </a:p>
@@ -10589,8 +9834,7 @@
                 <a:ea typeface="Consolas" pitchFamily="34" charset="-122"/>
                 <a:cs typeface="Consolas" pitchFamily="34" charset="-120"/>
               </a:rPr>
-              <a:t>    {"role": "user",
-</a:t>
+              <a:t>    {"role": "user",</a:t>
             </a:r>
             <a:endParaRPr lang="en-US" sz="1350" dirty="0"/>
           </a:p>
@@ -10610,8 +9854,7 @@
                 <a:ea typeface="Consolas" pitchFamily="34" charset="-122"/>
                 <a:cs typeface="Consolas" pitchFamily="34" charset="-120"/>
               </a:rPr>
-              <a:t>     "content": "What is an API?"}
-</a:t>
+              <a:t>     "content": "What is an API?"}</a:t>
             </a:r>
             <a:endParaRPr lang="en-US" sz="1350" dirty="0"/>
           </a:p>
@@ -10631,8 +9874,7 @@
                 <a:ea typeface="Consolas" pitchFamily="34" charset="-122"/>
                 <a:cs typeface="Consolas" pitchFamily="34" charset="-120"/>
               </a:rPr>
-              <a:t>  ],
-</a:t>
+              <a:t>  ]</a:t>
             </a:r>
             <a:endParaRPr lang="en-US" sz="1350" dirty="0"/>
           </a:p>
@@ -10652,27 +9894,6 @@
                 <a:ea typeface="Consolas" pitchFamily="34" charset="-122"/>
                 <a:cs typeface="Consolas" pitchFamily="34" charset="-120"/>
               </a:rPr>
-              <a:t>  "temperature": 0.2
-</a:t>
-            </a:r>
-            <a:endParaRPr lang="en-US" sz="1350" dirty="0"/>
-          </a:p>
-          <a:p>
-            <a:pPr indent="0" marL="0">
-              <a:lnSpc>
-                <a:spcPct val="115000"/>
-              </a:lnSpc>
-              <a:buNone/>
-            </a:pPr>
-            <a:r>
-              <a:rPr lang="en-US" sz="1350" dirty="0">
-                <a:solidFill>
-                  <a:srgbClr val="D8FFF0"/>
-                </a:solidFill>
-                <a:latin typeface="Consolas" pitchFamily="34" charset="0"/>
-                <a:ea typeface="Consolas" pitchFamily="34" charset="-122"/>
-                <a:cs typeface="Consolas" pitchFamily="34" charset="-120"/>
-              </a:rPr>
               <a:t>}</a:t>
             </a:r>
             <a:endParaRPr lang="en-US" sz="1350" dirty="0"/>
@@ -10727,11 +9948,11 @@
         <p:spPr>
           <a:xfrm>
             <a:off x="6278728" y="2091690"/>
-            <a:ext cx="5135728" cy="2422017"/>
+            <a:ext cx="5135728" cy="2185416"/>
           </a:xfrm>
           <a:prstGeom prst="roundRect">
             <a:avLst>
-              <a:gd name="adj" fmla="val 4530"/>
+              <a:gd name="adj" fmla="val 5021"/>
             </a:avLst>
           </a:prstGeom>
           <a:solidFill>
@@ -10754,7 +9975,7 @@
         <p:spPr>
           <a:xfrm>
             <a:off x="6461608" y="2201418"/>
-            <a:ext cx="4769968" cy="2239137"/>
+            <a:ext cx="4769968" cy="2002536"/>
           </a:xfrm>
           <a:prstGeom prst="rect">
             <a:avLst/>
@@ -10781,8 +10002,7 @@
                 <a:ea typeface="Consolas" pitchFamily="34" charset="-122"/>
                 <a:cs typeface="Consolas" pitchFamily="34" charset="-120"/>
               </a:rPr>
-              <a:t>{
-</a:t>
+              <a:t>{</a:t>
             </a:r>
             <a:endParaRPr lang="en-US" sz="1350" dirty="0"/>
           </a:p>
@@ -10802,8 +10022,7 @@
                 <a:ea typeface="Consolas" pitchFamily="34" charset="-122"/>
                 <a:cs typeface="Consolas" pitchFamily="34" charset="-120"/>
               </a:rPr>
-              <a:t>  "choices": [{"message": {
-</a:t>
+              <a:t>  "choices": [{"message": {</a:t>
             </a:r>
             <a:endParaRPr lang="en-US" sz="1350" dirty="0"/>
           </a:p>
@@ -10823,8 +10042,7 @@
                 <a:ea typeface="Consolas" pitchFamily="34" charset="-122"/>
                 <a:cs typeface="Consolas" pitchFamily="34" charset="-120"/>
               </a:rPr>
-              <a:t>    "content": "A set of rules that
-</a:t>
+              <a:t>    "content": "A set of rules that…"}}],</a:t>
             </a:r>
             <a:endParaRPr lang="en-US" sz="1350" dirty="0"/>
           </a:p>
@@ -10844,8 +10062,7 @@
                 <a:ea typeface="Consolas" pitchFamily="34" charset="-122"/>
                 <a:cs typeface="Consolas" pitchFamily="34" charset="-120"/>
               </a:rPr>
-              <a:t>     lets programs talk..."}}],
-</a:t>
+              <a:t>  "usage": {</a:t>
             </a:r>
             <a:endParaRPr lang="en-US" sz="1350" dirty="0"/>
           </a:p>
@@ -10865,8 +10082,7 @@
                 <a:ea typeface="Consolas" pitchFamily="34" charset="-122"/>
                 <a:cs typeface="Consolas" pitchFamily="34" charset="-120"/>
               </a:rPr>
-              <a:t>  "usage": {
-</a:t>
+              <a:t>    "prompt_tokens": 31,</a:t>
             </a:r>
             <a:endParaRPr lang="en-US" sz="1350" dirty="0"/>
           </a:p>
@@ -10886,8 +10102,7 @@
                 <a:ea typeface="Consolas" pitchFamily="34" charset="-122"/>
                 <a:cs typeface="Consolas" pitchFamily="34" charset="-120"/>
               </a:rPr>
-              <a:t>    "prompt_tokens": 31,
-</a:t>
+              <a:t>    "completion_tokens": 24</a:t>
             </a:r>
             <a:endParaRPr lang="en-US" sz="1350" dirty="0"/>
           </a:p>
@@ -10907,8 +10122,7 @@
                 <a:ea typeface="Consolas" pitchFamily="34" charset="-122"/>
                 <a:cs typeface="Consolas" pitchFamily="34" charset="-120"/>
               </a:rPr>
-              <a:t>    "completion_tokens": 24
-</a:t>
+              <a:t>  }</a:t>
             </a:r>
             <a:endParaRPr lang="en-US" sz="1350" dirty="0"/>
           </a:p>
@@ -10928,31 +10142,10 @@
                 <a:ea typeface="Consolas" pitchFamily="34" charset="-122"/>
                 <a:cs typeface="Consolas" pitchFamily="34" charset="-120"/>
               </a:rPr>
-              <a:t>  }
-</a:t>
+              <a:t>}</a:t>
             </a:r>
             <a:endParaRPr lang="en-US" sz="1350" dirty="0"/>
           </a:p>
-          <a:p>
-            <a:pPr indent="0" marL="0">
-              <a:lnSpc>
-                <a:spcPct val="115000"/>
-              </a:lnSpc>
-              <a:buNone/>
-            </a:pPr>
-            <a:r>
-              <a:rPr lang="en-US" sz="1350" dirty="0">
-                <a:solidFill>
-                  <a:srgbClr val="D8FFF0"/>
-                </a:solidFill>
-                <a:latin typeface="Consolas" pitchFamily="34" charset="0"/>
-                <a:ea typeface="Consolas" pitchFamily="34" charset="-122"/>
-                <a:cs typeface="Consolas" pitchFamily="34" charset="-120"/>
-              </a:rPr>
-              <a:t>}</a:t>
-            </a:r>
-            <a:endParaRPr lang="en-US" sz="1350" dirty="0"/>
-          </a:p>
         </p:txBody>
       </p:sp>
       <p:sp>
@@ -10963,7 +10156,7 @@
         </p:nvSpPr>
         <p:spPr>
           <a:xfrm>
-            <a:off x="777240" y="4969764"/>
+            <a:off x="777240" y="4733163"/>
             <a:ext cx="10637215" cy="650748"/>
           </a:xfrm>
           <a:prstGeom prst="rect">
@@ -11044,7 +10237,7 @@
                 <a:ea typeface="Segoe UI" pitchFamily="34" charset="-122"/>
                 <a:cs typeface="Segoe UI" pitchFamily="34" charset="-120"/>
               </a:rPr>
-              <a:t>temperature</a:t>
+              <a:t>usage</a:t>
             </a:r>
             <a:pPr algn="l" indent="0" marL="0">
               <a:buNone/>
@@ -11058,35 +10251,7 @@
                 <a:ea typeface="Segoe UI" pitchFamily="34" charset="-122"/>
                 <a:cs typeface="Segoe UI" pitchFamily="34" charset="-120"/>
               </a:rPr>
-              <a:t> is randomness (0 = steady) · </a:t>
-            </a:r>
-            <a:pPr algn="l" indent="0" marL="0">
-              <a:buNone/>
-            </a:pPr>
-            <a:r>
-              <a:rPr lang="en-US" sz="1700" b="1" dirty="0">
-                <a:solidFill>
-                  <a:srgbClr val="FFFFFF"/>
-                </a:solidFill>
-                <a:latin typeface="Segoe UI" pitchFamily="34" charset="0"/>
-                <a:ea typeface="Segoe UI" pitchFamily="34" charset="-122"/>
-                <a:cs typeface="Segoe UI" pitchFamily="34" charset="-120"/>
-              </a:rPr>
-              <a:t>usage</a:t>
-            </a:r>
-            <a:pPr algn="l" indent="0" marL="0">
-              <a:buNone/>
-            </a:pPr>
-            <a:r>
-              <a:rPr lang="en-US" sz="1700" dirty="0">
-                <a:solidFill>
-                  <a:srgbClr val="EEF6F3"/>
-                </a:solidFill>
-                <a:latin typeface="Segoe UI" pitchFamily="34" charset="0"/>
-                <a:ea typeface="Segoe UI" pitchFamily="34" charset="-122"/>
-                <a:cs typeface="Segoe UI" pitchFamily="34" charset="-120"/>
-              </a:rPr>
-              <a:t> is what you pay for</a:t>
+              <a:t>: how many tokens (chunks of text, step 06) went in and out. That's the bill.</a:t>
             </a:r>
             <a:endParaRPr lang="en-US" sz="1700" dirty="0"/>
           </a:p>
@@ -11125,7 +10290,7 @@
                 <a:ea typeface="Segoe UI" pitchFamily="34" charset="-122"/>
                 <a:cs typeface="Segoe UI" pitchFamily="34" charset="-120"/>
               </a:rPr>
-              <a:t>Applied AI Engineering · SE Factory · Resolvo</a:t>
+              <a:t>Applied AI Engineering · SE Factory · Deskhand</a:t>
             </a:r>
             <a:endParaRPr lang="en-US" sz="1000" dirty="0"/>
           </a:p>
@@ -11457,7 +10622,7 @@
                 <a:ea typeface="Segoe UI" pitchFamily="34" charset="-122"/>
                 <a:cs typeface="Segoe UI" pitchFamily="34" charset="-120"/>
               </a:rPr>
-              <a:t>Applied AI Engineering · SE Factory · Resolvo</a:t>
+              <a:t>Applied AI Engineering · SE Factory · Deskhand</a:t>
             </a:r>
             <a:endParaRPr lang="en-US" sz="1000" dirty="0"/>
           </a:p>
@@ -11668,11 +10833,11 @@
         <p:spPr>
           <a:xfrm>
             <a:off x="777240" y="1577340"/>
-            <a:ext cx="10637215" cy="2895219"/>
+            <a:ext cx="10637215" cy="3874159"/>
           </a:xfrm>
           <a:prstGeom prst="roundRect">
             <a:avLst>
-              <a:gd name="adj" fmla="val 3790"/>
+              <a:gd name="adj" fmla="val 2832"/>
             </a:avLst>
           </a:prstGeom>
           <a:solidFill>
@@ -11695,7 +10860,7 @@
         <p:spPr>
           <a:xfrm>
             <a:off x="960120" y="1687068"/>
-            <a:ext cx="10271455" cy="2712339"/>
+            <a:ext cx="10271455" cy="3691279"/>
           </a:xfrm>
           <a:prstGeom prst="rect">
             <a:avLst/>
@@ -11714,7 +10879,7 @@
               <a:buNone/>
             </a:pPr>
             <a:r>
-              <a:rPr lang="en-US" sz="1350" dirty="0">
+              <a:rPr lang="en-US" sz="1135" dirty="0">
                 <a:solidFill>
                   <a:srgbClr val="D8FFF0"/>
                 </a:solidFill>
@@ -11722,10 +10887,9 @@
                 <a:ea typeface="Consolas" pitchFamily="34" charset="-122"/>
                 <a:cs typeface="Consolas" pitchFamily="34" charset="-120"/>
               </a:rPr>
-              <a:t>from openai import OpenAI
-</a:t>
-            </a:r>
-            <a:endParaRPr lang="en-US" sz="1350" dirty="0"/>
+              <a:t>import os</a:t>
+            </a:r>
+            <a:endParaRPr lang="en-US" sz="1135" dirty="0"/>
           </a:p>
           <a:p>
             <a:pPr indent="0" marL="0">
@@ -11735,7 +10899,7 @@
               <a:buNone/>
             </a:pPr>
             <a:r>
-              <a:rPr lang="en-US" sz="1350" dirty="0">
+              <a:rPr lang="en-US" sz="1135" dirty="0">
                 <a:solidFill>
                   <a:srgbClr val="D8FFF0"/>
                 </a:solidFill>
@@ -11743,10 +10907,9 @@
                 <a:ea typeface="Consolas" pitchFamily="34" charset="-122"/>
                 <a:cs typeface="Consolas" pitchFamily="34" charset="-120"/>
               </a:rPr>
-              <a:t>
-</a:t>
-            </a:r>
-            <a:endParaRPr lang="en-US" sz="1350" dirty="0"/>
+              <a:t>from dotenv import load_dotenv</a:t>
+            </a:r>
+            <a:endParaRPr lang="en-US" sz="1135" dirty="0"/>
           </a:p>
           <a:p>
             <a:pPr indent="0" marL="0">
@@ -11756,7 +10919,7 @@
               <a:buNone/>
             </a:pPr>
             <a:r>
-              <a:rPr lang="en-US" sz="1350" dirty="0">
+              <a:rPr lang="en-US" sz="1135" dirty="0">
                 <a:solidFill>
                   <a:srgbClr val="D8FFF0"/>
                 </a:solidFill>
@@ -11764,10 +10927,9 @@
                 <a:ea typeface="Consolas" pitchFamily="34" charset="-122"/>
                 <a:cs typeface="Consolas" pitchFamily="34" charset="-120"/>
               </a:rPr>
-              <a:t>client = OpenAI(base_url="https://openrouter.ai/api/v1", api_key=key)
-</a:t>
-            </a:r>
-            <a:endParaRPr lang="en-US" sz="1350" dirty="0"/>
+              <a:t>from openai import OpenAI</a:t>
+            </a:r>
+            <a:endParaRPr lang="en-US" sz="1135" dirty="0"/>
           </a:p>
           <a:p>
             <a:pPr indent="0" marL="0">
@@ -11777,7 +10939,7 @@
               <a:buNone/>
             </a:pPr>
             <a:r>
-              <a:rPr lang="en-US" sz="1350" dirty="0">
+              <a:rPr lang="en-US" sz="1135" dirty="0">
                 <a:solidFill>
                   <a:srgbClr val="D8FFF0"/>
                 </a:solidFill>
@@ -11785,10 +10947,9 @@
                 <a:ea typeface="Consolas" pitchFamily="34" charset="-122"/>
                 <a:cs typeface="Consolas" pitchFamily="34" charset="-120"/>
               </a:rPr>
-              <a:t>
-</a:t>
-            </a:r>
-            <a:endParaRPr lang="en-US" sz="1350" dirty="0"/>
+              <a:t> </a:t>
+            </a:r>
+            <a:endParaRPr lang="en-US" sz="1135" dirty="0"/>
           </a:p>
           <a:p>
             <a:pPr indent="0" marL="0">
@@ -11798,7 +10959,7 @@
               <a:buNone/>
             </a:pPr>
             <a:r>
-              <a:rPr lang="en-US" sz="1350" dirty="0">
+              <a:rPr lang="en-US" sz="1135" dirty="0">
                 <a:solidFill>
                   <a:srgbClr val="D8FFF0"/>
                 </a:solidFill>
@@ -11806,10 +10967,9 @@
                 <a:ea typeface="Consolas" pitchFamily="34" charset="-122"/>
                 <a:cs typeface="Consolas" pitchFamily="34" charset="-120"/>
               </a:rPr>
-              <a:t>response = client.chat.completions.create(
-</a:t>
-            </a:r>
-            <a:endParaRPr lang="en-US" sz="1350" dirty="0"/>
+              <a:t># 1 · the address and the key (load_dotenv reads .env, as on the secrets slide)</a:t>
+            </a:r>
+            <a:endParaRPr lang="en-US" sz="1135" dirty="0"/>
           </a:p>
           <a:p>
             <a:pPr indent="0" marL="0">
@@ -11819,7 +10979,7 @@
               <a:buNone/>
             </a:pPr>
             <a:r>
-              <a:rPr lang="en-US" sz="1350" dirty="0">
+              <a:rPr lang="en-US" sz="1135" dirty="0">
                 <a:solidFill>
                   <a:srgbClr val="D8FFF0"/>
                 </a:solidFill>
@@ -11827,10 +10987,9 @@
                 <a:ea typeface="Consolas" pitchFamily="34" charset="-122"/>
                 <a:cs typeface="Consolas" pitchFamily="34" charset="-120"/>
               </a:rPr>
-              <a:t>    model="openrouter/free",
-</a:t>
-            </a:r>
-            <a:endParaRPr lang="en-US" sz="1350" dirty="0"/>
+              <a:t>load_dotenv()</a:t>
+            </a:r>
+            <a:endParaRPr lang="en-US" sz="1135" dirty="0"/>
           </a:p>
           <a:p>
             <a:pPr indent="0" marL="0">
@@ -11840,7 +10999,7 @@
               <a:buNone/>
             </a:pPr>
             <a:r>
-              <a:rPr lang="en-US" sz="1350" dirty="0">
+              <a:rPr lang="en-US" sz="1135" dirty="0">
                 <a:solidFill>
                   <a:srgbClr val="D8FFF0"/>
                 </a:solidFill>
@@ -11848,10 +11007,9 @@
                 <a:ea typeface="Consolas" pitchFamily="34" charset="-122"/>
                 <a:cs typeface="Consolas" pitchFamily="34" charset="-120"/>
               </a:rPr>
-              <a:t>    messages=[{"role": "system", "content": "Keep answers short."},
-</a:t>
-            </a:r>
-            <a:endParaRPr lang="en-US" sz="1350" dirty="0"/>
+              <a:t>key = os.environ["OPENROUTER_API_KEY"]</a:t>
+            </a:r>
+            <a:endParaRPr lang="en-US" sz="1135" dirty="0"/>
           </a:p>
           <a:p>
             <a:pPr indent="0" marL="0">
@@ -11861,7 +11019,7 @@
               <a:buNone/>
             </a:pPr>
             <a:r>
-              <a:rPr lang="en-US" sz="1350" dirty="0">
+              <a:rPr lang="en-US" sz="1135" dirty="0">
                 <a:solidFill>
                   <a:srgbClr val="D8FFF0"/>
                 </a:solidFill>
@@ -11869,10 +11027,9 @@
                 <a:ea typeface="Consolas" pitchFamily="34" charset="-122"/>
                 <a:cs typeface="Consolas" pitchFamily="34" charset="-120"/>
               </a:rPr>
-              <a:t>              {"role": "user", "content": "Explain an API in one sentence."}],
-</a:t>
-            </a:r>
-            <a:endParaRPr lang="en-US" sz="1350" dirty="0"/>
+              <a:t>client = OpenAI(base_url="https://openrouter.ai/api/v1", api_key=key)</a:t>
+            </a:r>
+            <a:endParaRPr lang="en-US" sz="1135" dirty="0"/>
           </a:p>
           <a:p>
             <a:pPr indent="0" marL="0">
@@ -11882,7 +11039,7 @@
               <a:buNone/>
             </a:pPr>
             <a:r>
-              <a:rPr lang="en-US" sz="1350" dirty="0">
+              <a:rPr lang="en-US" sz="1135" dirty="0">
                 <a:solidFill>
                   <a:srgbClr val="D8FFF0"/>
                 </a:solidFill>
@@ -11890,10 +11047,9 @@
                 <a:ea typeface="Consolas" pitchFamily="34" charset="-122"/>
                 <a:cs typeface="Consolas" pitchFamily="34" charset="-120"/>
               </a:rPr>
-              <a:t>)
-</a:t>
-            </a:r>
-            <a:endParaRPr lang="en-US" sz="1350" dirty="0"/>
+              <a:t> </a:t>
+            </a:r>
+            <a:endParaRPr lang="en-US" sz="1135" dirty="0"/>
           </a:p>
           <a:p>
             <a:pPr indent="0" marL="0">
@@ -11903,7 +11059,7 @@
               <a:buNone/>
             </a:pPr>
             <a:r>
-              <a:rPr lang="en-US" sz="1350" dirty="0">
+              <a:rPr lang="en-US" sz="1135" dirty="0">
                 <a:solidFill>
                   <a:srgbClr val="D8FFF0"/>
                 </a:solidFill>
@@ -11911,10 +11067,9 @@
                 <a:ea typeface="Consolas" pitchFamily="34" charset="-122"/>
                 <a:cs typeface="Consolas" pitchFamily="34" charset="-120"/>
               </a:rPr>
-              <a:t>print(response.choices[0].message.content)
-</a:t>
-            </a:r>
-            <a:endParaRPr lang="en-US" sz="1350" dirty="0"/>
+              <a:t># 2 · one call: a model name and the messages</a:t>
+            </a:r>
+            <a:endParaRPr lang="en-US" sz="1135" dirty="0"/>
           </a:p>
           <a:p>
             <a:pPr indent="0" marL="0">
@@ -11924,7 +11079,7 @@
               <a:buNone/>
             </a:pPr>
             <a:r>
-              <a:rPr lang="en-US" sz="1350" dirty="0">
+              <a:rPr lang="en-US" sz="1135" dirty="0">
                 <a:solidFill>
                   <a:srgbClr val="D8FFF0"/>
                 </a:solidFill>
@@ -11932,52 +11087,19 @@
                 <a:ea typeface="Consolas" pitchFamily="34" charset="-122"/>
                 <a:cs typeface="Consolas" pitchFamily="34" charset="-120"/>
               </a:rPr>
-              <a:t>print(response.usage.prompt_tokens, response.usage.completion_tokens)</a:t>
-            </a:r>
-            <a:endParaRPr lang="en-US" sz="1350" dirty="0"/>
-          </a:p>
-        </p:txBody>
-      </p:sp>
-      <p:sp>
-        <p:nvSpPr>
-          <p:cNvPr id="8" name="Text 6"/>
-          <p:cNvSpPr/>
-          <p:nvPr/>
-        </p:nvSpPr>
-        <p:spPr>
-          <a:xfrm>
-            <a:off x="777240" y="4600575"/>
-            <a:ext cx="10637215" cy="352806"/>
-          </a:xfrm>
-          <a:prstGeom prst="rect">
-            <a:avLst/>
-          </a:prstGeom>
-          <a:noFill/>
-          <a:ln/>
-        </p:spPr>
-        <p:txBody>
-          <a:bodyPr wrap="square" lIns="0" tIns="0" rIns="0" bIns="0" rtlCol="0" anchor="t"/>
-          <a:lstStyle/>
-          <a:p>
-            <a:pPr algn="l" indent="0" marL="0">
-              <a:buNone/>
-            </a:pPr>
-            <a:r>
-              <a:rPr lang="en-US" sz="1700" dirty="0">
-                <a:solidFill>
-                  <a:srgbClr val="EEF6F3"/>
-                </a:solidFill>
-                <a:latin typeface="Segoe UI" pitchFamily="34" charset="0"/>
-                <a:ea typeface="Segoe UI" pitchFamily="34" charset="-122"/>
-                <a:cs typeface="Segoe UI" pitchFamily="34" charset="-120"/>
-              </a:rPr>
-              <a:t>The kit wraps this in </a:t>
-            </a:r>
-            <a:pPr algn="l" indent="0" marL="0">
-              <a:buNone/>
-            </a:pPr>
-            <a:r>
-              <a:rPr lang="en-US" sz="1500" dirty="0">
+              <a:t>response = client.chat.completions.create(</a:t>
+            </a:r>
+            <a:endParaRPr lang="en-US" sz="1135" dirty="0"/>
+          </a:p>
+          <a:p>
+            <a:pPr indent="0" marL="0">
+              <a:lnSpc>
+                <a:spcPct val="115000"/>
+              </a:lnSpc>
+              <a:buNone/>
+            </a:pPr>
+            <a:r>
+              <a:rPr lang="en-US" sz="1135" dirty="0">
                 <a:solidFill>
                   <a:srgbClr val="D8FFF0"/>
                 </a:solidFill>
@@ -11985,27 +11107,19 @@
                 <a:ea typeface="Consolas" pitchFamily="34" charset="-122"/>
                 <a:cs typeface="Consolas" pitchFamily="34" charset="-120"/>
               </a:rPr>
-              <a:t>code/chat.py</a:t>
-            </a:r>
-            <a:pPr algn="l" indent="0" marL="0">
-              <a:buNone/>
-            </a:pPr>
-            <a:r>
-              <a:rPr lang="en-US" sz="1700" dirty="0">
-                <a:solidFill>
-                  <a:srgbClr val="EEF6F3"/>
-                </a:solidFill>
-                <a:latin typeface="Segoe UI" pitchFamily="34" charset="0"/>
-                <a:ea typeface="Segoe UI" pitchFamily="34" charset="-122"/>
-                <a:cs typeface="Segoe UI" pitchFamily="34" charset="-120"/>
-              </a:rPr>
-              <a:t> with a </a:t>
-            </a:r>
-            <a:pPr algn="l" indent="0" marL="0">
-              <a:buNone/>
-            </a:pPr>
-            <a:r>
-              <a:rPr lang="en-US" sz="1500" dirty="0">
+              <a:t>    model="openrouter/free",</a:t>
+            </a:r>
+            <a:endParaRPr lang="en-US" sz="1135" dirty="0"/>
+          </a:p>
+          <a:p>
+            <a:pPr indent="0" marL="0">
+              <a:lnSpc>
+                <a:spcPct val="115000"/>
+              </a:lnSpc>
+              <a:buNone/>
+            </a:pPr>
+            <a:r>
+              <a:rPr lang="en-US" sz="1135" dirty="0">
                 <a:solidFill>
                   <a:srgbClr val="D8FFF0"/>
                 </a:solidFill>
@@ -12013,13 +11127,194 @@
                 <a:ea typeface="Consolas" pitchFamily="34" charset="-122"/>
                 <a:cs typeface="Consolas" pitchFamily="34" charset="-120"/>
               </a:rPr>
+              <a:t>    messages=[{"role": "system", "content": "Keep answers short."},</a:t>
+            </a:r>
+            <a:endParaRPr lang="en-US" sz="1135" dirty="0"/>
+          </a:p>
+          <a:p>
+            <a:pPr indent="0" marL="0">
+              <a:lnSpc>
+                <a:spcPct val="115000"/>
+              </a:lnSpc>
+              <a:buNone/>
+            </a:pPr>
+            <a:r>
+              <a:rPr lang="en-US" sz="1135" dirty="0">
+                <a:solidFill>
+                  <a:srgbClr val="D8FFF0"/>
+                </a:solidFill>
+                <a:latin typeface="Consolas" pitchFamily="34" charset="0"/>
+                <a:ea typeface="Consolas" pitchFamily="34" charset="-122"/>
+                <a:cs typeface="Consolas" pitchFamily="34" charset="-120"/>
+              </a:rPr>
+              <a:t>              {"role": "user", "content": "Explain an API in one sentence."}],</a:t>
+            </a:r>
+            <a:endParaRPr lang="en-US" sz="1135" dirty="0"/>
+          </a:p>
+          <a:p>
+            <a:pPr indent="0" marL="0">
+              <a:lnSpc>
+                <a:spcPct val="115000"/>
+              </a:lnSpc>
+              <a:buNone/>
+            </a:pPr>
+            <a:r>
+              <a:rPr lang="en-US" sz="1135" dirty="0">
+                <a:solidFill>
+                  <a:srgbClr val="D8FFF0"/>
+                </a:solidFill>
+                <a:latin typeface="Consolas" pitchFamily="34" charset="0"/>
+                <a:ea typeface="Consolas" pitchFamily="34" charset="-122"/>
+                <a:cs typeface="Consolas" pitchFamily="34" charset="-120"/>
+              </a:rPr>
+              <a:t>)</a:t>
+            </a:r>
+            <a:endParaRPr lang="en-US" sz="1135" dirty="0"/>
+          </a:p>
+          <a:p>
+            <a:pPr indent="0" marL="0">
+              <a:lnSpc>
+                <a:spcPct val="115000"/>
+              </a:lnSpc>
+              <a:buNone/>
+            </a:pPr>
+            <a:r>
+              <a:rPr lang="en-US" sz="1135" dirty="0">
+                <a:solidFill>
+                  <a:srgbClr val="D8FFF0"/>
+                </a:solidFill>
+                <a:latin typeface="Consolas" pitchFamily="34" charset="0"/>
+                <a:ea typeface="Consolas" pitchFamily="34" charset="-122"/>
+                <a:cs typeface="Consolas" pitchFamily="34" charset="-120"/>
+              </a:rPr>
+              <a:t># 3 · the reply, and the two token counts</a:t>
+            </a:r>
+            <a:endParaRPr lang="en-US" sz="1135" dirty="0"/>
+          </a:p>
+          <a:p>
+            <a:pPr indent="0" marL="0">
+              <a:lnSpc>
+                <a:spcPct val="115000"/>
+              </a:lnSpc>
+              <a:buNone/>
+            </a:pPr>
+            <a:r>
+              <a:rPr lang="en-US" sz="1135" dirty="0">
+                <a:solidFill>
+                  <a:srgbClr val="D8FFF0"/>
+                </a:solidFill>
+                <a:latin typeface="Consolas" pitchFamily="34" charset="0"/>
+                <a:ea typeface="Consolas" pitchFamily="34" charset="-122"/>
+                <a:cs typeface="Consolas" pitchFamily="34" charset="-120"/>
+              </a:rPr>
+              <a:t>print(response.choices[0].message.content)</a:t>
+            </a:r>
+            <a:endParaRPr lang="en-US" sz="1135" dirty="0"/>
+          </a:p>
+          <a:p>
+            <a:pPr indent="0" marL="0">
+              <a:lnSpc>
+                <a:spcPct val="115000"/>
+              </a:lnSpc>
+              <a:buNone/>
+            </a:pPr>
+            <a:r>
+              <a:rPr lang="en-US" sz="1135" dirty="0">
+                <a:solidFill>
+                  <a:srgbClr val="D8FFF0"/>
+                </a:solidFill>
+                <a:latin typeface="Consolas" pitchFamily="34" charset="0"/>
+                <a:ea typeface="Consolas" pitchFamily="34" charset="-122"/>
+                <a:cs typeface="Consolas" pitchFamily="34" charset="-120"/>
+              </a:rPr>
+              <a:t>print(response.usage.prompt_tokens, response.usage.completion_tokens)</a:t>
+            </a:r>
+            <a:endParaRPr lang="en-US" sz="1135" dirty="0"/>
+          </a:p>
+        </p:txBody>
+      </p:sp>
+      <p:sp>
+        <p:nvSpPr>
+          <p:cNvPr id="8" name="Text 6"/>
+          <p:cNvSpPr/>
+          <p:nvPr/>
+        </p:nvSpPr>
+        <p:spPr>
+          <a:xfrm>
+            <a:off x="777240" y="5579515"/>
+            <a:ext cx="10637215" cy="555986"/>
+          </a:xfrm>
+          <a:prstGeom prst="rect">
+            <a:avLst/>
+          </a:prstGeom>
+          <a:noFill/>
+          <a:ln/>
+        </p:spPr>
+        <p:txBody>
+          <a:bodyPr wrap="square" lIns="0" tIns="0" rIns="0" bIns="0" rtlCol="0" anchor="t"/>
+          <a:lstStyle/>
+          <a:p>
+            <a:pPr algn="l" indent="0" marL="0">
+              <a:buNone/>
+            </a:pPr>
+            <a:r>
+              <a:rPr lang="en-US" sz="1430" dirty="0">
+                <a:solidFill>
+                  <a:srgbClr val="EEF6F3"/>
+                </a:solidFill>
+                <a:latin typeface="Segoe UI" pitchFamily="34" charset="0"/>
+                <a:ea typeface="Segoe UI" pitchFamily="34" charset="-122"/>
+                <a:cs typeface="Segoe UI" pitchFamily="34" charset="-120"/>
+              </a:rPr>
+              <a:t>A minimal version to read, not a file in the kit. The kit's </a:t>
+            </a:r>
+            <a:pPr algn="l" indent="0" marL="0">
+              <a:buNone/>
+            </a:pPr>
+            <a:r>
+              <a:rPr lang="en-US" sz="1260" dirty="0">
+                <a:solidFill>
+                  <a:srgbClr val="D8FFF0"/>
+                </a:solidFill>
+                <a:latin typeface="Consolas" pitchFamily="34" charset="0"/>
+                <a:ea typeface="Consolas" pitchFamily="34" charset="-122"/>
+                <a:cs typeface="Consolas" pitchFamily="34" charset="-120"/>
+              </a:rPr>
+              <a:t>code/chat.py</a:t>
+            </a:r>
+            <a:pPr algn="l" indent="0" marL="0">
+              <a:buNone/>
+            </a:pPr>
+            <a:r>
+              <a:rPr lang="en-US" sz="1430" dirty="0">
+                <a:solidFill>
+                  <a:srgbClr val="EEF6F3"/>
+                </a:solidFill>
+                <a:latin typeface="Segoe UI" pitchFamily="34" charset="0"/>
+                <a:ea typeface="Segoe UI" pitchFamily="34" charset="-122"/>
+                <a:cs typeface="Segoe UI" pitchFamily="34" charset="-120"/>
+              </a:rPr>
+              <a:t> does the same, with a </a:t>
+            </a:r>
+            <a:pPr algn="l" indent="0" marL="0">
+              <a:buNone/>
+            </a:pPr>
+            <a:r>
+              <a:rPr lang="en-US" sz="1260" dirty="0">
+                <a:solidFill>
+                  <a:srgbClr val="D8FFF0"/>
+                </a:solidFill>
+                <a:latin typeface="Consolas" pitchFamily="34" charset="0"/>
+                <a:ea typeface="Consolas" pitchFamily="34" charset="-122"/>
+                <a:cs typeface="Consolas" pitchFamily="34" charset="-120"/>
+              </a:rPr>
               <a:t>--provider</a:t>
             </a:r>
             <a:pPr algn="l" indent="0" marL="0">
               <a:buNone/>
             </a:pPr>
             <a:r>
-              <a:rPr lang="en-US" sz="1700" dirty="0">
+              <a:rPr lang="en-US" sz="1430" dirty="0">
                 <a:solidFill>
                   <a:srgbClr val="EEF6F3"/>
                 </a:solidFill>
@@ -12029,7 +11324,7 @@
               </a:rPr>
               <a:t> switch and friendly error messages.</a:t>
             </a:r>
-            <a:endParaRPr lang="en-US" sz="1700" dirty="0"/>
+            <a:endParaRPr lang="en-US" sz="1430" dirty="0"/>
           </a:p>
         </p:txBody>
       </p:sp>
@@ -12066,7 +11361,7 @@
                 <a:ea typeface="Segoe UI" pitchFamily="34" charset="-122"/>
                 <a:cs typeface="Segoe UI" pitchFamily="34" charset="-120"/>
               </a:rPr>
-              <a:t>Applied AI Engineering · SE Factory · Resolvo</a:t>
+              <a:t>Applied AI Engineering · SE Factory · Deskhand</a:t>
             </a:r>
             <a:endParaRPr lang="en-US" sz="1000" dirty="0"/>
           </a:p>
@@ -12262,7 +11557,7 @@
                 <a:ea typeface="Segoe UI" pitchFamily="34" charset="-122"/>
                 <a:cs typeface="Segoe UI" pitchFamily="34" charset="-120"/>
               </a:rPr>
-              <a:t>What this is, and what it isn't</a:t>
+              <a:t>A first touch, not a test</a:t>
             </a:r>
             <a:endParaRPr lang="en-US" sz="3000" dirty="0"/>
           </a:p>
@@ -12667,7 +11962,7 @@
                 <a:ea typeface="Segoe UI" pitchFamily="34" charset="-122"/>
                 <a:cs typeface="Segoe UI" pitchFamily="34" charset="-120"/>
               </a:rPr>
-              <a:t>Applied AI Engineering · SE Factory · Resolvo</a:t>
+              <a:t>Applied AI Engineering · SE Factory · Deskhand</a:t>
             </a:r>
             <a:endParaRPr lang="en-US" sz="1000" dirty="0"/>
           </a:p>
@@ -12796,7 +12091,7 @@
         <p:spPr>
           <a:xfrm>
             <a:off x="777240" y="457200"/>
-            <a:ext cx="2203704" cy="274320"/>
+            <a:ext cx="2331720" cy="274320"/>
           </a:xfrm>
           <a:prstGeom prst="roundRect">
             <a:avLst>
@@ -12824,7 +12119,7 @@
                 <a:ea typeface="Segoe UI" pitchFamily="34" charset="-122"/>
                 <a:cs typeface="Segoe UI" pitchFamily="34" charset="-120"/>
               </a:rPr>
-              <a:t>STEP 04 AND 05</a:t>
+              <a:t>STEPS 04 AND 05</a:t>
             </a:r>
             <a:endParaRPr lang="en-US" sz="1100" dirty="0"/>
           </a:p>
@@ -13556,7 +12851,7 @@
                 <a:ea typeface="Segoe UI" pitchFamily="34" charset="-122"/>
                 <a:cs typeface="Segoe UI" pitchFamily="34" charset="-120"/>
               </a:rPr>
-              <a:t>These are for practice. The course code needs OpenAI, Azure or Anthropic (step 08).</a:t>
+              <a:t>These are for practice. The course needs a paid OpenAI or Azure OpenAI key (step 08).</a:t>
             </a:r>
             <a:endParaRPr lang="en-US" sz="1720" dirty="0"/>
           </a:p>
@@ -13595,7 +12890,7 @@
                 <a:ea typeface="Segoe UI" pitchFamily="34" charset="-122"/>
                 <a:cs typeface="Segoe UI" pitchFamily="34" charset="-120"/>
               </a:rPr>
-              <a:t>Applied AI Engineering · SE Factory · Resolvo</a:t>
+              <a:t>Applied AI Engineering · SE Factory · Deskhand</a:t>
             </a:r>
             <a:endParaRPr lang="en-US" sz="1000" dirty="0"/>
           </a:p>
@@ -13928,8 +13223,7 @@
                 <a:ea typeface="Consolas" pitchFamily="34" charset="-122"/>
                 <a:cs typeface="Consolas" pitchFamily="34" charset="-120"/>
               </a:rPr>
-              <a:t>py code\show_env.py                  # are the keys set? (never prints them)
-</a:t>
+              <a:t>py code\show_env.py                  # are the keys set? (never prints them)</a:t>
             </a:r>
             <a:endParaRPr lang="en-US" sz="1350" dirty="0"/>
           </a:p>
@@ -13949,8 +13243,7 @@
                 <a:ea typeface="Consolas" pitchFamily="34" charset="-122"/>
                 <a:cs typeface="Consolas" pitchFamily="34" charset="-120"/>
               </a:rPr>
-              <a:t>py code\chat.py --provider gemini "Explain what an API is in one sentence."
-</a:t>
+              <a:t>py code\chat.py --provider gemini "Explain what an API is in one sentence."</a:t>
             </a:r>
             <a:endParaRPr lang="en-US" sz="1350" dirty="0"/>
           </a:p>
@@ -13970,8 +13263,7 @@
                 <a:ea typeface="Consolas" pitchFamily="34" charset="-122"/>
                 <a:cs typeface="Consolas" pitchFamily="34" charset="-120"/>
               </a:rPr>
-              <a:t>py code\chat.py --provider openrouter "Explain what an API is in one sentence."
-</a:t>
+              <a:t>py code\chat.py --provider openrouter "Explain what an API is in one sentence."</a:t>
             </a:r>
             <a:endParaRPr lang="en-US" sz="1350" dirty="0"/>
           </a:p>
@@ -13991,8 +13283,7 @@
                 <a:ea typeface="Consolas" pitchFamily="34" charset="-122"/>
                 <a:cs typeface="Consolas" pitchFamily="34" charset="-120"/>
               </a:rPr>
-              <a:t>py code\chat.py --provider ollama "Explain what an API is in one sentence."
-</a:t>
+              <a:t>py code\chat.py --provider ollama "Explain what an API is in one sentence."   # after step 05</a:t>
             </a:r>
             <a:endParaRPr lang="en-US" sz="1350" dirty="0"/>
           </a:p>
@@ -14012,8 +13303,7 @@
                 <a:ea typeface="Consolas" pitchFamily="34" charset="-122"/>
                 <a:cs typeface="Consolas" pitchFamily="34" charset="-120"/>
               </a:rPr>
-              <a:t>
-</a:t>
+              <a:t> </a:t>
             </a:r>
             <a:endParaRPr lang="en-US" sz="1350" dirty="0"/>
           </a:p>
@@ -14033,8 +13323,7 @@
                 <a:ea typeface="Consolas" pitchFamily="34" charset="-122"/>
                 <a:cs typeface="Consolas" pitchFamily="34" charset="-120"/>
               </a:rPr>
-              <a:t>An API is a set of rules that lets different programs talk to each other.
-</a:t>
+              <a:t>An API is a set of rules that lets different programs talk to each other.</a:t>
             </a:r>
             <a:endParaRPr lang="en-US" sz="1350" dirty="0"/>
           </a:p>
@@ -14054,8 +13343,7 @@
                 <a:ea typeface="Consolas" pitchFamily="34" charset="-122"/>
                 <a:cs typeface="Consolas" pitchFamily="34" charset="-120"/>
               </a:rPr>
-              <a:t>
-</a:t>
+              <a:t> </a:t>
             </a:r>
             <a:endParaRPr lang="en-US" sz="1350" dirty="0"/>
           </a:p>
@@ -14090,7 +13378,7 @@
         <p:spPr>
           <a:xfrm>
             <a:off x="777240" y="3890772"/>
-            <a:ext cx="10637215" cy="405384"/>
+            <a:ext cx="10637215" cy="755904"/>
           </a:xfrm>
           <a:prstGeom prst="rect">
             <a:avLst/>
@@ -14106,6 +13394,20 @@
               <a:buNone/>
             </a:pPr>
             <a:r>
+              <a:rPr lang="en-US" sz="2000" b="1" dirty="0">
+                <a:solidFill>
+                  <a:srgbClr val="FFFFFF"/>
+                </a:solidFill>
+                <a:latin typeface="Segoe UI" pitchFamily="34" charset="0"/>
+                <a:ea typeface="Segoe UI" pitchFamily="34" charset="-122"/>
+                <a:cs typeface="Segoe UI" pitchFamily="34" charset="-120"/>
+              </a:rPr>
+              <a:t>Temperature</a:t>
+            </a:r>
+            <a:pPr algn="l" indent="0" marL="0">
+              <a:buNone/>
+            </a:pPr>
+            <a:r>
               <a:rPr lang="en-US" sz="2000" dirty="0">
                 <a:solidFill>
                   <a:srgbClr val="EEF6F3"/>
@@ -14114,7 +13416,7 @@
                 <a:ea typeface="Segoe UI" pitchFamily="34" charset="-122"/>
                 <a:cs typeface="Segoe UI" pitchFamily="34" charset="-120"/>
               </a:rPr>
-              <a:t>Then: the same joke at </a:t>
+              <a:t> is a randomness dial: near 0 you get the same answer most times, higher gives variety. Run this three times, then three times with </a:t>
             </a:r>
             <a:pPr algn="l" indent="0" marL="0">
               <a:buNone/>
@@ -14142,13 +13444,68 @@
                 <a:ea typeface="Segoe UI" pitchFamily="34" charset="-122"/>
                 <a:cs typeface="Segoe UI" pitchFamily="34" charset="-120"/>
               </a:rPr>
-              <a:t> three times, and at </a:t>
-            </a:r>
-            <a:pPr algn="l" indent="0" marL="0">
-              <a:buNone/>
-            </a:pPr>
-            <a:r>
-              <a:rPr lang="en-US" sz="1760" dirty="0">
+              <a:t>:</a:t>
+            </a:r>
+            <a:endParaRPr lang="en-US" sz="2000" dirty="0"/>
+          </a:p>
+        </p:txBody>
+      </p:sp>
+      <p:sp>
+        <p:nvSpPr>
+          <p:cNvPr id="11" name="Shape 9"/>
+          <p:cNvSpPr/>
+          <p:nvPr/>
+        </p:nvSpPr>
+        <p:spPr>
+          <a:xfrm>
+            <a:off x="777240" y="4774692"/>
+            <a:ext cx="10637215" cy="529209"/>
+          </a:xfrm>
+          <a:prstGeom prst="roundRect">
+            <a:avLst>
+              <a:gd name="adj" fmla="val 20734"/>
+            </a:avLst>
+          </a:prstGeom>
+          <a:solidFill>
+            <a:srgbClr val="13272B"/>
+          </a:solidFill>
+          <a:ln w="9525">
+            <a:solidFill>
+              <a:srgbClr val="24413F"/>
+            </a:solidFill>
+            <a:prstDash val="solid"/>
+          </a:ln>
+        </p:spPr>
+      </p:sp>
+      <p:sp>
+        <p:nvSpPr>
+          <p:cNvPr id="12" name="Text 10"/>
+          <p:cNvSpPr/>
+          <p:nvPr/>
+        </p:nvSpPr>
+        <p:spPr>
+          <a:xfrm>
+            <a:off x="960120" y="4884420"/>
+            <a:ext cx="10271455" cy="346329"/>
+          </a:xfrm>
+          <a:prstGeom prst="rect">
+            <a:avLst/>
+          </a:prstGeom>
+          <a:noFill/>
+          <a:ln/>
+        </p:spPr>
+        <p:txBody>
+          <a:bodyPr wrap="square" lIns="0" tIns="0" rIns="0" bIns="0" rtlCol="0" anchor="t"/>
+          <a:lstStyle/>
+          <a:p>
+            <a:pPr indent="0" marL="0">
+              <a:lnSpc>
+                <a:spcPct val="115000"/>
+              </a:lnSpc>
+              <a:buNone/>
+            </a:pPr>
+            <a:r>
+              <a:rPr lang="en-US" sz="1350" dirty="0">
                 <a:solidFill>
                   <a:srgbClr val="D8FFF0"/>
                 </a:solidFill>
@@ -14156,29 +13513,15 @@
                 <a:ea typeface="Consolas" pitchFamily="34" charset="-122"/>
                 <a:cs typeface="Consolas" pitchFamily="34" charset="-120"/>
               </a:rPr>
-              <a:t>1.5</a:t>
-            </a:r>
-            <a:pPr algn="l" indent="0" marL="0">
-              <a:buNone/>
-            </a:pPr>
-            <a:r>
-              <a:rPr lang="en-US" sz="2000" dirty="0">
-                <a:solidFill>
-                  <a:srgbClr val="EEF6F3"/>
-                </a:solidFill>
-                <a:latin typeface="Segoe UI" pitchFamily="34" charset="0"/>
-                <a:ea typeface="Segoe UI" pitchFamily="34" charset="-122"/>
-                <a:cs typeface="Segoe UI" pitchFamily="34" charset="-120"/>
-              </a:rPr>
-              <a:t> three times.</a:t>
-            </a:r>
-            <a:endParaRPr lang="en-US" sz="2000" dirty="0"/>
-          </a:p>
-        </p:txBody>
-      </p:sp>
-      <p:sp>
-        <p:nvSpPr>
-          <p:cNvPr id="11" name="Text 9"/>
+              <a:t>py code\chat.py --provider gemini --temperature 1.5 "Tell me a one-line joke about printers."</a:t>
+            </a:r>
+            <a:endParaRPr lang="en-US" sz="1350" dirty="0"/>
+          </a:p>
+        </p:txBody>
+      </p:sp>
+      <p:sp>
+        <p:nvSpPr>
+          <p:cNvPr id="13" name="Text 11"/>
           <p:cNvSpPr/>
           <p:nvPr/>
         </p:nvSpPr>
@@ -14209,7 +13552,7 @@
                 <a:ea typeface="Segoe UI" pitchFamily="34" charset="-122"/>
                 <a:cs typeface="Segoe UI" pitchFamily="34" charset="-120"/>
               </a:rPr>
-              <a:t>Applied AI Engineering · SE Factory · Resolvo</a:t>
+              <a:t>Applied AI Engineering · SE Factory · Deskhand</a:t>
             </a:r>
             <a:endParaRPr lang="en-US" sz="1000" dirty="0"/>
           </a:p>
@@ -14217,7 +13560,7 @@
       </p:sp>
       <p:sp>
         <p:nvSpPr>
-          <p:cNvPr id="12" name="Text 10"/>
+          <p:cNvPr id="14" name="Text 12"/>
           <p:cNvSpPr/>
           <p:nvPr/>
         </p:nvSpPr>
@@ -14474,8 +13817,7 @@
                 <a:ea typeface="Consolas" pitchFamily="34" charset="-122"/>
                 <a:cs typeface="Consolas" pitchFamily="34" charset="-120"/>
               </a:rPr>
-              <a:t>ollama pull llama3.2          # about 2 GB, 3 billion parameters
-</a:t>
+              <a:t>ollama pull llama3.2          # about 2 GB, 3 billion parameters (the numbers the model is made of)</a:t>
             </a:r>
             <a:endParaRPr lang="en-US" sz="1350" dirty="0"/>
           </a:p>
@@ -15164,7 +14506,7 @@
                 <a:ea typeface="Segoe UI" pitchFamily="34" charset="-122"/>
                 <a:cs typeface="Segoe UI" pitchFamily="34" charset="-120"/>
               </a:rPr>
-              <a:t>Applied AI Engineering · SE Factory · Resolvo</a:t>
+              <a:t>Applied AI Engineering · SE Factory · Deskhand</a:t>
             </a:r>
             <a:endParaRPr lang="en-US" sz="1000" dirty="0"/>
           </a:p>
@@ -15375,11 +14717,11 @@
         <p:spPr>
           <a:xfrm>
             <a:off x="777240" y="1577340"/>
-            <a:ext cx="10637215" cy="1712214"/>
+            <a:ext cx="10637215" cy="1948815"/>
           </a:xfrm>
           <a:prstGeom prst="roundRect">
             <a:avLst>
-              <a:gd name="adj" fmla="val 6409"/>
+              <a:gd name="adj" fmla="val 5630"/>
             </a:avLst>
           </a:prstGeom>
           <a:solidFill>
@@ -15402,7 +14744,7 @@
         <p:spPr>
           <a:xfrm>
             <a:off x="960120" y="1687068"/>
-            <a:ext cx="10271455" cy="1529334"/>
+            <a:ext cx="10271455" cy="1765935"/>
           </a:xfrm>
           <a:prstGeom prst="rect">
             <a:avLst/>
@@ -15429,8 +14771,7 @@
                 <a:ea typeface="Consolas" pitchFamily="34" charset="-122"/>
                 <a:cs typeface="Consolas" pitchFamily="34" charset="-120"/>
               </a:rPr>
-              <a:t>py code\count_tokens.py
-</a:t>
+              <a:t>py code\count_tokens.py          # output trimmed</a:t>
             </a:r>
             <a:endParaRPr lang="en-US" sz="1350" dirty="0"/>
           </a:p>
@@ -15450,8 +14791,7 @@
                 <a:ea typeface="Consolas" pitchFamily="34" charset="-122"/>
                 <a:cs typeface="Consolas" pitchFamily="34" charset="-120"/>
               </a:rPr>
-              <a:t>
-</a:t>
+              <a:t> </a:t>
             </a:r>
             <a:endParaRPr lang="en-US" sz="1350" dirty="0"/>
           </a:p>
@@ -15471,8 +14811,7 @@
                 <a:ea typeface="Consolas" pitchFamily="34" charset="-122"/>
                 <a:cs typeface="Consolas" pitchFamily="34" charset="-120"/>
               </a:rPr>
-              <a:t>Ticket T-1001: 217 characters, 40 words, 47 tokens
-</a:t>
+              <a:t>Ticket T-1001: 217 characters, 40 words, 47 tokens</a:t>
             </a:r>
             <a:endParaRPr lang="en-US" sz="1350" dirty="0"/>
           </a:p>
@@ -15492,8 +14831,7 @@
                 <a:ea typeface="Consolas" pitchFamily="34" charset="-122"/>
                 <a:cs typeface="Consolas" pitchFamily="34" charset="-120"/>
               </a:rPr>
-              <a:t>
-</a:t>
+              <a:t> </a:t>
             </a:r>
             <a:endParaRPr lang="en-US" sz="1350" dirty="0"/>
           </a:p>
@@ -15513,8 +14851,7 @@
                 <a:ea typeface="Consolas" pitchFamily="34" charset="-122"/>
                 <a:cs typeface="Consolas" pitchFamily="34" charset="-120"/>
               </a:rPr>
-              <a:t>'I' | ' ordered' | ' the' | ' wireless' | ' headphones' | ' two' | ' weeks' |
-</a:t>
+              <a:t>The first 20 tokens, as the model sees them:</a:t>
             </a:r>
             <a:endParaRPr lang="en-US" sz="1350" dirty="0"/>
           </a:p>
@@ -15534,6 +14871,26 @@
                 <a:ea typeface="Consolas" pitchFamily="34" charset="-122"/>
                 <a:cs typeface="Consolas" pitchFamily="34" charset="-120"/>
               </a:rPr>
+              <a:t>'I' | ' ordered' | ' the' | ' wireless' | ' headphones' | ' two' | ' weeks' |</a:t>
+            </a:r>
+            <a:endParaRPr lang="en-US" sz="1350" dirty="0"/>
+          </a:p>
+          <a:p>
+            <a:pPr indent="0" marL="0">
+              <a:lnSpc>
+                <a:spcPct val="115000"/>
+              </a:lnSpc>
+              <a:buNone/>
+            </a:pPr>
+            <a:r>
+              <a:rPr lang="en-US" sz="1350" dirty="0">
+                <a:solidFill>
+                  <a:srgbClr val="D8FFF0"/>
+                </a:solidFill>
+                <a:latin typeface="Consolas" pitchFamily="34" charset="0"/>
+                <a:ea typeface="Consolas" pitchFamily="34" charset="-122"/>
+                <a:cs typeface="Consolas" pitchFamily="34" charset="-120"/>
+              </a:rPr>
               <a:t>' ago' | ',' | ' order' | ' #' | '482' | '91' | '.' | ' They' | ' arrived' | ...</a:t>
             </a:r>
             <a:endParaRPr lang="en-US" sz="1350" dirty="0"/>
@@ -15548,7 +14905,7 @@
         </p:nvSpPr>
         <p:spPr>
           <a:xfrm>
-            <a:off x="777240" y="3417570"/>
+            <a:off x="777240" y="3654171"/>
             <a:ext cx="10637215" cy="1169822"/>
           </a:xfrm>
           <a:prstGeom prst="roundRect">
@@ -15575,7 +14932,7 @@
         </p:nvSpPr>
         <p:spPr>
           <a:xfrm>
-            <a:off x="777240" y="3417570"/>
+            <a:off x="777240" y="3654171"/>
             <a:ext cx="82296" cy="1169822"/>
           </a:xfrm>
           <a:prstGeom prst="rect">
@@ -15600,7 +14957,7 @@
         </p:nvSpPr>
         <p:spPr>
           <a:xfrm>
-            <a:off x="1051560" y="3527298"/>
+            <a:off x="1051560" y="3763899"/>
             <a:ext cx="10225735" cy="237744"/>
           </a:xfrm>
           <a:prstGeom prst="rect">
@@ -15639,7 +14996,7 @@
         </p:nvSpPr>
         <p:spPr>
           <a:xfrm>
-            <a:off x="1051560" y="3765042"/>
+            <a:off x="1051560" y="4001643"/>
             <a:ext cx="10225735" cy="657758"/>
           </a:xfrm>
           <a:prstGeom prst="rect">
@@ -15706,7 +15063,7 @@
         </p:nvSpPr>
         <p:spPr>
           <a:xfrm>
-            <a:off x="777240" y="4715408"/>
+            <a:off x="777240" y="4952009"/>
             <a:ext cx="10637215" cy="352806"/>
           </a:xfrm>
           <a:prstGeom prst="rect">
@@ -15798,7 +15155,7 @@
                 <a:ea typeface="Segoe UI" pitchFamily="34" charset="-122"/>
                 <a:cs typeface="Segoe UI" pitchFamily="34" charset="-120"/>
               </a:rPr>
-              <a:t>Applied AI Engineering · SE Factory · Resolvo</a:t>
+              <a:t>Applied AI Engineering · SE Factory · Deskhand</a:t>
             </a:r>
             <a:endParaRPr lang="en-US" sz="1000" dirty="0"/>
           </a:p>
@@ -17099,7 +16456,7 @@
                 <a:ea typeface="Segoe UI" pitchFamily="34" charset="-122"/>
                 <a:cs typeface="Segoe UI" pitchFamily="34" charset="-120"/>
               </a:rPr>
-              <a:t>Applied AI Engineering · SE Factory · Resolvo</a:t>
+              <a:t>Applied AI Engineering · SE Factory · Deskhand</a:t>
             </a:r>
             <a:endParaRPr lang="en-US" sz="1000" dirty="0"/>
           </a:p>
@@ -18401,7 +17758,7 @@
                 <a:ea typeface="Segoe UI" pitchFamily="34" charset="-122"/>
                 <a:cs typeface="Segoe UI" pitchFamily="34" charset="-120"/>
               </a:rPr>
-              <a:t>Applied AI Engineering · SE Factory · Resolvo</a:t>
+              <a:t>Applied AI Engineering · SE Factory · Deskhand</a:t>
             </a:r>
             <a:endParaRPr lang="en-US" sz="1000" dirty="0"/>
           </a:p>
@@ -18848,7 +18205,7 @@
                 <a:ea typeface="Segoe UI" pitchFamily="34" charset="-122"/>
                 <a:cs typeface="Segoe UI" pitchFamily="34" charset="-120"/>
               </a:rPr>
-              <a:t>Applied AI Engineering · SE Factory · Resolvo</a:t>
+              <a:t>Applied AI Engineering · SE Factory · Deskhand</a:t>
             </a:r>
             <a:endParaRPr lang="en-US" sz="1000" dirty="0"/>
           </a:p>
@@ -19044,7 +18401,7 @@
                 <a:ea typeface="Segoe UI" pitchFamily="34" charset="-122"/>
                 <a:cs typeface="Segoe UI" pitchFamily="34" charset="-120"/>
               </a:rPr>
-              <a:t>A taste of Resolvo: the model suggests, your code decides</a:t>
+              <a:t>Sorting real tickets: the model suggests, your code decides</a:t>
             </a:r>
             <a:endParaRPr lang="en-US" sz="3000" dirty="0"/>
           </a:p>
@@ -19113,8 +18470,7 @@
                 <a:ea typeface="Consolas" pitchFamily="34" charset="-122"/>
                 <a:cs typeface="Consolas" pitchFamily="34" charset="-120"/>
               </a:rPr>
-              <a:t>py code\taste_of_resolvo.py --provider gemini
-</a:t>
+              <a:t>py code\taste_of_resolvo.py --provider gemini</a:t>
             </a:r>
             <a:endParaRPr lang="en-US" sz="1350" dirty="0"/>
           </a:p>
@@ -19134,8 +18490,7 @@
                 <a:ea typeface="Consolas" pitchFamily="34" charset="-122"/>
                 <a:cs typeface="Consolas" pitchFamily="34" charset="-120"/>
               </a:rPr>
-              <a:t>
-</a:t>
+              <a:t> </a:t>
             </a:r>
             <a:endParaRPr lang="en-US" sz="1350" dirty="0"/>
           </a:p>
@@ -19155,8 +18510,7 @@
                 <a:ea typeface="Consolas" pitchFamily="34" charset="-122"/>
                 <a:cs typeface="Consolas" pitchFamily="34" charset="-120"/>
               </a:rPr>
-              <a:t>--- T-1002: Hi, checking on order O-58204 (SoundBar Mini). It says shipped...
-</a:t>
+              <a:t>--- T-1002: Hi, checking on order O-58204 (SoundBar Mini). It says shipped...</a:t>
             </a:r>
             <a:endParaRPr lang="en-US" sz="1350" dirty="0"/>
           </a:p>
@@ -19672,7 +19026,7 @@
                 <a:ea typeface="Segoe UI" pitchFamily="34" charset="-122"/>
                 <a:cs typeface="Segoe UI" pitchFamily="34" charset="-120"/>
               </a:rPr>
-              <a:t>Applied AI Engineering · SE Factory · Resolvo</a:t>
+              <a:t>Applied AI Engineering · SE Factory · Deskhand</a:t>
             </a:r>
             <a:endParaRPr lang="en-US" sz="1000" dirty="0"/>
           </a:p>
@@ -20181,7 +19535,7 @@
                 <a:ea typeface="Segoe UI" pitchFamily="34" charset="-122"/>
                 <a:cs typeface="Segoe UI" pitchFamily="34" charset="-120"/>
               </a:rPr>
-              <a:t>Session 2 makes it nearly impossible.</a:t>
+              <a:t>Your code can check this.</a:t>
             </a:r>
             <a:endParaRPr lang="en-US" sz="1360" dirty="0"/>
           </a:p>
@@ -20311,7 +19665,7 @@
                 <a:ea typeface="Segoe UI" pitchFamily="34" charset="-122"/>
                 <a:cs typeface="Segoe UI" pitchFamily="34" charset="-120"/>
               </a:rPr>
-              <a:t>Perfect JSON, wrong label. Nothing is broken: it's a duplicate gift.</a:t>
+              <a:t>Perfect JSON, wrong label. The speaker isn't faulty: it's a duplicate gift.</a:t>
             </a:r>
             <a:endParaRPr lang="en-US" sz="1600" dirty="0"/>
           </a:p>
@@ -20350,7 +19704,7 @@
                 <a:ea typeface="Segoe UI" pitchFamily="34" charset="-122"/>
                 <a:cs typeface="Segoe UI" pitchFamily="34" charset="-120"/>
               </a:rPr>
-              <a:t>Session 10: test against tickets with known answers.</a:t>
+              <a:t>No check on one reply can catch this.</a:t>
             </a:r>
             <a:endParaRPr lang="en-US" sz="1360" dirty="0"/>
           </a:p>
@@ -20389,7 +19743,7 @@
                 <a:ea typeface="Segoe UI" pitchFamily="34" charset="-122"/>
                 <a:cs typeface="Segoe UI" pitchFamily="34" charset="-120"/>
               </a:rPr>
-              <a:t>Applied AI Engineering · SE Factory · Resolvo</a:t>
+              <a:t>Applied AI Engineering · SE Factory · Deskhand</a:t>
             </a:r>
             <a:endParaRPr lang="en-US" sz="1000" dirty="0"/>
           </a:p>
@@ -20614,9 +19968,9 @@
             <a:tbl>
               <a:tblPr/>
               <a:tblGrid>
-                <a:gridCol w="2532888"/>
-                <a:gridCol w="1645920"/>
-                <a:gridCol w="6458407"/>
+                <a:gridCol w="2287829"/>
+                <a:gridCol w="1486814"/>
+                <a:gridCol w="6862572"/>
               </a:tblGrid>
               <a:tr h="0">
                 <a:tc>
@@ -21404,7 +20758,7 @@
                           <a:ea typeface="Segoe UI" pitchFamily="34" charset="-122"/>
                           <a:cs typeface="Segoe UI" pitchFamily="34" charset="-120"/>
                         </a:rPr>
-                        <a:t>Session 1 and the RAG weeks also need an OpenAI key</a:t>
+                        <a:t>Some course code only speaks OpenAI or Azure, so you'd need an OpenAI key as well</a:t>
                       </a:r>
                       <a:endParaRPr lang="en-US" sz="1450" dirty="0">
                         <a:latin typeface="Segoe UI" charset="0"/>
@@ -21468,8 +20822,8 @@
         </p:nvSpPr>
         <p:spPr>
           <a:xfrm>
-            <a:off x="777240" y="3279648"/>
-            <a:ext cx="10637215" cy="1289304"/>
+            <a:off x="777240" y="3533775"/>
+            <a:ext cx="10637215" cy="1639824"/>
           </a:xfrm>
           <a:prstGeom prst="rect">
             <a:avLst/>
@@ -21612,7 +20966,7 @@
                 <a:ea typeface="Segoe UI" pitchFamily="34" charset="-122"/>
                 <a:cs typeface="Segoe UI" pitchFamily="34" charset="-120"/>
               </a:rPr>
-              <a:t>. You only see it once.</a:t>
+              <a:t> (the kit's name for it). You only see it once.</a:t>
             </a:r>
             <a:endParaRPr lang="en-US" sz="2000" dirty="0"/>
           </a:p>
@@ -21626,7 +20980,7 @@
         </p:nvSpPr>
         <p:spPr>
           <a:xfrm>
-            <a:off x="777240" y="4696968"/>
+            <a:off x="777240" y="5301615"/>
             <a:ext cx="10637215" cy="352806"/>
           </a:xfrm>
           <a:prstGeom prst="rect">
@@ -21690,7 +21044,7 @@
                 <a:ea typeface="Segoe UI" pitchFamily="34" charset="-122"/>
                 <a:cs typeface="Segoe UI" pitchFamily="34" charset="-120"/>
               </a:rPr>
-              <a:t>Applied AI Engineering · SE Factory · Resolvo</a:t>
+              <a:t>Applied AI Engineering · SE Factory · Deskhand</a:t>
             </a:r>
             <a:endParaRPr lang="en-US" sz="1000" dirty="0"/>
           </a:p>
@@ -21901,7 +21255,7 @@
         <p:spPr>
           <a:xfrm>
             <a:off x="777240" y="1577340"/>
-            <a:ext cx="10637215" cy="2755392"/>
+            <a:ext cx="10637215" cy="1990344"/>
           </a:xfrm>
           <a:prstGeom prst="rect">
             <a:avLst/>
@@ -21964,7 +21318,7 @@
                 <a:ea typeface="Segoe UI" pitchFamily="34" charset="-122"/>
                 <a:cs typeface="Segoe UI" pitchFamily="34" charset="-120"/>
               </a:rPr>
-              <a:t>Resolvo</a:t>
+              <a:t>Deskhand</a:t>
             </a:r>
             <a:pPr indent="0" marL="0">
               <a:buNone/>
@@ -22003,27 +21357,6 @@
             </a:r>
             <a:endParaRPr lang="en-US" sz="2000" dirty="0"/>
           </a:p>
-          <a:p>
-            <a:pPr marL="279400" indent="-279400">
-              <a:spcAft>
-                <a:spcPts val="500"/>
-              </a:spcAft>
-              <a:buSzPct val="100000"/>
-              <a:buChar char="•"/>
-            </a:pPr>
-            <a:r>
-              <a:rPr lang="en-US" sz="2000" dirty="0">
-                <a:solidFill>
-                  <a:srgbClr val="EEF6F3"/>
-                </a:solidFill>
-                <a:latin typeface="Segoe UI" pitchFamily="34" charset="0"/>
-                <a:ea typeface="Segoe UI" pitchFamily="34" charset="-122"/>
-                <a:cs typeface="Segoe UI" pitchFamily="34" charset="-120"/>
-              </a:rPr>
-              <a:t>No coding in class: you predict and vote before every run. Each evening you run the same thing yourself.</a:t>
-            </a:r>
-            <a:endParaRPr lang="en-US" sz="2000" dirty="0"/>
-          </a:p>
         </p:txBody>
       </p:sp>
       <p:sp>
@@ -22034,7 +21367,7 @@
         </p:nvSpPr>
         <p:spPr>
           <a:xfrm>
-            <a:off x="777240" y="4460748"/>
+            <a:off x="777240" y="3695700"/>
             <a:ext cx="10637215" cy="1169822"/>
           </a:xfrm>
           <a:prstGeom prst="roundRect">
@@ -22061,7 +21394,7 @@
         </p:nvSpPr>
         <p:spPr>
           <a:xfrm>
-            <a:off x="777240" y="4460748"/>
+            <a:off x="777240" y="3695700"/>
             <a:ext cx="82296" cy="1169822"/>
           </a:xfrm>
           <a:prstGeom prst="rect">
@@ -22086,7 +21419,7 @@
         </p:nvSpPr>
         <p:spPr>
           <a:xfrm>
-            <a:off x="1051560" y="4570476"/>
+            <a:off x="1051560" y="3805428"/>
             <a:ext cx="10225735" cy="237744"/>
           </a:xfrm>
           <a:prstGeom prst="rect">
@@ -22125,7 +21458,7 @@
         </p:nvSpPr>
         <p:spPr>
           <a:xfrm>
-            <a:off x="1051560" y="4808220"/>
+            <a:off x="1051560" y="4043172"/>
             <a:ext cx="10225735" cy="657758"/>
           </a:xfrm>
           <a:prstGeom prst="rect">
@@ -22189,7 +21522,7 @@
                 <a:ea typeface="Segoe UI" pitchFamily="34" charset="-122"/>
                 <a:cs typeface="Segoe UI" pitchFamily="34" charset="-120"/>
               </a:rPr>
-              <a:t>Applied AI Engineering · SE Factory · Resolvo</a:t>
+              <a:t>Applied AI Engineering · SE Factory · Deskhand</a:t>
             </a:r>
             <a:endParaRPr lang="en-US" sz="1000" dirty="0"/>
           </a:p>
@@ -22400,11 +21733,11 @@
         <p:spPr>
           <a:xfrm>
             <a:off x="777240" y="1577340"/>
-            <a:ext cx="10637215" cy="3605022"/>
+            <a:ext cx="10637215" cy="4078224"/>
           </a:xfrm>
           <a:prstGeom prst="roundRect">
             <a:avLst>
-              <a:gd name="adj" fmla="val 3044"/>
+              <a:gd name="adj" fmla="val 2691"/>
             </a:avLst>
           </a:prstGeom>
           <a:solidFill>
@@ -22427,7 +21760,7 @@
         <p:spPr>
           <a:xfrm>
             <a:off x="960120" y="1687068"/>
-            <a:ext cx="10271455" cy="3422142"/>
+            <a:ext cx="10271455" cy="3895344"/>
           </a:xfrm>
           <a:prstGeom prst="rect">
             <a:avLst/>
@@ -22454,8 +21787,7 @@
                 <a:ea typeface="Consolas" pitchFamily="34" charset="-122"/>
                 <a:cs typeface="Consolas" pitchFamily="34" charset="-120"/>
               </a:rPr>
-              <a:t># from the folder that holds prep-kit
-</a:t>
+              <a:t># from the folder that holds prep-kit</a:t>
             </a:r>
             <a:endParaRPr lang="en-US" sz="1350" dirty="0"/>
           </a:p>
@@ -22475,8 +21807,7 @@
                 <a:ea typeface="Consolas" pitchFamily="34" charset="-122"/>
                 <a:cs typeface="Consolas" pitchFamily="34" charset="-120"/>
               </a:rPr>
-              <a:t>git clone https://github.com/hasankanaan26/resolvo-workshop.git
-</a:t>
+              <a:t>git clone https://github.com/hasankanaan26/deskhand-workshop.git</a:t>
             </a:r>
             <a:endParaRPr lang="en-US" sz="1350" dirty="0"/>
           </a:p>
@@ -22496,8 +21827,7 @@
                 <a:ea typeface="Consolas" pitchFamily="34" charset="-122"/>
                 <a:cs typeface="Consolas" pitchFamily="34" charset="-120"/>
               </a:rPr>
-              <a:t>cd resolvo-workshop
-</a:t>
+              <a:t>cd deskhand-workshop</a:t>
             </a:r>
             <a:endParaRPr lang="en-US" sz="1350" dirty="0"/>
           </a:p>
@@ -22517,8 +21847,7 @@
                 <a:ea typeface="Consolas" pitchFamily="34" charset="-122"/>
                 <a:cs typeface="Consolas" pitchFamily="34" charset="-120"/>
               </a:rPr>
-              <a:t>deactivate; py -3.12 -m venv .venv; .venv\Scripts\activate   # the course's own venv
-</a:t>
+              <a:t>deactivate                          # only if your prompt starts with (.venv)</a:t>
             </a:r>
             <a:endParaRPr lang="en-US" sz="1350" dirty="0"/>
           </a:p>
@@ -22538,8 +21867,7 @@
                 <a:ea typeface="Consolas" pitchFamily="34" charset="-122"/>
                 <a:cs typeface="Consolas" pitchFamily="34" charset="-120"/>
               </a:rPr>
-              <a:t>pip install -r requirements.txt     # the full course list: 10 to 20 minutes
-</a:t>
+              <a:t>py -3.12 -m venv .venv; .venv\Scripts\activate   # the course's own venv</a:t>
             </a:r>
             <a:endParaRPr lang="en-US" sz="1350" dirty="0"/>
           </a:p>
@@ -22559,8 +21887,7 @@
                 <a:ea typeface="Consolas" pitchFamily="34" charset="-122"/>
                 <a:cs typeface="Consolas" pitchFamily="34" charset="-120"/>
               </a:rPr>
-              <a:t>copy .env.example .env              # then set LLM_PROVIDER=openai and OPENAI_API_KEY=
-</a:t>
+              <a:t>pip install -r requirements.txt     # the full course list: 10 to 20 minutes</a:t>
             </a:r>
             <a:endParaRPr lang="en-US" sz="1350" dirty="0"/>
           </a:p>
@@ -22580,8 +21907,7 @@
                 <a:ea typeface="Consolas" pitchFamily="34" charset="-122"/>
                 <a:cs typeface="Consolas" pitchFamily="34" charset="-120"/>
               </a:rPr>
-              <a:t>python ..\prep-kit\code\check_setup.py --live
-</a:t>
+              <a:t>copy .env.example .env              # then set LLM_PROVIDER=openai and OPENAI_API_KEY=</a:t>
             </a:r>
             <a:endParaRPr lang="en-US" sz="1350" dirty="0"/>
           </a:p>
@@ -22601,8 +21927,7 @@
                 <a:ea typeface="Consolas" pitchFamily="34" charset="-122"/>
                 <a:cs typeface="Consolas" pitchFamily="34" charset="-120"/>
               </a:rPr>
-              <a:t>
-</a:t>
+              <a:t>python ..\prep-kit\code\check_setup.py --live      # output trimmed</a:t>
             </a:r>
             <a:endParaRPr lang="en-US" sz="1350" dirty="0"/>
           </a:p>
@@ -22622,8 +21947,7 @@
                 <a:ea typeface="Consolas" pitchFamily="34" charset="-122"/>
                 <a:cs typeface="Consolas" pitchFamily="34" charset="-120"/>
               </a:rPr>
-              <a:t>[ ok ] Course repo found: C:\...\resolvo-workshop
-</a:t>
+              <a:t> </a:t>
             </a:r>
             <a:endParaRPr lang="en-US" sz="1350" dirty="0"/>
           </a:p>
@@ -22643,8 +21967,7 @@
                 <a:ea typeface="Consolas" pitchFamily="34" charset="-122"/>
                 <a:cs typeface="Consolas" pitchFamily="34" charset="-120"/>
               </a:rPr>
-              <a:t>[ ok ] The course's virtual environment is active
-</a:t>
+              <a:t>[ ok ] Course repo found: C:\...\deskhand-workshop</a:t>
             </a:r>
             <a:endParaRPr lang="en-US" sz="1350" dirty="0"/>
           </a:p>
@@ -22664,8 +21987,7 @@
                 <a:ea typeface="Consolas" pitchFamily="34" charset="-122"/>
                 <a:cs typeface="Consolas" pitchFamily="34" charset="-120"/>
               </a:rPr>
-              <a:t>[ ok ] Course provider: openai (key filled in)
-</a:t>
+              <a:t>[ ok ] The course's virtual environment is active</a:t>
             </a:r>
             <a:endParaRPr lang="en-US" sz="1350" dirty="0"/>
           </a:p>
@@ -22685,8 +22007,7 @@
                 <a:ea typeface="Consolas" pitchFamily="34" charset="-122"/>
                 <a:cs typeface="Consolas" pitchFamily="34" charset="-120"/>
               </a:rPr>
-              <a:t>[ ok ] Live call to openai (gpt-4o-mini) answered: 'ready'
-</a:t>
+              <a:t>[ ok ] Course provider: openai (key filled in)</a:t>
             </a:r>
             <a:endParaRPr lang="en-US" sz="1350" dirty="0"/>
           </a:p>
@@ -22706,8 +22027,7 @@
                 <a:ea typeface="Consolas" pitchFamily="34" charset="-122"/>
                 <a:cs typeface="Consolas" pitchFamily="34" charset="-120"/>
               </a:rPr>
-              <a:t>
-</a:t>
+              <a:t>[warn] Mock order API not running (fine for now)</a:t>
             </a:r>
             <a:endParaRPr lang="en-US" sz="1350" dirty="0"/>
           </a:p>
@@ -22727,6 +22047,46 @@
                 <a:ea typeface="Consolas" pitchFamily="34" charset="-122"/>
                 <a:cs typeface="Consolas" pitchFamily="34" charset="-120"/>
               </a:rPr>
+              <a:t>[ ok ] Live call to openai (gpt-4o-mini) answered: 'ready'</a:t>
+            </a:r>
+            <a:endParaRPr lang="en-US" sz="1350" dirty="0"/>
+          </a:p>
+          <a:p>
+            <a:pPr indent="0" marL="0">
+              <a:lnSpc>
+                <a:spcPct val="115000"/>
+              </a:lnSpc>
+              <a:buNone/>
+            </a:pPr>
+            <a:r>
+              <a:rPr lang="en-US" sz="1350" dirty="0">
+                <a:solidFill>
+                  <a:srgbClr val="D8FFF0"/>
+                </a:solidFill>
+                <a:latin typeface="Consolas" pitchFamily="34" charset="0"/>
+                <a:ea typeface="Consolas" pitchFamily="34" charset="-122"/>
+                <a:cs typeface="Consolas" pitchFamily="34" charset="-120"/>
+              </a:rPr>
+              <a:t> </a:t>
+            </a:r>
+            <a:endParaRPr lang="en-US" sz="1350" dirty="0"/>
+          </a:p>
+          <a:p>
+            <a:pPr indent="0" marL="0">
+              <a:lnSpc>
+                <a:spcPct val="115000"/>
+              </a:lnSpc>
+              <a:buNone/>
+            </a:pPr>
+            <a:r>
+              <a:rPr lang="en-US" sz="1350" dirty="0">
+                <a:solidFill>
+                  <a:srgbClr val="D8FFF0"/>
+                </a:solidFill>
+                <a:latin typeface="Consolas" pitchFamily="34" charset="0"/>
+                <a:ea typeface="Consolas" pitchFamily="34" charset="-122"/>
+                <a:cs typeface="Consolas" pitchFamily="34" charset="-120"/>
+              </a:rPr>
               <a:t>Ready for Day 1. See you on Monday.</a:t>
             </a:r>
             <a:endParaRPr lang="en-US" sz="1350" dirty="0"/>
@@ -22766,7 +22126,7 @@
                 <a:ea typeface="Segoe UI" pitchFamily="34" charset="-122"/>
                 <a:cs typeface="Segoe UI" pitchFamily="34" charset="-120"/>
               </a:rPr>
-              <a:t>Applied AI Engineering · SE Factory · Resolvo</a:t>
+              <a:t>Applied AI Engineering · SE Factory · Deskhand</a:t>
             </a:r>
             <a:endParaRPr lang="en-US" sz="1000" dirty="0"/>
           </a:p>
@@ -23232,7 +22592,7 @@
                 <a:ea typeface="Consolas" pitchFamily="34" charset="-122"/>
                 <a:cs typeface="Consolas" pitchFamily="34" charset="-120"/>
               </a:rPr>
-              <a:t>resolvo-workshop/.env</a:t>
+              <a:t>deskhand-workshop/.env</a:t>
             </a:r>
             <a:pPr indent="0" marL="0">
               <a:buNone/>
@@ -23454,7 +22814,7 @@
                 <a:ea typeface="Segoe UI" pitchFamily="34" charset="-122"/>
                 <a:cs typeface="Segoe UI" pitchFamily="34" charset="-120"/>
               </a:rPr>
-              <a:t>Applied AI Engineering · SE Factory · Resolvo</a:t>
+              <a:t>Applied AI Engineering · SE Factory · Deskhand</a:t>
             </a:r>
             <a:endParaRPr lang="en-US" sz="1000" dirty="0"/>
           </a:p>
@@ -23704,7 +23064,7 @@
                 <a:ea typeface="Segoe UI" pitchFamily="34" charset="-122"/>
                 <a:cs typeface="Segoe UI" pitchFamily="34" charset="-120"/>
               </a:rPr>
-              <a:t>Session 1: What Changed, and What Didn't. The laptop that passed the check is for the evenings.</a:t>
+              <a:t>Session 1: What Changed, and What Didn't. In class you watch; in the evenings you run it yourself.</a:t>
             </a:r>
             <a:endParaRPr lang="en-US" sz="2200" dirty="0"/>
           </a:p>
@@ -23782,7 +23142,7 @@
                 <a:ea typeface="Segoe UI" pitchFamily="34" charset="-122"/>
                 <a:cs typeface="Segoe UI" pitchFamily="34" charset="-120"/>
               </a:rPr>
-              <a:t>Applied AI Engineering · SE Factory · Resolvo</a:t>
+              <a:t>Applied AI Engineering · SE Factory · Deskhand</a:t>
             </a:r>
             <a:endParaRPr lang="en-US" sz="1000" dirty="0"/>
           </a:p>
@@ -25877,6 +25237,45 @@
         </p:nvSpPr>
         <p:spPr>
           <a:xfrm>
+            <a:off x="777240" y="5190363"/>
+            <a:ext cx="10637215" cy="352806"/>
+          </a:xfrm>
+          <a:prstGeom prst="rect">
+            <a:avLst/>
+          </a:prstGeom>
+          <a:noFill/>
+          <a:ln/>
+        </p:spPr>
+        <p:txBody>
+          <a:bodyPr wrap="square" lIns="0" tIns="0" rIns="0" bIns="0" rtlCol="0" anchor="t"/>
+          <a:lstStyle/>
+          <a:p>
+            <a:pPr algn="l" indent="0" marL="0">
+              <a:buNone/>
+            </a:pPr>
+            <a:r>
+              <a:rPr lang="en-US" sz="1700" dirty="0">
+                <a:solidFill>
+                  <a:srgbClr val="9DB5B1"/>
+                </a:solidFill>
+                <a:latin typeface="Segoe UI" pitchFamily="34" charset="0"/>
+                <a:ea typeface="Segoe UI" pitchFamily="34" charset="-122"/>
+                <a:cs typeface="Segoe UI" pitchFamily="34" charset="-120"/>
+              </a:rPr>
+              <a:t>The kit still calls Deskhand by its earlier name, Resolvo, in a few places. Same bot.</a:t>
+            </a:r>
+            <a:endParaRPr lang="en-US" sz="1700" dirty="0"/>
+          </a:p>
+        </p:txBody>
+      </p:sp>
+      <p:sp>
+        <p:nvSpPr>
+          <p:cNvPr id="8" name="Text 5"/>
+          <p:cNvSpPr/>
+          <p:nvPr/>
+        </p:nvSpPr>
+        <p:spPr>
+          <a:xfrm>
             <a:off x="777240" y="6473952"/>
             <a:ext cx="5486400" cy="274320"/>
           </a:xfrm>
@@ -25902,7 +25301,7 @@
                 <a:ea typeface="Segoe UI" pitchFamily="34" charset="-122"/>
                 <a:cs typeface="Segoe UI" pitchFamily="34" charset="-120"/>
               </a:rPr>
-              <a:t>Applied AI Engineering · SE Factory · Resolvo</a:t>
+              <a:t>Applied AI Engineering · SE Factory · Deskhand</a:t>
             </a:r>
             <a:endParaRPr lang="en-US" sz="1000" dirty="0"/>
           </a:p>
@@ -25910,7 +25309,7 @@
       </p:sp>
       <p:sp>
         <p:nvSpPr>
-          <p:cNvPr id="8" name="Text 5"/>
+          <p:cNvPr id="9" name="Text 6"/>
           <p:cNvSpPr/>
           <p:nvPr/>
         </p:nvSpPr>
@@ -27562,7 +26961,7 @@
                 <a:ea typeface="Segoe UI" pitchFamily="34" charset="-122"/>
                 <a:cs typeface="Segoe UI" pitchFamily="34" charset="-120"/>
               </a:rPr>
-              <a:t>Applied AI Engineering · SE Factory · Resolvo</a:t>
+              <a:t>Applied AI Engineering · SE Factory · Deskhand</a:t>
             </a:r>
             <a:endParaRPr lang="en-US" sz="1000" dirty="0"/>
           </a:p>
@@ -27796,7 +27195,165 @@
       </p:pic>
       <p:sp>
         <p:nvSpPr>
-          <p:cNvPr id="7" name="Text 4"/>
+          <p:cNvPr id="7" name="Shape 4"/>
+          <p:cNvSpPr/>
+          <p:nvPr/>
+        </p:nvSpPr>
+        <p:spPr>
+          <a:xfrm>
+            <a:off x="777240" y="4561324"/>
+            <a:ext cx="10637215" cy="1169822"/>
+          </a:xfrm>
+          <a:prstGeom prst="roundRect">
+            <a:avLst>
+              <a:gd name="adj" fmla="val 7817"/>
+            </a:avLst>
+          </a:prstGeom>
+          <a:solidFill>
+            <a:srgbClr val="0D3029"/>
+          </a:solidFill>
+          <a:ln w="12700">
+            <a:solidFill>
+              <a:srgbClr val="0D3029"/>
+            </a:solidFill>
+            <a:prstDash val="solid"/>
+          </a:ln>
+        </p:spPr>
+      </p:sp>
+      <p:sp>
+        <p:nvSpPr>
+          <p:cNvPr id="8" name="Shape 5"/>
+          <p:cNvSpPr/>
+          <p:nvPr/>
+        </p:nvSpPr>
+        <p:spPr>
+          <a:xfrm>
+            <a:off x="777240" y="4561324"/>
+            <a:ext cx="82296" cy="1169822"/>
+          </a:xfrm>
+          <a:prstGeom prst="rect">
+            <a:avLst/>
+          </a:prstGeom>
+          <a:solidFill>
+            <a:srgbClr val="01D294"/>
+          </a:solidFill>
+          <a:ln w="12700">
+            <a:solidFill>
+              <a:srgbClr val="01D294"/>
+            </a:solidFill>
+            <a:prstDash val="solid"/>
+          </a:ln>
+        </p:spPr>
+      </p:sp>
+      <p:sp>
+        <p:nvSpPr>
+          <p:cNvPr id="9" name="Text 6"/>
+          <p:cNvSpPr/>
+          <p:nvPr/>
+        </p:nvSpPr>
+        <p:spPr>
+          <a:xfrm>
+            <a:off x="1051560" y="4671052"/>
+            <a:ext cx="10225735" cy="237744"/>
+          </a:xfrm>
+          <a:prstGeom prst="rect">
+            <a:avLst/>
+          </a:prstGeom>
+          <a:noFill/>
+          <a:ln/>
+        </p:spPr>
+        <p:txBody>
+          <a:bodyPr wrap="square" lIns="0" tIns="0" rIns="0" bIns="0" rtlCol="0" anchor="t"/>
+          <a:lstStyle/>
+          <a:p>
+            <a:pPr indent="0" marL="0">
+              <a:buNone/>
+            </a:pPr>
+            <a:r>
+              <a:rPr lang="en-US" sz="1050" b="1" spc="300" kern="0" dirty="0">
+                <a:solidFill>
+                  <a:srgbClr val="01D294"/>
+                </a:solidFill>
+                <a:latin typeface="Segoe UI" pitchFamily="34" charset="0"/>
+                <a:ea typeface="Segoe UI" pitchFamily="34" charset="-122"/>
+                <a:cs typeface="Segoe UI" pitchFamily="34" charset="-120"/>
+              </a:rPr>
+              <a:t>IN PLAIN WORDS</a:t>
+            </a:r>
+            <a:endParaRPr lang="en-US" sz="1050" dirty="0"/>
+          </a:p>
+        </p:txBody>
+      </p:sp>
+      <p:sp>
+        <p:nvSpPr>
+          <p:cNvPr id="10" name="Text 7"/>
+          <p:cNvSpPr/>
+          <p:nvPr/>
+        </p:nvSpPr>
+        <p:spPr>
+          <a:xfrm>
+            <a:off x="1051560" y="4908796"/>
+            <a:ext cx="10225735" cy="657758"/>
+          </a:xfrm>
+          <a:prstGeom prst="rect">
+            <a:avLst/>
+          </a:prstGeom>
+          <a:noFill/>
+          <a:ln/>
+        </p:spPr>
+        <p:txBody>
+          <a:bodyPr wrap="square" lIns="0" tIns="0" rIns="0" bIns="0" rtlCol="0" anchor="t"/>
+          <a:lstStyle/>
+          <a:p>
+            <a:pPr algn="l" indent="0" marL="0">
+              <a:buNone/>
+            </a:pPr>
+            <a:r>
+              <a:rPr lang="en-US" sz="1720" dirty="0">
+                <a:solidFill>
+                  <a:srgbClr val="EEF6F3"/>
+                </a:solidFill>
+                <a:latin typeface="Segoe UI" pitchFamily="34" charset="0"/>
+                <a:ea typeface="Segoe UI" pitchFamily="34" charset="-122"/>
+                <a:cs typeface="Segoe UI" pitchFamily="34" charset="-120"/>
+              </a:rPr>
+              <a:t>A </a:t>
+            </a:r>
+            <a:pPr algn="l" indent="0" marL="0">
+              <a:buNone/>
+            </a:pPr>
+            <a:r>
+              <a:rPr lang="en-US" sz="1720" b="1" dirty="0">
+                <a:solidFill>
+                  <a:srgbClr val="FFFFFF"/>
+                </a:solidFill>
+                <a:latin typeface="Segoe UI" pitchFamily="34" charset="0"/>
+                <a:ea typeface="Segoe UI" pitchFamily="34" charset="-122"/>
+                <a:cs typeface="Segoe UI" pitchFamily="34" charset="-120"/>
+              </a:rPr>
+              <a:t>virtual environment</a:t>
+            </a:r>
+            <a:pPr algn="l" indent="0" marL="0">
+              <a:buNone/>
+            </a:pPr>
+            <a:r>
+              <a:rPr lang="en-US" sz="1720" dirty="0">
+                <a:solidFill>
+                  <a:srgbClr val="EEF6F3"/>
+                </a:solidFill>
+                <a:latin typeface="Segoe UI" pitchFamily="34" charset="0"/>
+                <a:ea typeface="Segoe UI" pitchFamily="34" charset="-122"/>
+                <a:cs typeface="Segoe UI" pitchFamily="34" charset="-120"/>
+              </a:rPr>
+              <a:t> (venv) is a folder with its own Python and its own packages, one per project.</a:t>
+            </a:r>
+            <a:endParaRPr lang="en-US" sz="1720" dirty="0"/>
+          </a:p>
+        </p:txBody>
+      </p:sp>
+      <p:sp>
+        <p:nvSpPr>
+          <p:cNvPr id="11" name="Text 8"/>
           <p:cNvSpPr/>
           <p:nvPr/>
         </p:nvSpPr>
@@ -27827,7 +27384,7 @@
                 <a:ea typeface="Segoe UI" pitchFamily="34" charset="-122"/>
                 <a:cs typeface="Segoe UI" pitchFamily="34" charset="-120"/>
               </a:rPr>
-              <a:t>Applied AI Engineering · SE Factory · Resolvo</a:t>
+              <a:t>Applied AI Engineering · SE Factory · Deskhand</a:t>
             </a:r>
             <a:endParaRPr lang="en-US" sz="1000" dirty="0"/>
           </a:p>
@@ -27835,7 +27392,7 @@
       </p:sp>
       <p:sp>
         <p:nvSpPr>
-          <p:cNvPr id="8" name="Text 5"/>
+          <p:cNvPr id="12" name="Text 9"/>
           <p:cNvSpPr/>
           <p:nvPr/>
         </p:nvSpPr>
@@ -28023,7 +27580,7 @@
                 <a:ea typeface="Segoe UI" pitchFamily="34" charset="-122"/>
                 <a:cs typeface="Segoe UI" pitchFamily="34" charset="-120"/>
               </a:rPr>
-              <a:t>Make it, switch it on, fill it</a:t>
+              <a:t>Make a venv, switch it on, install packages</a:t>
             </a:r>
             <a:endParaRPr lang="en-US" sz="3000" dirty="0"/>
           </a:p>
@@ -28131,8 +27688,7 @@
                 <a:ea typeface="Consolas" pitchFamily="34" charset="-122"/>
                 <a:cs typeface="Consolas" pitchFamily="34" charset="-120"/>
               </a:rPr>
-              <a:t># from prep-kit/
-</a:t>
+              <a:t># from prep-kit/</a:t>
             </a:r>
             <a:endParaRPr lang="en-US" sz="1350" dirty="0"/>
           </a:p>
@@ -28152,8 +27708,7 @@
                 <a:ea typeface="Consolas" pitchFamily="34" charset="-122"/>
                 <a:cs typeface="Consolas" pitchFamily="34" charset="-120"/>
               </a:rPr>
-              <a:t>py -3.12 -m venv .venv
-</a:t>
+              <a:t>py -3.12 -m venv .venv</a:t>
             </a:r>
             <a:endParaRPr lang="en-US" sz="1350" dirty="0"/>
           </a:p>
@@ -28173,8 +27728,7 @@
                 <a:ea typeface="Consolas" pitchFamily="34" charset="-122"/>
                 <a:cs typeface="Consolas" pitchFamily="34" charset="-120"/>
               </a:rPr>
-              <a:t>.venv\Scripts\activate
-</a:t>
+              <a:t>.venv\Scripts\activate</a:t>
             </a:r>
             <a:endParaRPr lang="en-US" sz="1350" dirty="0"/>
           </a:p>
@@ -28302,8 +27856,7 @@
                 <a:ea typeface="Consolas" pitchFamily="34" charset="-122"/>
                 <a:cs typeface="Consolas" pitchFamily="34" charset="-120"/>
               </a:rPr>
-              <a:t># from prep-kit/
-</a:t>
+              <a:t># from prep-kit/</a:t>
             </a:r>
             <a:endParaRPr lang="en-US" sz="1350" dirty="0"/>
           </a:p>
@@ -28323,8 +27876,7 @@
                 <a:ea typeface="Consolas" pitchFamily="34" charset="-122"/>
                 <a:cs typeface="Consolas" pitchFamily="34" charset="-120"/>
               </a:rPr>
-              <a:t>python3.12 -m venv .venv
-</a:t>
+              <a:t>python3.12 -m venv .venv</a:t>
             </a:r>
             <a:endParaRPr lang="en-US" sz="1350" dirty="0"/>
           </a:p>
@@ -28344,8 +27896,7 @@
                 <a:ea typeface="Consolas" pitchFamily="34" charset="-122"/>
                 <a:cs typeface="Consolas" pitchFamily="34" charset="-120"/>
               </a:rPr>
-              <a:t>source .venv/bin/activate
-</a:t>
+              <a:t>source .venv/bin/activate</a:t>
             </a:r>
             <a:endParaRPr lang="en-US" sz="1350" dirty="0"/>
           </a:p>
@@ -28615,7 +28166,7 @@
                 <a:ea typeface="Segoe UI" pitchFamily="34" charset="-122"/>
                 <a:cs typeface="Segoe UI" pitchFamily="34" charset="-120"/>
               </a:rPr>
-              <a:t>Applied AI Engineering · SE Factory · Resolvo</a:t>
+              <a:t>Applied AI Engineering · SE Factory · Deskhand</a:t>
             </a:r>
             <a:endParaRPr lang="en-US" sz="1000" dirty="0"/>
           </a:p>
@@ -28948,8 +28499,7 @@
                 <a:ea typeface="Consolas" pitchFamily="34" charset="-122"/>
                 <a:cs typeface="Consolas" pitchFamily="34" charset="-120"/>
               </a:rPr>
-              <a:t>py code\where_am_i.py
-</a:t>
+              <a:t>py code\where_am_i.py</a:t>
             </a:r>
             <a:endParaRPr lang="en-US" sz="1350" dirty="0"/>
           </a:p>
@@ -28969,8 +28519,7 @@
                 <a:ea typeface="Consolas" pitchFamily="34" charset="-122"/>
                 <a:cs typeface="Consolas" pitchFamily="34" charset="-120"/>
               </a:rPr>
-              <a:t>
-</a:t>
+              <a:t> </a:t>
             </a:r>
             <a:endParaRPr lang="en-US" sz="1350" dirty="0"/>
           </a:p>
@@ -28990,8 +28539,7 @@
                 <a:ea typeface="Consolas" pitchFamily="34" charset="-122"/>
                 <a:cs typeface="Consolas" pitchFamily="34" charset="-120"/>
               </a:rPr>
-              <a:t>Python version : 3.12.7
-</a:t>
+              <a:t>Python version : 3.12.7</a:t>
             </a:r>
             <a:endParaRPr lang="en-US" sz="1350" dirty="0"/>
           </a:p>
@@ -29011,8 +28559,7 @@
                 <a:ea typeface="Consolas" pitchFamily="34" charset="-122"/>
                 <a:cs typeface="Consolas" pitchFamily="34" charset="-120"/>
               </a:rPr>
-              <a:t>Running from   : C:\...\prep-kit\.venv\Scripts\python.exe
-</a:t>
+              <a:t>Running from   : C:\...\prep-kit\.venv\Scripts\python.exe</a:t>
             </a:r>
             <a:endParaRPr lang="en-US" sz="1350" dirty="0"/>
           </a:p>
@@ -29032,8 +28579,7 @@
                 <a:ea typeface="Consolas" pitchFamily="34" charset="-122"/>
                 <a:cs typeface="Consolas" pitchFamily="34" charset="-120"/>
               </a:rPr>
-              <a:t>Virtual env    : YES  (C:\...\prep-kit\.venv)
-</a:t>
+              <a:t>Virtual env    : YES  (C:\...\prep-kit\.venv)</a:t>
             </a:r>
             <a:endParaRPr lang="en-US" sz="1350" dirty="0"/>
           </a:p>
@@ -29053,8 +28599,7 @@
                 <a:ea typeface="Consolas" pitchFamily="34" charset="-122"/>
                 <a:cs typeface="Consolas" pitchFamily="34" charset="-120"/>
               </a:rPr>
-              <a:t>
-</a:t>
+              <a:t> </a:t>
             </a:r>
             <a:endParaRPr lang="en-US" sz="1350" dirty="0"/>
           </a:p>
@@ -29074,8 +28619,7 @@
                 <a:ea typeface="Consolas" pitchFamily="34" charset="-122"/>
                 <a:cs typeface="Consolas" pitchFamily="34" charset="-120"/>
               </a:rPr>
-              <a:t>Packages the prep kit needs:
-</a:t>
+              <a:t>Packages the prep kit needs:</a:t>
             </a:r>
             <a:endParaRPr lang="en-US" sz="1350" dirty="0"/>
           </a:p>
@@ -29095,8 +28639,7 @@
                 <a:ea typeface="Consolas" pitchFamily="34" charset="-122"/>
                 <a:cs typeface="Consolas" pitchFamily="34" charset="-120"/>
               </a:rPr>
-              <a:t>  ok       openai
-</a:t>
+              <a:t>  ok       openai</a:t>
             </a:r>
             <a:endParaRPr lang="en-US" sz="1350" dirty="0"/>
           </a:p>
@@ -29116,8 +28659,7 @@
                 <a:ea typeface="Consolas" pitchFamily="34" charset="-122"/>
                 <a:cs typeface="Consolas" pitchFamily="34" charset="-120"/>
               </a:rPr>
-              <a:t>  ok       httpx
-</a:t>
+              <a:t>  ok       httpx</a:t>
             </a:r>
             <a:endParaRPr lang="en-US" sz="1350" dirty="0"/>
           </a:p>
@@ -29137,8 +28679,7 @@
                 <a:ea typeface="Consolas" pitchFamily="34" charset="-122"/>
                 <a:cs typeface="Consolas" pitchFamily="34" charset="-120"/>
               </a:rPr>
-              <a:t>  ok       dotenv
-</a:t>
+              <a:t>  ok       dotenv</a:t>
             </a:r>
             <a:endParaRPr lang="en-US" sz="1350" dirty="0"/>
           </a:p>
@@ -29239,6 +28780,101 @@
         </p:nvSpPr>
         <p:spPr>
           <a:xfrm>
+            <a:off x="777240" y="5484495"/>
+            <a:ext cx="10637215" cy="650748"/>
+          </a:xfrm>
+          <a:prstGeom prst="rect">
+            <a:avLst/>
+          </a:prstGeom>
+          <a:noFill/>
+          <a:ln/>
+        </p:spPr>
+        <p:txBody>
+          <a:bodyPr wrap="square" lIns="0" tIns="0" rIns="0" bIns="0" rtlCol="0" anchor="t"/>
+          <a:lstStyle/>
+          <a:p>
+            <a:pPr algn="l" indent="0" marL="0">
+              <a:buNone/>
+            </a:pPr>
+            <a:r>
+              <a:rPr lang="en-US" sz="1700" dirty="0">
+                <a:solidFill>
+                  <a:srgbClr val="9DB5B1"/>
+                </a:solidFill>
+                <a:latin typeface="Segoe UI" pitchFamily="34" charset="0"/>
+                <a:ea typeface="Segoe UI" pitchFamily="34" charset="-122"/>
+                <a:cs typeface="Segoe UI" pitchFamily="34" charset="-120"/>
+              </a:rPr>
+              <a:t>macOS / Linux, with the venv active: </a:t>
+            </a:r>
+            <a:pPr algn="l" indent="0" marL="0">
+              <a:buNone/>
+            </a:pPr>
+            <a:r>
+              <a:rPr lang="en-US" sz="1500" dirty="0">
+                <a:solidFill>
+                  <a:srgbClr val="D8FFF0"/>
+                </a:solidFill>
+                <a:latin typeface="Consolas" pitchFamily="34" charset="0"/>
+                <a:ea typeface="Consolas" pitchFamily="34" charset="-122"/>
+                <a:cs typeface="Consolas" pitchFamily="34" charset="-120"/>
+              </a:rPr>
+              <a:t>python code/where_am_i.py</a:t>
+            </a:r>
+            <a:pPr algn="l" indent="0" marL="0">
+              <a:buNone/>
+            </a:pPr>
+            <a:r>
+              <a:rPr lang="en-US" sz="1700" dirty="0">
+                <a:solidFill>
+                  <a:srgbClr val="9DB5B1"/>
+                </a:solidFill>
+                <a:latin typeface="Segoe UI" pitchFamily="34" charset="0"/>
+                <a:ea typeface="Segoe UI" pitchFamily="34" charset="-122"/>
+                <a:cs typeface="Segoe UI" pitchFamily="34" charset="-120"/>
+              </a:rPr>
+              <a:t>. The same goes for every </a:t>
+            </a:r>
+            <a:pPr algn="l" indent="0" marL="0">
+              <a:buNone/>
+            </a:pPr>
+            <a:r>
+              <a:rPr lang="en-US" sz="1500" dirty="0">
+                <a:solidFill>
+                  <a:srgbClr val="D8FFF0"/>
+                </a:solidFill>
+                <a:latin typeface="Consolas" pitchFamily="34" charset="0"/>
+                <a:ea typeface="Consolas" pitchFamily="34" charset="-122"/>
+                <a:cs typeface="Consolas" pitchFamily="34" charset="-120"/>
+              </a:rPr>
+              <a:t>py code\…</a:t>
+            </a:r>
+            <a:pPr algn="l" indent="0" marL="0">
+              <a:buNone/>
+            </a:pPr>
+            <a:r>
+              <a:rPr lang="en-US" sz="1700" dirty="0">
+                <a:solidFill>
+                  <a:srgbClr val="9DB5B1"/>
+                </a:solidFill>
+                <a:latin typeface="Segoe UI" pitchFamily="34" charset="0"/>
+                <a:ea typeface="Segoe UI" pitchFamily="34" charset="-122"/>
+                <a:cs typeface="Segoe UI" pitchFamily="34" charset="-120"/>
+              </a:rPr>
+              <a:t> command in this deck.</a:t>
+            </a:r>
+            <a:endParaRPr lang="en-US" sz="1700" dirty="0"/>
+          </a:p>
+        </p:txBody>
+      </p:sp>
+      <p:sp>
+        <p:nvSpPr>
+          <p:cNvPr id="12" name="Text 10"/>
+          <p:cNvSpPr/>
+          <p:nvPr/>
+        </p:nvSpPr>
+        <p:spPr>
+          <a:xfrm>
             <a:off x="777240" y="6473952"/>
             <a:ext cx="5486400" cy="274320"/>
           </a:xfrm>
@@ -29264,7 +28900,7 @@
                 <a:ea typeface="Segoe UI" pitchFamily="34" charset="-122"/>
                 <a:cs typeface="Segoe UI" pitchFamily="34" charset="-120"/>
               </a:rPr>
-              <a:t>Applied AI Engineering · SE Factory · Resolvo</a:t>
+              <a:t>Applied AI Engineering · SE Factory · Deskhand</a:t>
             </a:r>
             <a:endParaRPr lang="en-US" sz="1000" dirty="0"/>
           </a:p>
@@ -29272,7 +28908,7 @@
       </p:sp>
       <p:sp>
         <p:nvSpPr>
-          <p:cNvPr id="12" name="Text 10"/>
+          <p:cNvPr id="13" name="Text 11"/>
           <p:cNvSpPr/>
           <p:nvPr/>
         </p:nvSpPr>
@@ -29638,7 +29274,7 @@
                 <a:ea typeface="Segoe UI" pitchFamily="34" charset="-122"/>
                 <a:cs typeface="Segoe UI" pitchFamily="34" charset="-120"/>
               </a:rPr>
-              <a:t>Applied AI Engineering · SE Factory · Resolvo</a:t>
+              <a:t>Applied AI Engineering · SE Factory · Deskhand</a:t>
             </a:r>
             <a:endParaRPr lang="en-US" sz="1000" dirty="0"/>
           </a:p>

</xml_diff>